<commit_message>
docs: o oitavo achado e os dois níveis de pull request
Integrar uma onda faz o GitHub marcar os PRs daquela onda como MERGED
sozinho, sem revisão de ninguém. É comportamento normal de stacked PRs e
consequência direta da correção do achado 7, então virou o achado 8 — o
único da palestra que foi criado pela correção de outro.

Deck: slide de achados novo, pipeline com PR por item e PR de entrega
separados, demo 4 mostrando os dois níveis, e o não-negociável trocado de
"merge humano" para "um PR que proponha mexer no main, que nenhum agente
possa aprovar" — que é a versão verificável da mesma regra.

Roteiro: numeração dos slides deslocada, callout explicando o par 7/8, o
que apontar no PR de entrega, e uma resposta pronta para "vi PRs marcados
como MERGED, quem aprovou aquilo?".

Co-Authored-By: Claude Opus 5 (1M context) <noreply@anthropic.com>
</commit_message>
<xml_diff>
--- a/docs/apresentacao/Agent-Squad-TDC-SP-2026.pptx
+++ b/docs/apresentacao/Agent-Squad-TDC-SP-2026.pptx
@@ -40,6 +40,7 @@
     <p:sldId id="288" r:id="rId40"/>
     <p:sldId id="289" r:id="rId41"/>
     <p:sldId id="290" r:id="rId42"/>
+    <p:sldId id="291" r:id="rId43"/>
   </p:sldIdLst>
   <p:sldSz cx="12191695" cy="6858000" type="screen4x3"/>
   <p:notesSz cx="6858000" cy="9144000"/>
@@ -1166,7 +1167,7 @@
           <a:lstStyle/>
           <a:p>
             <a:r>
-              <a:t>Transição importante. Diga: 'a partir daqui eu paro de te vender a solução e começo a te contar o que deu errado'. Plateia técnica confia muito mais em quem mostra as cicatrizes. Estes sete achados custaram horas cada um.</a:t>
+              <a:t>Transição importante. Diga: 'a partir daqui eu paro de te vender a solução e começo a te contar o que deu errado'. Plateia técnica confia muito mais em quem mostra as cicatrizes. Estes oito achados custaram horas cada um. E o oitavo é consequência direta da correção do sétimo.</a:t>
             </a:r>
           </a:p>
         </p:txBody>
@@ -1967,7 +1968,13 @@
           <a:lstStyle/>
           <a:p>
             <a:r>
-              <a:t>Percorra os oito blocos em ~90 segundos, apontando. Não detalhe ainda — cada demo vai abrir um deles. O que precisa ficar: os dois portões amarelos. Diga: 'a fábrica é autônoma no meio, e amarrada nas pontas — é exatamente aí que ela se torna utilizável numa empresa de verdade'.</a:t>
+              <a:t>Percorra os nove blocos em ~90 segundos, apontando. Não detalhe ainda — cada demo vai abrir um deles. O que precisa ficar: os dois portões amarelos. Diga: 'a fábrica é autônoma no meio, e amarrada nas pontas — é exatamente aí que ela se torna utilizável numa empresa de verdade'.</a:t>
+            </a:r>
+          </a:p>
+          <a:p/>
+          <a:p>
+            <a:r>
+              <a:t>Os dois últimos blocos são níveis diferentes de pull request, e a distinção vai voltar no achado 8: os PRs por item apontam para o branch de integração e servem para LER uma mudança de cada vez; o PR de entrega vai do branch de integração para main e é a única coisa que propõe mexer no que o time entrega. Se alguém perguntar por que dois, a resposta curta é: 'revisar em pedaços, decidir de uma vez'.</a:t>
             </a:r>
           </a:p>
         </p:txBody>
@@ -6440,7 +6447,7 @@
                 </a:solidFill>
                 <a:latin typeface="Segoe UI"/>
               </a:rPr>
-              <a:t>10/35</a:t>
+              <a:t>10/36</a:t>
             </a:r>
           </a:p>
         </p:txBody>
@@ -7885,7 +7892,7 @@
                 </a:solidFill>
                 <a:latin typeface="Segoe UI"/>
               </a:rPr>
-              <a:t>12/35</a:t>
+              <a:t>12/36</a:t>
             </a:r>
           </a:p>
         </p:txBody>
@@ -9242,7 +9249,7 @@
                 </a:solidFill>
                 <a:latin typeface="Segoe UI"/>
               </a:rPr>
-              <a:t>13/35</a:t>
+              <a:t>13/36</a:t>
             </a:r>
           </a:p>
         </p:txBody>
@@ -10430,7 +10437,7 @@
                 </a:solidFill>
                 <a:latin typeface="Segoe UI"/>
               </a:rPr>
-              <a:t>15/35</a:t>
+              <a:t>15/36</a:t>
             </a:r>
           </a:p>
         </p:txBody>
@@ -11143,7 +11150,7 @@
                 </a:solidFill>
                 <a:latin typeface="Segoe UI"/>
               </a:rPr>
-              <a:t>16/35</a:t>
+              <a:t>16/36</a:t>
             </a:r>
           </a:p>
         </p:txBody>
@@ -12023,7 +12030,7 @@
                 </a:solidFill>
                 <a:latin typeface="Segoe UI"/>
               </a:rPr>
-              <a:t>17/35</a:t>
+              <a:t>17/36</a:t>
             </a:r>
           </a:p>
         </p:txBody>
@@ -13460,7 +13467,7 @@
                 </a:solidFill>
                 <a:latin typeface="Segoe UI"/>
               </a:rPr>
-              <a:t>19/35</a:t>
+              <a:t>19/36</a:t>
             </a:r>
           </a:p>
         </p:txBody>
@@ -14177,7 +14184,7 @@
                 </a:solidFill>
                 <a:latin typeface="Segoe UI"/>
               </a:rPr>
-              <a:t>2/35</a:t>
+              <a:t>2/36</a:t>
             </a:r>
           </a:p>
         </p:txBody>
@@ -15338,7 +15345,7 @@
                 </a:solidFill>
                 <a:latin typeface="Segoe UI"/>
               </a:rPr>
-              <a:t>20/35</a:t>
+              <a:t>20/36</a:t>
             </a:r>
           </a:p>
         </p:txBody>
@@ -15562,7 +15569,7 @@
                 </a:solidFill>
                 <a:latin typeface="Segoe UI"/>
               </a:rPr>
-              <a:t>O que um humano recebe no fim: relatório de validação, revisão citando a regra, e procedência.</a:t>
+              <a:t>Dois níveis: os PRs por item são as unidades de revisão. O PR de entrega é o portão.</a:t>
             </a:r>
           </a:p>
         </p:txBody>
@@ -15576,7 +15583,7 @@
         <p:spPr>
           <a:xfrm>
             <a:off x="1051560" y="2743200"/>
-            <a:ext cx="10058400" cy="1938528"/>
+            <a:ext cx="10058400" cy="2249424"/>
           </a:xfrm>
           <a:prstGeom prst="roundRect">
             <a:avLst>
@@ -15669,11 +15676,33 @@
             <a:r>
               <a:rPr sz="1500" b="0">
                 <a:solidFill>
+                  <a:srgbClr val="BC8CFF"/>
+                </a:solidFill>
+                <a:latin typeface="Consolas"/>
+              </a:rPr>
+              <a:t>  #27  [agent-generated]  feat: catálogo   agent/run-... → main</a:t>
+            </a:r>
+          </a:p>
+          <a:p>
+            <a:pPr algn="l">
+              <a:lnSpc>
+                <a:spcPct val="115000"/>
+              </a:lnSpc>
+              <a:spcBef>
+                <a:spcPts val="0"/>
+              </a:spcBef>
+              <a:spcAft>
+                <a:spcPts val="300"/>
+              </a:spcAft>
+            </a:pPr>
+            <a:r>
+              <a:rPr sz="1500" b="0">
+                <a:solidFill>
                   <a:srgbClr val="E6EDF3"/>
                 </a:solidFill>
                 <a:latin typeface="Consolas"/>
               </a:rPr>
-              <a:t>  #15  [agent-generated,area:api]    feat: exponha get products com logs e testes</a:t>
+              <a:t>  #15  [area:api]   feat: exponha get products com logs e testes</a:t>
             </a:r>
           </a:p>
           <a:p>
@@ -15695,7 +15724,7 @@
                 </a:solidFill>
                 <a:latin typeface="Consolas"/>
               </a:rPr>
-              <a:t>  #13  [agent-generated,area:core]   feat: implemente validação filtros e paginação</a:t>
+              <a:t>  #13  [area:core]  feat: implemente validação filtros e paginação</a:t>
             </a:r>
           </a:p>
           <a:p>
@@ -15717,7 +15746,7 @@
                 </a:solidFill>
                 <a:latin typeface="Consolas"/>
               </a:rPr>
-              <a:t>  #11  [agent-generated,area:infra]  build: crie a base .net e os contratos</a:t>
+              <a:t>  #11  [area:infra] build: crie a base .net e os contratos</a:t>
             </a:r>
           </a:p>
         </p:txBody>
@@ -15790,7 +15819,7 @@
                 </a:solidFill>
                 <a:latin typeface="Segoe UI"/>
               </a:rPr>
-              <a:t>Abra um PR: tabela do gate, apontamento citando TST-004 com arquivo:linha, e bloco de procedência</a:t>
+              <a:t>Abra um PR de item: tabela do gate, apontamento citando TST-004 com arquivo:linha, procedência</a:t>
             </a:r>
           </a:p>
           <a:p>
@@ -15818,7 +15847,7 @@
                 </a:solidFill>
                 <a:latin typeface="Segoe UI"/>
               </a:rPr>
-              <a:t>Todos são draft. O merge é humano — sempre.</a:t>
+              <a:t>Depois abra o #27: o que entrou, o que NÃO entrou, e 'O merge é seu.'</a:t>
             </a:r>
           </a:p>
         </p:txBody>
@@ -16014,7 +16043,7 @@
                 </a:solidFill>
                 <a:latin typeface="Segoe UI"/>
               </a:rPr>
-              <a:t>Sete coisas que quebraram</a:t>
+              <a:t>Oito coisas que quebraram</a:t>
             </a:r>
           </a:p>
           <a:p>
@@ -16188,7 +16217,7 @@
                 </a:solidFill>
                 <a:latin typeface="Segoe UI"/>
               </a:rPr>
-              <a:t>ACHADO 1 DE 7</a:t>
+              <a:t>ACHADO 1 DE 8</a:t>
             </a:r>
           </a:p>
         </p:txBody>
@@ -16656,7 +16685,7 @@
                 </a:solidFill>
                 <a:latin typeface="Segoe UI"/>
               </a:rPr>
-              <a:t>23/35</a:t>
+              <a:t>23/36</a:t>
             </a:r>
           </a:p>
         </p:txBody>
@@ -16763,7 +16792,7 @@
                 </a:solidFill>
                 <a:latin typeface="Segoe UI"/>
               </a:rPr>
-              <a:t>ACHADO 2 DE 7</a:t>
+              <a:t>ACHADO 2 DE 8</a:t>
             </a:r>
           </a:p>
         </p:txBody>
@@ -17187,7 +17216,7 @@
                 </a:solidFill>
                 <a:latin typeface="Segoe UI"/>
               </a:rPr>
-              <a:t>24/35</a:t>
+              <a:t>24/36</a:t>
             </a:r>
           </a:p>
         </p:txBody>
@@ -17294,7 +17323,7 @@
                 </a:solidFill>
                 <a:latin typeface="Segoe UI"/>
               </a:rPr>
-              <a:t>ACHADO 3 DE 7</a:t>
+              <a:t>ACHADO 3 DE 8</a:t>
             </a:r>
           </a:p>
         </p:txBody>
@@ -17740,7 +17769,7 @@
                 </a:solidFill>
                 <a:latin typeface="Segoe UI"/>
               </a:rPr>
-              <a:t>25/35</a:t>
+              <a:t>25/36</a:t>
             </a:r>
           </a:p>
         </p:txBody>
@@ -17847,7 +17876,7 @@
                 </a:solidFill>
                 <a:latin typeface="Segoe UI"/>
               </a:rPr>
-              <a:t>ACHADO 4 DE 7</a:t>
+              <a:t>ACHADO 4 DE 8</a:t>
             </a:r>
           </a:p>
         </p:txBody>
@@ -18293,7 +18322,7 @@
                 </a:solidFill>
                 <a:latin typeface="Segoe UI"/>
               </a:rPr>
-              <a:t>26/35</a:t>
+              <a:t>26/36</a:t>
             </a:r>
           </a:p>
         </p:txBody>
@@ -18400,7 +18429,7 @@
                 </a:solidFill>
                 <a:latin typeface="Segoe UI"/>
               </a:rPr>
-              <a:t>ACHADO 5 DE 7</a:t>
+              <a:t>ACHADO 5 DE 8</a:t>
             </a:r>
           </a:p>
         </p:txBody>
@@ -18824,7 +18853,7 @@
                 </a:solidFill>
                 <a:latin typeface="Segoe UI"/>
               </a:rPr>
-              <a:t>27/35</a:t>
+              <a:t>27/36</a:t>
             </a:r>
           </a:p>
         </p:txBody>
@@ -18931,7 +18960,7 @@
                 </a:solidFill>
                 <a:latin typeface="Segoe UI"/>
               </a:rPr>
-              <a:t>ACHADO 6 DE 7</a:t>
+              <a:t>ACHADO 6 DE 8</a:t>
             </a:r>
           </a:p>
         </p:txBody>
@@ -19355,7 +19384,7 @@
                 </a:solidFill>
                 <a:latin typeface="Segoe UI"/>
               </a:rPr>
-              <a:t>28/35</a:t>
+              <a:t>28/36</a:t>
             </a:r>
           </a:p>
         </p:txBody>
@@ -19462,7 +19491,7 @@
                 </a:solidFill>
                 <a:latin typeface="Segoe UI"/>
               </a:rPr>
-              <a:t>ACHADO 7 DE 7</a:t>
+              <a:t>ACHADO 7 DE 8</a:t>
             </a:r>
           </a:p>
         </p:txBody>
@@ -19886,7 +19915,7 @@
                 </a:solidFill>
                 <a:latin typeface="Segoe UI"/>
               </a:rPr>
-              <a:t>29/35</a:t>
+              <a:t>29/36</a:t>
             </a:r>
           </a:p>
         </p:txBody>
@@ -21313,7 +21342,7 @@
                 </a:solidFill>
                 <a:latin typeface="Segoe UI"/>
               </a:rPr>
-              <a:t>3/35</a:t>
+              <a:t>3/36</a:t>
             </a:r>
           </a:p>
         </p:txBody>
@@ -21420,7 +21449,7 @@
                 </a:solidFill>
                 <a:latin typeface="Segoe UI"/>
               </a:rPr>
-              <a:t>OS ACHADOS</a:t>
+              <a:t>ACHADO 8 DE 8</a:t>
             </a:r>
           </a:p>
         </p:txBody>
@@ -21465,7 +21494,7 @@
                 </a:solidFill>
                 <a:latin typeface="Segoe UI"/>
               </a:rPr>
-              <a:t>O padrão por trás dos sete</a:t>
+              <a:t>A correção do achado 7 fechou PRs que ninguém revisou</a:t>
             </a:r>
           </a:p>
         </p:txBody>
@@ -21516,185 +21545,14 @@
       </p:sp>
       <p:sp>
         <p:nvSpPr>
-          <p:cNvPr id="6" name="TextBox 5"/>
-          <p:cNvSpPr txBox="1"/>
-          <p:nvPr/>
-        </p:nvSpPr>
-        <p:spPr>
-          <a:xfrm>
-            <a:off x="777240" y="1901952"/>
-            <a:ext cx="10637215" cy="4133088"/>
-          </a:xfrm>
-          <a:prstGeom prst="rect">
-            <a:avLst/>
-          </a:prstGeom>
-          <a:noFill/>
-        </p:spPr>
-        <p:txBody>
-          <a:bodyPr wrap="square" lIns="0" rIns="0" tIns="0" bIns="0">
-            <a:spAutoFit/>
-          </a:bodyPr>
-          <a:lstStyle/>
-          <a:p>
-            <a:pPr algn="l">
-              <a:lnSpc>
-                <a:spcPct val="125000"/>
-              </a:lnSpc>
-              <a:spcAft>
-                <a:spcPts val="1800"/>
-              </a:spcAft>
-            </a:pPr>
-            <a:r>
-              <a:rPr sz="1900" b="1">
-                <a:solidFill>
-                  <a:srgbClr val="58A6FF"/>
-                </a:solidFill>
-                <a:latin typeface="Segoe UI"/>
-              </a:rPr>
-              <a:t>—  </a:t>
-            </a:r>
-            <a:r>
-              <a:rPr sz="1900" b="1">
-                <a:solidFill>
-                  <a:srgbClr val="E6EDF3"/>
-                </a:solidFill>
-                <a:latin typeface="Segoe UI"/>
-              </a:rPr>
-              <a:t>Nenhum era sobre o modelo. </a:t>
-            </a:r>
-            <a:r>
-              <a:rPr sz="1900" b="0">
-                <a:solidFill>
-                  <a:srgbClr val="9198A1"/>
-                </a:solidFill>
-                <a:latin typeface="Segoe UI"/>
-              </a:rPr>
-              <a:t>Todos eram integração, versão, permissão ou hierarquia de autoridade.</a:t>
-            </a:r>
-          </a:p>
-          <a:p>
-            <a:pPr algn="l">
-              <a:lnSpc>
-                <a:spcPct val="125000"/>
-              </a:lnSpc>
-              <a:spcAft>
-                <a:spcPts val="1800"/>
-              </a:spcAft>
-            </a:pPr>
-            <a:r>
-              <a:rPr sz="1900" b="1">
-                <a:solidFill>
-                  <a:srgbClr val="58A6FF"/>
-                </a:solidFill>
-                <a:latin typeface="Segoe UI"/>
-              </a:rPr>
-              <a:t>—  </a:t>
-            </a:r>
-            <a:r>
-              <a:rPr sz="1900" b="1">
-                <a:solidFill>
-                  <a:srgbClr val="E6EDF3"/>
-                </a:solidFill>
-                <a:latin typeface="Segoe UI"/>
-              </a:rPr>
-              <a:t>Nenhum aparecia em teste unitário. </a:t>
-            </a:r>
-            <a:r>
-              <a:rPr sz="1900" b="0">
-                <a:solidFill>
-                  <a:srgbClr val="9198A1"/>
-                </a:solidFill>
-                <a:latin typeface="Segoe UI"/>
-              </a:rPr>
-              <a:t>Todos apareceram rodando contra a nuvem de verdade.</a:t>
-            </a:r>
-          </a:p>
-          <a:p>
-            <a:pPr algn="l">
-              <a:lnSpc>
-                <a:spcPct val="125000"/>
-              </a:lnSpc>
-              <a:spcAft>
-                <a:spcPts val="1800"/>
-              </a:spcAft>
-            </a:pPr>
-            <a:r>
-              <a:rPr sz="1900" b="1">
-                <a:solidFill>
-                  <a:srgbClr val="58A6FF"/>
-                </a:solidFill>
-                <a:latin typeface="Segoe UI"/>
-              </a:rPr>
-              <a:t>—  </a:t>
-            </a:r>
-            <a:r>
-              <a:rPr sz="1900" b="1">
-                <a:solidFill>
-                  <a:srgbClr val="E6EDF3"/>
-                </a:solidFill>
-                <a:latin typeface="Segoe UI"/>
-              </a:rPr>
-              <a:t>Quatro só apareceram depois de 10 minutos de execução. </a:t>
-            </a:r>
-            <a:r>
-              <a:rPr sz="1900" b="0">
-                <a:solidFill>
-                  <a:srgbClr val="9198A1"/>
-                </a:solidFill>
-                <a:latin typeface="Segoe UI"/>
-              </a:rPr>
-              <a:t>Por isso cada integração arriscada virou um diagnóstico que roda em segundos.</a:t>
-            </a:r>
-          </a:p>
-          <a:p>
-            <a:pPr algn="l">
-              <a:lnSpc>
-                <a:spcPct val="125000"/>
-              </a:lnSpc>
-              <a:spcAft>
-                <a:spcPts val="1800"/>
-              </a:spcAft>
-            </a:pPr>
-            <a:r>
-              <a:rPr sz="1900" b="1">
-                <a:solidFill>
-                  <a:srgbClr val="58A6FF"/>
-                </a:solidFill>
-                <a:latin typeface="Segoe UI"/>
-              </a:rPr>
-              <a:t>—  </a:t>
-            </a:r>
-            <a:r>
-              <a:rPr sz="1900" b="1">
-                <a:solidFill>
-                  <a:srgbClr val="E6EDF3"/>
-                </a:solidFill>
-                <a:latin typeface="Segoe UI"/>
-              </a:rPr>
-              <a:t>O mais caro foi o que culpava a parte errada. </a:t>
-            </a:r>
-            <a:r>
-              <a:rPr sz="1900" b="0">
-                <a:solidFill>
-                  <a:srgbClr val="9198A1"/>
-                </a:solidFill>
-                <a:latin typeface="Segoe UI"/>
-              </a:rPr>
-              <a:t>Um gate com bug faz um agente correto parecer incompetente — e queima as tentativas de reparo.</a:t>
-            </a:r>
-          </a:p>
-        </p:txBody>
-      </p:sp>
-      <p:sp>
-        <p:nvSpPr>
-          <p:cNvPr id="7" name="Rounded Rectangle 6"/>
+          <p:cNvPr id="6" name="Rounded Rectangle 5"/>
           <p:cNvSpPr/>
           <p:nvPr/>
         </p:nvSpPr>
         <p:spPr>
           <a:xfrm>
-            <a:off x="777240" y="4937760"/>
-            <a:ext cx="10637215" cy="1143000"/>
+            <a:off x="777240" y="1810512"/>
+            <a:ext cx="10637215" cy="1051560"/>
           </a:xfrm>
           <a:prstGeom prst="roundRect">
             <a:avLst>
@@ -21706,7 +21564,7 @@
           </a:solidFill>
           <a:ln w="12700">
             <a:solidFill>
-              <a:srgbClr val="58A6FF"/>
+              <a:srgbClr val="BC8CFF"/>
             </a:solidFill>
           </a:ln>
           <a:effectLst/>
@@ -21726,7 +21584,185 @@
           </a:fontRef>
         </p:style>
         <p:txBody>
-          <a:bodyPr rtlCol="0" anchor="ctr" wrap="square" lIns="320040" tIns="219456" rIns="274320"/>
+          <a:bodyPr rtlCol="0" anchor="ctr" wrap="square" lIns="320040" tIns="182880" rIns="274320"/>
+          <a:lstStyle/>
+          <a:p>
+            <a:pPr algn="l">
+              <a:lnSpc>
+                <a:spcPct val="125000"/>
+              </a:lnSpc>
+              <a:spcBef>
+                <a:spcPts val="0"/>
+              </a:spcBef>
+              <a:spcAft>
+                <a:spcPts val="700"/>
+              </a:spcAft>
+            </a:pPr>
+            <a:r>
+              <a:rPr sz="1200" b="1">
+                <a:solidFill>
+                  <a:srgbClr val="BC8CFF"/>
+                </a:solidFill>
+                <a:latin typeface="Segoe UI"/>
+              </a:rPr>
+              <a:t>O SINTOMA</a:t>
+            </a:r>
+          </a:p>
+          <a:p>
+            <a:pPr algn="l">
+              <a:lnSpc>
+                <a:spcPct val="120000"/>
+              </a:lnSpc>
+              <a:spcBef>
+                <a:spcPts val="0"/>
+              </a:spcBef>
+              <a:spcAft>
+                <a:spcPts val="0"/>
+              </a:spcAft>
+            </a:pPr>
+            <a:r>
+              <a:rPr sz="1700" b="0">
+                <a:solidFill>
+                  <a:srgbClr val="E6EDF3"/>
+                </a:solidFill>
+                <a:latin typeface="Segoe UI"/>
+              </a:rPr>
+              <a:t>Integrar uma onda faz os commits dos PRs dela virarem alcançáveis pela base. O GitHub então marca esses PRs como MERGED sozinho. Três deles, sem revisão humana nenhuma.</a:t>
+            </a:r>
+          </a:p>
+        </p:txBody>
+      </p:sp>
+      <p:sp>
+        <p:nvSpPr>
+          <p:cNvPr id="7" name="Rounded Rectangle 6"/>
+          <p:cNvSpPr/>
+          <p:nvPr/>
+        </p:nvSpPr>
+        <p:spPr>
+          <a:xfrm>
+            <a:off x="777240" y="3136392"/>
+            <a:ext cx="10637215" cy="1005840"/>
+          </a:xfrm>
+          <a:prstGeom prst="roundRect">
+            <a:avLst>
+              <a:gd name="adj" fmla="val 8000"/>
+            </a:avLst>
+          </a:prstGeom>
+          <a:solidFill>
+            <a:srgbClr val="010409"/>
+          </a:solidFill>
+          <a:ln w="12700">
+            <a:solidFill>
+              <a:srgbClr val="30363D"/>
+            </a:solidFill>
+          </a:ln>
+          <a:effectLst/>
+        </p:spPr>
+        <p:style>
+          <a:lnRef idx="1">
+            <a:schemeClr val="accent1"/>
+          </a:lnRef>
+          <a:fillRef idx="3">
+            <a:schemeClr val="accent1"/>
+          </a:fillRef>
+          <a:effectRef idx="2">
+            <a:schemeClr val="accent1"/>
+          </a:effectRef>
+          <a:fontRef idx="minor">
+            <a:schemeClr val="lt1"/>
+          </a:fontRef>
+        </p:style>
+        <p:txBody>
+          <a:bodyPr rtlCol="0" anchor="t" wrap="square" lIns="256032" rIns="182880" tIns="182880" bIns="164592"/>
+          <a:lstStyle/>
+          <a:p>
+            <a:pPr algn="l">
+              <a:lnSpc>
+                <a:spcPct val="115000"/>
+              </a:lnSpc>
+              <a:spcBef>
+                <a:spcPts val="0"/>
+              </a:spcBef>
+              <a:spcAft>
+                <a:spcPts val="300"/>
+              </a:spcAft>
+            </a:pPr>
+            <a:r>
+              <a:rPr sz="1400" b="0">
+                <a:solidFill>
+                  <a:srgbClr val="F85149"/>
+                </a:solidFill>
+                <a:latin typeface="Consolas"/>
+              </a:rPr>
+              <a:t>#24 #25 #26  MERGED  — nenhum humano abriu esses</a:t>
+            </a:r>
+          </a:p>
+          <a:p>
+            <a:pPr algn="l">
+              <a:lnSpc>
+                <a:spcPct val="115000"/>
+              </a:lnSpc>
+              <a:spcBef>
+                <a:spcPts val="0"/>
+              </a:spcBef>
+              <a:spcAft>
+                <a:spcPts val="300"/>
+              </a:spcAft>
+            </a:pPr>
+            <a:r>
+              <a:rPr sz="1400" b="0">
+                <a:solidFill>
+                  <a:srgbClr val="3FB950"/>
+                </a:solidFill>
+                <a:latin typeface="Consolas"/>
+              </a:rPr>
+              <a:t>#27  DRAFT  agent/run-... → main  — este é o portão</a:t>
+            </a:r>
+          </a:p>
+        </p:txBody>
+      </p:sp>
+      <p:sp>
+        <p:nvSpPr>
+          <p:cNvPr id="8" name="Rounded Rectangle 7"/>
+          <p:cNvSpPr/>
+          <p:nvPr/>
+        </p:nvSpPr>
+        <p:spPr>
+          <a:xfrm>
+            <a:off x="777240" y="4443984"/>
+            <a:ext cx="10637215" cy="1371600"/>
+          </a:xfrm>
+          <a:prstGeom prst="roundRect">
+            <a:avLst>
+              <a:gd name="adj" fmla="val 8000"/>
+            </a:avLst>
+          </a:prstGeom>
+          <a:solidFill>
+            <a:srgbClr val="010409"/>
+          </a:solidFill>
+          <a:ln w="12700">
+            <a:solidFill>
+              <a:srgbClr val="3FB950"/>
+            </a:solidFill>
+          </a:ln>
+          <a:effectLst/>
+        </p:spPr>
+        <p:style>
+          <a:lnRef idx="1">
+            <a:schemeClr val="accent1"/>
+          </a:lnRef>
+          <a:fillRef idx="3">
+            <a:schemeClr val="accent1"/>
+          </a:fillRef>
+          <a:effectRef idx="2">
+            <a:schemeClr val="accent1"/>
+          </a:effectRef>
+          <a:fontRef idx="minor">
+            <a:schemeClr val="lt1"/>
+          </a:fontRef>
+        </p:style>
+        <p:txBody>
+          <a:bodyPr rtlCol="0" anchor="ctr" wrap="square" lIns="320040" tIns="201168" rIns="274320"/>
           <a:lstStyle/>
           <a:p>
             <a:pPr algn="l">
@@ -21741,42 +21777,42 @@
               </a:spcAft>
             </a:pPr>
             <a:r>
-              <a:rPr sz="2000" b="1">
-                <a:solidFill>
-                  <a:srgbClr val="FFFFFF"/>
-                </a:solidFill>
-                <a:latin typeface="Segoe UI"/>
-              </a:rPr>
-              <a:t>Se você for construir algo assim, orce o dobro do tempo para integração — e nada para 'fazer o modelo entender'.</a:t>
-            </a:r>
-          </a:p>
-          <a:p>
-            <a:pPr algn="l">
-              <a:lnSpc>
-                <a:spcPct val="125000"/>
-              </a:lnSpc>
-              <a:spcBef>
-                <a:spcPts val="0"/>
-              </a:spcBef>
-              <a:spcAft>
-                <a:spcPts val="0"/>
-              </a:spcAft>
-            </a:pPr>
-            <a:r>
-              <a:rPr sz="1700" b="0">
-                <a:solidFill>
-                  <a:srgbClr val="9198A1"/>
-                </a:solidFill>
-                <a:latin typeface="Segoe UI"/>
-              </a:rPr>
-              <a:t>O modelo é a parte que já funciona.</a:t>
-            </a:r>
-          </a:p>
-        </p:txBody>
-      </p:sp>
-      <p:sp>
-        <p:nvSpPr>
-          <p:cNvPr id="8" name="TextBox 7"/>
+              <a:rPr sz="1200" b="1">
+                <a:solidFill>
+                  <a:srgbClr val="3FB950"/>
+                </a:solidFill>
+                <a:latin typeface="Segoe UI"/>
+              </a:rPr>
+              <a:t>A LIÇÃO</a:t>
+            </a:r>
+          </a:p>
+          <a:p>
+            <a:pPr algn="l">
+              <a:lnSpc>
+                <a:spcPct val="125000"/>
+              </a:lnSpc>
+              <a:spcBef>
+                <a:spcPts val="0"/>
+              </a:spcBef>
+              <a:spcAft>
+                <a:spcPts val="0"/>
+              </a:spcAft>
+            </a:pPr>
+            <a:r>
+              <a:rPr sz="1800" b="0">
+                <a:solidFill>
+                  <a:srgbClr val="E6EDF3"/>
+                </a:solidFill>
+                <a:latin typeface="Segoe UI"/>
+              </a:rPr>
+              <a:t>É comportamento normal de stacked PRs, não bug — mas a execução terminava sem nada para aprovar, e isso contradiz a regra que está no slide anterior. Faltava a última peça: um PR de entrega, do branch de integração para main. Os PRs por item são unidades de REVISÃO; o de entrega é o PORTÃO.</a:t>
+            </a:r>
+          </a:p>
+        </p:txBody>
+      </p:sp>
+      <p:sp>
+        <p:nvSpPr>
+          <p:cNvPr id="9" name="TextBox 8"/>
           <p:cNvSpPr txBox="1"/>
           <p:nvPr/>
         </p:nvSpPr>
@@ -21821,7 +21857,7 @@
       </p:sp>
       <p:sp>
         <p:nvSpPr>
-          <p:cNvPr id="9" name="TextBox 8"/>
+          <p:cNvPr id="10" name="TextBox 9"/>
           <p:cNvSpPr txBox="1"/>
           <p:nvPr/>
         </p:nvSpPr>
@@ -21859,7 +21895,7 @@
                 </a:solidFill>
                 <a:latin typeface="Segoe UI"/>
               </a:rPr>
-              <a:t>30/35</a:t>
+              <a:t>30/36</a:t>
             </a:r>
           </a:p>
         </p:txBody>
@@ -21966,7 +22002,7 @@
                 </a:solidFill>
                 <a:latin typeface="Segoe UI"/>
               </a:rPr>
-              <a:t>NA SUA EMPRESA</a:t>
+              <a:t>OS ACHADOS</a:t>
             </a:r>
           </a:p>
         </p:txBody>
@@ -22011,7 +22047,7 @@
                 </a:solidFill>
                 <a:latin typeface="Segoe UI"/>
               </a:rPr>
-              <a:t>Por onde começar na segunda-feira</a:t>
+              <a:t>O padrão por trás dos oito</a:t>
             </a:r>
           </a:p>
         </p:txBody>
@@ -22062,14 +22098,222 @@
       </p:sp>
       <p:sp>
         <p:nvSpPr>
-          <p:cNvPr id="6" name="Rounded Rectangle 5"/>
+          <p:cNvPr id="6" name="TextBox 5"/>
+          <p:cNvSpPr txBox="1"/>
+          <p:nvPr/>
+        </p:nvSpPr>
+        <p:spPr>
+          <a:xfrm>
+            <a:off x="777240" y="1901952"/>
+            <a:ext cx="10637215" cy="4133088"/>
+          </a:xfrm>
+          <a:prstGeom prst="rect">
+            <a:avLst/>
+          </a:prstGeom>
+          <a:noFill/>
+        </p:spPr>
+        <p:txBody>
+          <a:bodyPr wrap="square" lIns="0" rIns="0" tIns="0" bIns="0">
+            <a:spAutoFit/>
+          </a:bodyPr>
+          <a:lstStyle/>
+          <a:p>
+            <a:pPr algn="l">
+              <a:lnSpc>
+                <a:spcPct val="125000"/>
+              </a:lnSpc>
+              <a:spcAft>
+                <a:spcPts val="1800"/>
+              </a:spcAft>
+            </a:pPr>
+            <a:r>
+              <a:rPr sz="1900" b="1">
+                <a:solidFill>
+                  <a:srgbClr val="58A6FF"/>
+                </a:solidFill>
+                <a:latin typeface="Segoe UI"/>
+              </a:rPr>
+              <a:t>—  </a:t>
+            </a:r>
+            <a:r>
+              <a:rPr sz="1900" b="1">
+                <a:solidFill>
+                  <a:srgbClr val="E6EDF3"/>
+                </a:solidFill>
+                <a:latin typeface="Segoe UI"/>
+              </a:rPr>
+              <a:t>Nenhum era sobre o modelo. </a:t>
+            </a:r>
+            <a:r>
+              <a:rPr sz="1900" b="0">
+                <a:solidFill>
+                  <a:srgbClr val="9198A1"/>
+                </a:solidFill>
+                <a:latin typeface="Segoe UI"/>
+              </a:rPr>
+              <a:t>Todos eram integração, versão, permissão ou hierarquia de autoridade.</a:t>
+            </a:r>
+          </a:p>
+          <a:p>
+            <a:pPr algn="l">
+              <a:lnSpc>
+                <a:spcPct val="125000"/>
+              </a:lnSpc>
+              <a:spcAft>
+                <a:spcPts val="1800"/>
+              </a:spcAft>
+            </a:pPr>
+            <a:r>
+              <a:rPr sz="1900" b="1">
+                <a:solidFill>
+                  <a:srgbClr val="58A6FF"/>
+                </a:solidFill>
+                <a:latin typeface="Segoe UI"/>
+              </a:rPr>
+              <a:t>—  </a:t>
+            </a:r>
+            <a:r>
+              <a:rPr sz="1900" b="1">
+                <a:solidFill>
+                  <a:srgbClr val="E6EDF3"/>
+                </a:solidFill>
+                <a:latin typeface="Segoe UI"/>
+              </a:rPr>
+              <a:t>Nenhum aparecia em teste unitário. </a:t>
+            </a:r>
+            <a:r>
+              <a:rPr sz="1900" b="0">
+                <a:solidFill>
+                  <a:srgbClr val="9198A1"/>
+                </a:solidFill>
+                <a:latin typeface="Segoe UI"/>
+              </a:rPr>
+              <a:t>Todos apareceram rodando contra a nuvem de verdade.</a:t>
+            </a:r>
+          </a:p>
+          <a:p>
+            <a:pPr algn="l">
+              <a:lnSpc>
+                <a:spcPct val="125000"/>
+              </a:lnSpc>
+              <a:spcAft>
+                <a:spcPts val="1800"/>
+              </a:spcAft>
+            </a:pPr>
+            <a:r>
+              <a:rPr sz="1900" b="1">
+                <a:solidFill>
+                  <a:srgbClr val="58A6FF"/>
+                </a:solidFill>
+                <a:latin typeface="Segoe UI"/>
+              </a:rPr>
+              <a:t>—  </a:t>
+            </a:r>
+            <a:r>
+              <a:rPr sz="1900" b="1">
+                <a:solidFill>
+                  <a:srgbClr val="E6EDF3"/>
+                </a:solidFill>
+                <a:latin typeface="Segoe UI"/>
+              </a:rPr>
+              <a:t>Quatro só apareceram depois de 10 minutos de execução. </a:t>
+            </a:r>
+            <a:r>
+              <a:rPr sz="1900" b="0">
+                <a:solidFill>
+                  <a:srgbClr val="9198A1"/>
+                </a:solidFill>
+                <a:latin typeface="Segoe UI"/>
+              </a:rPr>
+              <a:t>Por isso cada integração arriscada virou um diagnóstico que roda em segundos.</a:t>
+            </a:r>
+          </a:p>
+          <a:p>
+            <a:pPr algn="l">
+              <a:lnSpc>
+                <a:spcPct val="125000"/>
+              </a:lnSpc>
+              <a:spcAft>
+                <a:spcPts val="1800"/>
+              </a:spcAft>
+            </a:pPr>
+            <a:r>
+              <a:rPr sz="1900" b="1">
+                <a:solidFill>
+                  <a:srgbClr val="58A6FF"/>
+                </a:solidFill>
+                <a:latin typeface="Segoe UI"/>
+              </a:rPr>
+              <a:t>—  </a:t>
+            </a:r>
+            <a:r>
+              <a:rPr sz="1900" b="1">
+                <a:solidFill>
+                  <a:srgbClr val="E6EDF3"/>
+                </a:solidFill>
+                <a:latin typeface="Segoe UI"/>
+              </a:rPr>
+              <a:t>O mais caro foi o que culpava a parte errada. </a:t>
+            </a:r>
+            <a:r>
+              <a:rPr sz="1900" b="0">
+                <a:solidFill>
+                  <a:srgbClr val="9198A1"/>
+                </a:solidFill>
+                <a:latin typeface="Segoe UI"/>
+              </a:rPr>
+              <a:t>Um gate com bug faz um agente correto parecer incompetente — e queima as tentativas de reparo.</a:t>
+            </a:r>
+          </a:p>
+          <a:p>
+            <a:pPr algn="l">
+              <a:lnSpc>
+                <a:spcPct val="125000"/>
+              </a:lnSpc>
+              <a:spcAft>
+                <a:spcPts val="1800"/>
+              </a:spcAft>
+            </a:pPr>
+            <a:r>
+              <a:rPr sz="1900" b="1">
+                <a:solidFill>
+                  <a:srgbClr val="58A6FF"/>
+                </a:solidFill>
+                <a:latin typeface="Segoe UI"/>
+              </a:rPr>
+              <a:t>—  </a:t>
+            </a:r>
+            <a:r>
+              <a:rPr sz="1900" b="1">
+                <a:solidFill>
+                  <a:srgbClr val="E6EDF3"/>
+                </a:solidFill>
+                <a:latin typeface="Segoe UI"/>
+              </a:rPr>
+              <a:t>Um deles foi criado pela correção de outro. </a:t>
+            </a:r>
+            <a:r>
+              <a:rPr sz="1900" b="0">
+                <a:solidFill>
+                  <a:srgbClr val="9198A1"/>
+                </a:solidFill>
+                <a:latin typeface="Segoe UI"/>
+              </a:rPr>
+              <a:t>Consertar o fluxo das ondas passou a fechar PRs que ninguém revisou. Toda correção merece a mesma desconfiança.</a:t>
+            </a:r>
+          </a:p>
+        </p:txBody>
+      </p:sp>
+      <p:sp>
+        <p:nvSpPr>
+          <p:cNvPr id="7" name="Rounded Rectangle 6"/>
           <p:cNvSpPr/>
           <p:nvPr/>
         </p:nvSpPr>
         <p:spPr>
           <a:xfrm>
-            <a:off x="777240" y="1810512"/>
-            <a:ext cx="457200" cy="457200"/>
+            <a:off x="777240" y="4937760"/>
+            <a:ext cx="10637215" cy="1143000"/>
           </a:xfrm>
           <a:prstGeom prst="roundRect">
             <a:avLst>
@@ -22077,275 +22321,7 @@
             </a:avLst>
           </a:prstGeom>
           <a:solidFill>
-            <a:srgbClr val="010409"/>
-          </a:solidFill>
-          <a:ln w="12700">
-            <a:solidFill>
-              <a:srgbClr val="3FB950"/>
-            </a:solidFill>
-          </a:ln>
-          <a:effectLst/>
-        </p:spPr>
-        <p:style>
-          <a:lnRef idx="1">
-            <a:schemeClr val="accent1"/>
-          </a:lnRef>
-          <a:fillRef idx="3">
-            <a:schemeClr val="accent1"/>
-          </a:fillRef>
-          <a:effectRef idx="2">
-            <a:schemeClr val="accent1"/>
-          </a:effectRef>
-          <a:fontRef idx="minor">
-            <a:schemeClr val="lt1"/>
-          </a:fontRef>
-        </p:style>
-        <p:txBody>
-          <a:bodyPr rtlCol="0" anchor="ctr" wrap="square" lIns="0" rIns="0"/>
-          <a:lstStyle/>
-          <a:p>
-            <a:pPr algn="ctr">
-              <a:lnSpc>
-                <a:spcPct val="125000"/>
-              </a:lnSpc>
-              <a:spcBef>
-                <a:spcPts val="0"/>
-              </a:spcBef>
-              <a:spcAft>
-                <a:spcPts val="0"/>
-              </a:spcAft>
-            </a:pPr>
-            <a:r>
-              <a:rPr sz="1600" b="1">
-                <a:solidFill>
-                  <a:srgbClr val="3FB950"/>
-                </a:solidFill>
-                <a:latin typeface="Segoe UI"/>
-              </a:rPr>
-              <a:t>1</a:t>
-            </a:r>
-          </a:p>
-        </p:txBody>
-      </p:sp>
-      <p:sp>
-        <p:nvSpPr>
-          <p:cNvPr id="7" name="TextBox 6"/>
-          <p:cNvSpPr txBox="1"/>
-          <p:nvPr/>
-        </p:nvSpPr>
-        <p:spPr>
-          <a:xfrm>
-            <a:off x="1490472" y="1792224"/>
-            <a:ext cx="10058400" cy="731520"/>
-          </a:xfrm>
-          <a:prstGeom prst="rect">
-            <a:avLst/>
-          </a:prstGeom>
-          <a:noFill/>
-        </p:spPr>
-        <p:txBody>
-          <a:bodyPr wrap="square" lIns="0" rIns="0" tIns="0" bIns="0">
-            <a:spAutoFit/>
-          </a:bodyPr>
-          <a:lstStyle/>
-          <a:p>
-            <a:pPr algn="l">
-              <a:lnSpc>
-                <a:spcPct val="125000"/>
-              </a:lnSpc>
-              <a:spcBef>
-                <a:spcPts val="0"/>
-              </a:spcBef>
-              <a:spcAft>
-                <a:spcPts val="300"/>
-              </a:spcAft>
-            </a:pPr>
-            <a:r>
-              <a:rPr sz="1900" b="1">
-                <a:solidFill>
-                  <a:srgbClr val="E6EDF3"/>
-                </a:solidFill>
-                <a:latin typeface="Segoe UI"/>
-              </a:rPr>
-              <a:t>Escreva as regras antes do agente</a:t>
-            </a:r>
-          </a:p>
-          <a:p>
-            <a:pPr algn="l">
-              <a:lnSpc>
-                <a:spcPct val="125000"/>
-              </a:lnSpc>
-              <a:spcBef>
-                <a:spcPts val="0"/>
-              </a:spcBef>
-              <a:spcAft>
-                <a:spcPts val="0"/>
-              </a:spcAft>
-            </a:pPr>
-            <a:r>
-              <a:rPr sz="1500" b="0">
-                <a:solidFill>
-                  <a:srgbClr val="9198A1"/>
-                </a:solidFill>
-                <a:latin typeface="Segoe UI"/>
-              </a:rPr>
-              <a:t>docs/engineering-rules.md com identificador estável. Sem isso, você não tem como dizer se o agente acertou.</a:t>
-            </a:r>
-          </a:p>
-        </p:txBody>
-      </p:sp>
-      <p:sp>
-        <p:nvSpPr>
-          <p:cNvPr id="8" name="Rounded Rectangle 7"/>
-          <p:cNvSpPr/>
-          <p:nvPr/>
-        </p:nvSpPr>
-        <p:spPr>
-          <a:xfrm>
-            <a:off x="777240" y="2724912"/>
-            <a:ext cx="457200" cy="457200"/>
-          </a:xfrm>
-          <a:prstGeom prst="roundRect">
-            <a:avLst>
-              <a:gd name="adj" fmla="val 8000"/>
-            </a:avLst>
-          </a:prstGeom>
-          <a:solidFill>
-            <a:srgbClr val="010409"/>
-          </a:solidFill>
-          <a:ln w="12700">
-            <a:solidFill>
-              <a:srgbClr val="3FB950"/>
-            </a:solidFill>
-          </a:ln>
-          <a:effectLst/>
-        </p:spPr>
-        <p:style>
-          <a:lnRef idx="1">
-            <a:schemeClr val="accent1"/>
-          </a:lnRef>
-          <a:fillRef idx="3">
-            <a:schemeClr val="accent1"/>
-          </a:fillRef>
-          <a:effectRef idx="2">
-            <a:schemeClr val="accent1"/>
-          </a:effectRef>
-          <a:fontRef idx="minor">
-            <a:schemeClr val="lt1"/>
-          </a:fontRef>
-        </p:style>
-        <p:txBody>
-          <a:bodyPr rtlCol="0" anchor="ctr" wrap="square" lIns="0" rIns="0"/>
-          <a:lstStyle/>
-          <a:p>
-            <a:pPr algn="ctr">
-              <a:lnSpc>
-                <a:spcPct val="125000"/>
-              </a:lnSpc>
-              <a:spcBef>
-                <a:spcPts val="0"/>
-              </a:spcBef>
-              <a:spcAft>
-                <a:spcPts val="0"/>
-              </a:spcAft>
-            </a:pPr>
-            <a:r>
-              <a:rPr sz="1600" b="1">
-                <a:solidFill>
-                  <a:srgbClr val="3FB950"/>
-                </a:solidFill>
-                <a:latin typeface="Segoe UI"/>
-              </a:rPr>
-              <a:t>2</a:t>
-            </a:r>
-          </a:p>
-        </p:txBody>
-      </p:sp>
-      <p:sp>
-        <p:nvSpPr>
-          <p:cNvPr id="9" name="TextBox 8"/>
-          <p:cNvSpPr txBox="1"/>
-          <p:nvPr/>
-        </p:nvSpPr>
-        <p:spPr>
-          <a:xfrm>
-            <a:off x="1490472" y="2706624"/>
-            <a:ext cx="10058400" cy="731520"/>
-          </a:xfrm>
-          <a:prstGeom prst="rect">
-            <a:avLst/>
-          </a:prstGeom>
-          <a:noFill/>
-        </p:spPr>
-        <p:txBody>
-          <a:bodyPr wrap="square" lIns="0" rIns="0" tIns="0" bIns="0">
-            <a:spAutoFit/>
-          </a:bodyPr>
-          <a:lstStyle/>
-          <a:p>
-            <a:pPr algn="l">
-              <a:lnSpc>
-                <a:spcPct val="125000"/>
-              </a:lnSpc>
-              <a:spcBef>
-                <a:spcPts val="0"/>
-              </a:spcBef>
-              <a:spcAft>
-                <a:spcPts val="300"/>
-              </a:spcAft>
-            </a:pPr>
-            <a:r>
-              <a:rPr sz="1900" b="1">
-                <a:solidFill>
-                  <a:srgbClr val="E6EDF3"/>
-                </a:solidFill>
-                <a:latin typeface="Segoe UI"/>
-              </a:rPr>
-              <a:t>Automatize o gate para humanos primeiro</a:t>
-            </a:r>
-          </a:p>
-          <a:p>
-            <a:pPr algn="l">
-              <a:lnSpc>
-                <a:spcPct val="125000"/>
-              </a:lnSpc>
-              <a:spcBef>
-                <a:spcPts val="0"/>
-              </a:spcBef>
-              <a:spcAft>
-                <a:spcPts val="0"/>
-              </a:spcAft>
-            </a:pPr>
-            <a:r>
-              <a:rPr sz="1500" b="0">
-                <a:solidFill>
-                  <a:srgbClr val="9198A1"/>
-                </a:solidFill>
-                <a:latin typeface="Segoe UI"/>
-              </a:rPr>
-              <a:t>Se o seu CI não reprova um PR humano mal formatado, ele não vai reprovar o de um agente.</a:t>
-            </a:r>
-          </a:p>
-        </p:txBody>
-      </p:sp>
-      <p:sp>
-        <p:nvSpPr>
-          <p:cNvPr id="10" name="Rounded Rectangle 9"/>
-          <p:cNvSpPr/>
-          <p:nvPr/>
-        </p:nvSpPr>
-        <p:spPr>
-          <a:xfrm>
-            <a:off x="777240" y="3639312"/>
-            <a:ext cx="457200" cy="457200"/>
-          </a:xfrm>
-          <a:prstGeom prst="roundRect">
-            <a:avLst>
-              <a:gd name="adj" fmla="val 8000"/>
-            </a:avLst>
-          </a:prstGeom>
-          <a:solidFill>
-            <a:srgbClr val="010409"/>
+            <a:srgbClr val="161B22"/>
           </a:solidFill>
           <a:ln w="12700">
             <a:solidFill>
@@ -22369,42 +22345,64 @@
           </a:fontRef>
         </p:style>
         <p:txBody>
-          <a:bodyPr rtlCol="0" anchor="ctr" wrap="square" lIns="0" rIns="0"/>
-          <a:lstStyle/>
-          <a:p>
-            <a:pPr algn="ctr">
-              <a:lnSpc>
-                <a:spcPct val="125000"/>
-              </a:lnSpc>
-              <a:spcBef>
-                <a:spcPts val="0"/>
-              </a:spcBef>
-              <a:spcAft>
-                <a:spcPts val="0"/>
-              </a:spcAft>
-            </a:pPr>
-            <a:r>
-              <a:rPr sz="1600" b="1">
-                <a:solidFill>
-                  <a:srgbClr val="58A6FF"/>
-                </a:solidFill>
-                <a:latin typeface="Segoe UI"/>
-              </a:rPr>
-              <a:t>3</a:t>
-            </a:r>
-          </a:p>
-        </p:txBody>
-      </p:sp>
-      <p:sp>
-        <p:nvSpPr>
-          <p:cNvPr id="11" name="TextBox 10"/>
+          <a:bodyPr rtlCol="0" anchor="ctr" wrap="square" lIns="320040" tIns="219456" rIns="274320"/>
+          <a:lstStyle/>
+          <a:p>
+            <a:pPr algn="l">
+              <a:lnSpc>
+                <a:spcPct val="125000"/>
+              </a:lnSpc>
+              <a:spcBef>
+                <a:spcPts val="0"/>
+              </a:spcBef>
+              <a:spcAft>
+                <a:spcPts val="800"/>
+              </a:spcAft>
+            </a:pPr>
+            <a:r>
+              <a:rPr sz="2000" b="1">
+                <a:solidFill>
+                  <a:srgbClr val="FFFFFF"/>
+                </a:solidFill>
+                <a:latin typeface="Segoe UI"/>
+              </a:rPr>
+              <a:t>Se você for construir algo assim, orce o dobro do tempo para integração — e nada para 'fazer o modelo entender'.</a:t>
+            </a:r>
+          </a:p>
+          <a:p>
+            <a:pPr algn="l">
+              <a:lnSpc>
+                <a:spcPct val="125000"/>
+              </a:lnSpc>
+              <a:spcBef>
+                <a:spcPts val="0"/>
+              </a:spcBef>
+              <a:spcAft>
+                <a:spcPts val="0"/>
+              </a:spcAft>
+            </a:pPr>
+            <a:r>
+              <a:rPr sz="1700" b="0">
+                <a:solidFill>
+                  <a:srgbClr val="9198A1"/>
+                </a:solidFill>
+                <a:latin typeface="Segoe UI"/>
+              </a:rPr>
+              <a:t>O modelo é a parte que já funciona.</a:t>
+            </a:r>
+          </a:p>
+        </p:txBody>
+      </p:sp>
+      <p:sp>
+        <p:nvSpPr>
+          <p:cNvPr id="8" name="TextBox 7"/>
           <p:cNvSpPr txBox="1"/>
           <p:nvPr/>
         </p:nvSpPr>
         <p:spPr>
           <a:xfrm>
-            <a:off x="1490472" y="3621024"/>
-            <a:ext cx="10058400" cy="731520"/>
+            <a:off x="777240" y="6291072"/>
+            <a:ext cx="7446050" cy="274320"/>
           </a:xfrm>
           <a:prstGeom prst="rect">
             <a:avLst/>
@@ -22425,120 +22423,31 @@
                 <a:spcPts val="0"/>
               </a:spcBef>
               <a:spcAft>
-                <a:spcPts val="300"/>
-              </a:spcAft>
-            </a:pPr>
-            <a:r>
-              <a:rPr sz="1900" b="1">
-                <a:solidFill>
-                  <a:srgbClr val="E6EDF3"/>
-                </a:solidFill>
-                <a:latin typeface="Segoe UI"/>
-              </a:rPr>
-              <a:t>Um agente, uma issue, um worktree</a:t>
-            </a:r>
-          </a:p>
-          <a:p>
-            <a:pPr algn="l">
-              <a:lnSpc>
-                <a:spcPct val="125000"/>
-              </a:lnSpc>
-              <a:spcBef>
-                <a:spcPts val="0"/>
-              </a:spcBef>
-              <a:spcAft>
-                <a:spcPts val="0"/>
-              </a:spcAft>
-            </a:pPr>
-            <a:r>
-              <a:rPr sz="1500" b="0">
-                <a:solidFill>
-                  <a:srgbClr val="9198A1"/>
-                </a:solidFill>
-                <a:latin typeface="Segoe UI"/>
-              </a:rPr>
-              <a:t>Não comece com cinco. Faça um funcionar de ponta a ponta, incluindo o PR.</a:t>
-            </a:r>
-          </a:p>
-        </p:txBody>
-      </p:sp>
-      <p:sp>
-        <p:nvSpPr>
-          <p:cNvPr id="12" name="Rounded Rectangle 11"/>
-          <p:cNvSpPr/>
-          <p:nvPr/>
-        </p:nvSpPr>
-        <p:spPr>
-          <a:xfrm>
-            <a:off x="777240" y="4553712"/>
-            <a:ext cx="457200" cy="457200"/>
-          </a:xfrm>
-          <a:prstGeom prst="roundRect">
-            <a:avLst>
-              <a:gd name="adj" fmla="val 8000"/>
-            </a:avLst>
-          </a:prstGeom>
-          <a:solidFill>
-            <a:srgbClr val="010409"/>
-          </a:solidFill>
-          <a:ln w="12700">
-            <a:solidFill>
-              <a:srgbClr val="58A6FF"/>
-            </a:solidFill>
-          </a:ln>
-          <a:effectLst/>
-        </p:spPr>
-        <p:style>
-          <a:lnRef idx="1">
-            <a:schemeClr val="accent1"/>
-          </a:lnRef>
-          <a:fillRef idx="3">
-            <a:schemeClr val="accent1"/>
-          </a:fillRef>
-          <a:effectRef idx="2">
-            <a:schemeClr val="accent1"/>
-          </a:effectRef>
-          <a:fontRef idx="minor">
-            <a:schemeClr val="lt1"/>
-          </a:fontRef>
-        </p:style>
-        <p:txBody>
-          <a:bodyPr rtlCol="0" anchor="ctr" wrap="square" lIns="0" rIns="0"/>
-          <a:lstStyle/>
-          <a:p>
-            <a:pPr algn="ctr">
-              <a:lnSpc>
-                <a:spcPct val="125000"/>
-              </a:lnSpc>
-              <a:spcBef>
-                <a:spcPts val="0"/>
-              </a:spcBef>
-              <a:spcAft>
-                <a:spcPts val="0"/>
-              </a:spcAft>
-            </a:pPr>
-            <a:r>
-              <a:rPr sz="1600" b="1">
-                <a:solidFill>
-                  <a:srgbClr val="58A6FF"/>
-                </a:solidFill>
-                <a:latin typeface="Segoe UI"/>
-              </a:rPr>
-              <a:t>4</a:t>
-            </a:r>
-          </a:p>
-        </p:txBody>
-      </p:sp>
-      <p:sp>
-        <p:nvSpPr>
-          <p:cNvPr id="13" name="TextBox 12"/>
+                <a:spcPts val="0"/>
+              </a:spcAft>
+            </a:pPr>
+            <a:r>
+              <a:rPr sz="1100" b="0">
+                <a:solidFill>
+                  <a:srgbClr val="6E7681"/>
+                </a:solidFill>
+                <a:latin typeface="Segoe UI"/>
+              </a:rPr>
+              <a:t>Agent Squad · TDC São Paulo 2026</a:t>
+            </a:r>
+          </a:p>
+        </p:txBody>
+      </p:sp>
+      <p:sp>
+        <p:nvSpPr>
+          <p:cNvPr id="9" name="TextBox 8"/>
           <p:cNvSpPr txBox="1"/>
           <p:nvPr/>
         </p:nvSpPr>
         <p:spPr>
           <a:xfrm>
-            <a:off x="1490472" y="4535424"/>
-            <a:ext cx="10058400" cy="731520"/>
+            <a:off x="10317175" y="6291072"/>
+            <a:ext cx="1097280" cy="274320"/>
           </a:xfrm>
           <a:prstGeom prst="rect">
             <a:avLst/>
@@ -22551,208 +22460,7 @@
           </a:bodyPr>
           <a:lstStyle/>
           <a:p>
-            <a:pPr algn="l">
-              <a:lnSpc>
-                <a:spcPct val="125000"/>
-              </a:lnSpc>
-              <a:spcBef>
-                <a:spcPts val="0"/>
-              </a:spcBef>
-              <a:spcAft>
-                <a:spcPts val="300"/>
-              </a:spcAft>
-            </a:pPr>
-            <a:r>
-              <a:rPr sz="1900" b="1">
-                <a:solidFill>
-                  <a:srgbClr val="E6EDF3"/>
-                </a:solidFill>
-                <a:latin typeface="Segoe UI"/>
-              </a:rPr>
-              <a:t>Só então paralelize</a:t>
-            </a:r>
-          </a:p>
-          <a:p>
-            <a:pPr algn="l">
-              <a:lnSpc>
-                <a:spcPct val="125000"/>
-              </a:lnSpc>
-              <a:spcBef>
-                <a:spcPts val="0"/>
-              </a:spcBef>
-              <a:spcAft>
-                <a:spcPts val="0"/>
-              </a:spcAft>
-            </a:pPr>
-            <a:r>
-              <a:rPr sz="1500" b="0">
-                <a:solidFill>
-                  <a:srgbClr val="9198A1"/>
-                </a:solidFill>
-                <a:latin typeface="Segoe UI"/>
-              </a:rPr>
-              <a:t>E no minuto em que paralelizar, implemente a regra do conflito de arquivo.</a:t>
-            </a:r>
-          </a:p>
-        </p:txBody>
-      </p:sp>
-      <p:sp>
-        <p:nvSpPr>
-          <p:cNvPr id="14" name="Rounded Rectangle 13"/>
-          <p:cNvSpPr/>
-          <p:nvPr/>
-        </p:nvSpPr>
-        <p:spPr>
-          <a:xfrm>
-            <a:off x="777240" y="5468112"/>
-            <a:ext cx="457200" cy="457200"/>
-          </a:xfrm>
-          <a:prstGeom prst="roundRect">
-            <a:avLst>
-              <a:gd name="adj" fmla="val 8000"/>
-            </a:avLst>
-          </a:prstGeom>
-          <a:solidFill>
-            <a:srgbClr val="010409"/>
-          </a:solidFill>
-          <a:ln w="12700">
-            <a:solidFill>
-              <a:srgbClr val="D29922"/>
-            </a:solidFill>
-          </a:ln>
-          <a:effectLst/>
-        </p:spPr>
-        <p:style>
-          <a:lnRef idx="1">
-            <a:schemeClr val="accent1"/>
-          </a:lnRef>
-          <a:fillRef idx="3">
-            <a:schemeClr val="accent1"/>
-          </a:fillRef>
-          <a:effectRef idx="2">
-            <a:schemeClr val="accent1"/>
-          </a:effectRef>
-          <a:fontRef idx="minor">
-            <a:schemeClr val="lt1"/>
-          </a:fontRef>
-        </p:style>
-        <p:txBody>
-          <a:bodyPr rtlCol="0" anchor="ctr" wrap="square" lIns="0" rIns="0"/>
-          <a:lstStyle/>
-          <a:p>
-            <a:pPr algn="ctr">
-              <a:lnSpc>
-                <a:spcPct val="125000"/>
-              </a:lnSpc>
-              <a:spcBef>
-                <a:spcPts val="0"/>
-              </a:spcBef>
-              <a:spcAft>
-                <a:spcPts val="0"/>
-              </a:spcAft>
-            </a:pPr>
-            <a:r>
-              <a:rPr sz="1600" b="1">
-                <a:solidFill>
-                  <a:srgbClr val="D29922"/>
-                </a:solidFill>
-                <a:latin typeface="Segoe UI"/>
-              </a:rPr>
-              <a:t>5</a:t>
-            </a:r>
-          </a:p>
-        </p:txBody>
-      </p:sp>
-      <p:sp>
-        <p:nvSpPr>
-          <p:cNvPr id="15" name="TextBox 14"/>
-          <p:cNvSpPr txBox="1"/>
-          <p:nvPr/>
-        </p:nvSpPr>
-        <p:spPr>
-          <a:xfrm>
-            <a:off x="1490472" y="5449824"/>
-            <a:ext cx="10058400" cy="731520"/>
-          </a:xfrm>
-          <a:prstGeom prst="rect">
-            <a:avLst/>
-          </a:prstGeom>
-          <a:noFill/>
-        </p:spPr>
-        <p:txBody>
-          <a:bodyPr wrap="square" lIns="0" rIns="0" tIns="0" bIns="0">
-            <a:spAutoFit/>
-          </a:bodyPr>
-          <a:lstStyle/>
-          <a:p>
-            <a:pPr algn="l">
-              <a:lnSpc>
-                <a:spcPct val="125000"/>
-              </a:lnSpc>
-              <a:spcBef>
-                <a:spcPts val="0"/>
-              </a:spcBef>
-              <a:spcAft>
-                <a:spcPts val="300"/>
-              </a:spcAft>
-            </a:pPr>
-            <a:r>
-              <a:rPr sz="1900" b="1">
-                <a:solidFill>
-                  <a:srgbClr val="E6EDF3"/>
-                </a:solidFill>
-                <a:latin typeface="Segoe UI"/>
-              </a:rPr>
-              <a:t>Meça antes de otimizar</a:t>
-            </a:r>
-          </a:p>
-          <a:p>
-            <a:pPr algn="l">
-              <a:lnSpc>
-                <a:spcPct val="125000"/>
-              </a:lnSpc>
-              <a:spcBef>
-                <a:spcPts val="0"/>
-              </a:spcBef>
-              <a:spcAft>
-                <a:spcPts val="0"/>
-              </a:spcAft>
-            </a:pPr>
-            <a:r>
-              <a:rPr sz="1500" b="0">
-                <a:solidFill>
-                  <a:srgbClr val="9198A1"/>
-                </a:solidFill>
-                <a:latin typeface="Segoe UI"/>
-              </a:rPr>
-              <a:t>Quanto custa uma execução? Quantos reparos por item? Onde o tempo vai?</a:t>
-            </a:r>
-          </a:p>
-        </p:txBody>
-      </p:sp>
-      <p:sp>
-        <p:nvSpPr>
-          <p:cNvPr id="16" name="TextBox 15"/>
-          <p:cNvSpPr txBox="1"/>
-          <p:nvPr/>
-        </p:nvSpPr>
-        <p:spPr>
-          <a:xfrm>
-            <a:off x="777240" y="6291072"/>
-            <a:ext cx="7446050" cy="274320"/>
-          </a:xfrm>
-          <a:prstGeom prst="rect">
-            <a:avLst/>
-          </a:prstGeom>
-          <a:noFill/>
-        </p:spPr>
-        <p:txBody>
-          <a:bodyPr wrap="square" lIns="0" rIns="0" tIns="0" bIns="0">
-            <a:spAutoFit/>
-          </a:bodyPr>
-          <a:lstStyle/>
-          <a:p>
-            <a:pPr algn="l">
+            <a:pPr algn="r">
               <a:lnSpc>
                 <a:spcPct val="125000"/>
               </a:lnSpc>
@@ -22770,52 +22478,7 @@
                 </a:solidFill>
                 <a:latin typeface="Segoe UI"/>
               </a:rPr>
-              <a:t>Agent Squad · TDC São Paulo 2026</a:t>
-            </a:r>
-          </a:p>
-        </p:txBody>
-      </p:sp>
-      <p:sp>
-        <p:nvSpPr>
-          <p:cNvPr id="17" name="TextBox 16"/>
-          <p:cNvSpPr txBox="1"/>
-          <p:nvPr/>
-        </p:nvSpPr>
-        <p:spPr>
-          <a:xfrm>
-            <a:off x="10317175" y="6291072"/>
-            <a:ext cx="1097280" cy="274320"/>
-          </a:xfrm>
-          <a:prstGeom prst="rect">
-            <a:avLst/>
-          </a:prstGeom>
-          <a:noFill/>
-        </p:spPr>
-        <p:txBody>
-          <a:bodyPr wrap="square" lIns="0" rIns="0" tIns="0" bIns="0">
-            <a:spAutoFit/>
-          </a:bodyPr>
-          <a:lstStyle/>
-          <a:p>
-            <a:pPr algn="r">
-              <a:lnSpc>
-                <a:spcPct val="125000"/>
-              </a:lnSpc>
-              <a:spcBef>
-                <a:spcPts val="0"/>
-              </a:spcBef>
-              <a:spcAft>
-                <a:spcPts val="0"/>
-              </a:spcAft>
-            </a:pPr>
-            <a:r>
-              <a:rPr sz="1100" b="0">
-                <a:solidFill>
-                  <a:srgbClr val="6E7681"/>
-                </a:solidFill>
-                <a:latin typeface="Segoe UI"/>
-              </a:rPr>
-              <a:t>31/35</a:t>
+              <a:t>31/36</a:t>
             </a:r>
           </a:p>
         </p:txBody>
@@ -22967,7 +22630,7 @@
                 </a:solidFill>
                 <a:latin typeface="Segoe UI"/>
               </a:rPr>
-              <a:t>O que não negociar</a:t>
+              <a:t>Por onde começar na segunda-feira</a:t>
             </a:r>
           </a:p>
         </p:txBody>
@@ -23018,14 +22681,81 @@
       </p:sp>
       <p:sp>
         <p:nvSpPr>
-          <p:cNvPr id="6" name="TextBox 5"/>
+          <p:cNvPr id="6" name="Rounded Rectangle 5"/>
+          <p:cNvSpPr/>
+          <p:nvPr/>
+        </p:nvSpPr>
+        <p:spPr>
+          <a:xfrm>
+            <a:off x="777240" y="1810512"/>
+            <a:ext cx="457200" cy="457200"/>
+          </a:xfrm>
+          <a:prstGeom prst="roundRect">
+            <a:avLst>
+              <a:gd name="adj" fmla="val 8000"/>
+            </a:avLst>
+          </a:prstGeom>
+          <a:solidFill>
+            <a:srgbClr val="010409"/>
+          </a:solidFill>
+          <a:ln w="12700">
+            <a:solidFill>
+              <a:srgbClr val="3FB950"/>
+            </a:solidFill>
+          </a:ln>
+          <a:effectLst/>
+        </p:spPr>
+        <p:style>
+          <a:lnRef idx="1">
+            <a:schemeClr val="accent1"/>
+          </a:lnRef>
+          <a:fillRef idx="3">
+            <a:schemeClr val="accent1"/>
+          </a:fillRef>
+          <a:effectRef idx="2">
+            <a:schemeClr val="accent1"/>
+          </a:effectRef>
+          <a:fontRef idx="minor">
+            <a:schemeClr val="lt1"/>
+          </a:fontRef>
+        </p:style>
+        <p:txBody>
+          <a:bodyPr rtlCol="0" anchor="ctr" wrap="square" lIns="0" rIns="0"/>
+          <a:lstStyle/>
+          <a:p>
+            <a:pPr algn="ctr">
+              <a:lnSpc>
+                <a:spcPct val="125000"/>
+              </a:lnSpc>
+              <a:spcBef>
+                <a:spcPts val="0"/>
+              </a:spcBef>
+              <a:spcAft>
+                <a:spcPts val="0"/>
+              </a:spcAft>
+            </a:pPr>
+            <a:r>
+              <a:rPr sz="1600" b="1">
+                <a:solidFill>
+                  <a:srgbClr val="3FB950"/>
+                </a:solidFill>
+                <a:latin typeface="Segoe UI"/>
+              </a:rPr>
+              <a:t>1</a:t>
+            </a:r>
+          </a:p>
+        </p:txBody>
+      </p:sp>
+      <p:sp>
+        <p:nvSpPr>
+          <p:cNvPr id="7" name="TextBox 6"/>
           <p:cNvSpPr txBox="1"/>
           <p:nvPr/>
         </p:nvSpPr>
         <p:spPr>
           <a:xfrm>
-            <a:off x="777240" y="1901952"/>
-            <a:ext cx="10637215" cy="4133088"/>
+            <a:off x="1490472" y="1792224"/>
+            <a:ext cx="10058400" cy="731520"/>
           </a:xfrm>
           <a:prstGeom prst="rect">
             <a:avLst/>
@@ -23042,235 +22772,459 @@
               <a:lnSpc>
                 <a:spcPct val="125000"/>
               </a:lnSpc>
-              <a:spcAft>
-                <a:spcPts val="1600"/>
-              </a:spcAft>
-            </a:pPr>
-            <a:r>
-              <a:rPr sz="1800" b="1">
+              <a:spcBef>
+                <a:spcPts val="0"/>
+              </a:spcBef>
+              <a:spcAft>
+                <a:spcPts val="300"/>
+              </a:spcAft>
+            </a:pPr>
+            <a:r>
+              <a:rPr sz="1900" b="1">
+                <a:solidFill>
+                  <a:srgbClr val="E6EDF3"/>
+                </a:solidFill>
+                <a:latin typeface="Segoe UI"/>
+              </a:rPr>
+              <a:t>Escreva as regras antes do agente</a:t>
+            </a:r>
+          </a:p>
+          <a:p>
+            <a:pPr algn="l">
+              <a:lnSpc>
+                <a:spcPct val="125000"/>
+              </a:lnSpc>
+              <a:spcBef>
+                <a:spcPts val="0"/>
+              </a:spcBef>
+              <a:spcAft>
+                <a:spcPts val="0"/>
+              </a:spcAft>
+            </a:pPr>
+            <a:r>
+              <a:rPr sz="1500" b="0">
+                <a:solidFill>
+                  <a:srgbClr val="9198A1"/>
+                </a:solidFill>
+                <a:latin typeface="Segoe UI"/>
+              </a:rPr>
+              <a:t>docs/engineering-rules.md com identificador estável. Sem isso, você não tem como dizer se o agente acertou.</a:t>
+            </a:r>
+          </a:p>
+        </p:txBody>
+      </p:sp>
+      <p:sp>
+        <p:nvSpPr>
+          <p:cNvPr id="8" name="Rounded Rectangle 7"/>
+          <p:cNvSpPr/>
+          <p:nvPr/>
+        </p:nvSpPr>
+        <p:spPr>
+          <a:xfrm>
+            <a:off x="777240" y="2724912"/>
+            <a:ext cx="457200" cy="457200"/>
+          </a:xfrm>
+          <a:prstGeom prst="roundRect">
+            <a:avLst>
+              <a:gd name="adj" fmla="val 8000"/>
+            </a:avLst>
+          </a:prstGeom>
+          <a:solidFill>
+            <a:srgbClr val="010409"/>
+          </a:solidFill>
+          <a:ln w="12700">
+            <a:solidFill>
+              <a:srgbClr val="3FB950"/>
+            </a:solidFill>
+          </a:ln>
+          <a:effectLst/>
+        </p:spPr>
+        <p:style>
+          <a:lnRef idx="1">
+            <a:schemeClr val="accent1"/>
+          </a:lnRef>
+          <a:fillRef idx="3">
+            <a:schemeClr val="accent1"/>
+          </a:fillRef>
+          <a:effectRef idx="2">
+            <a:schemeClr val="accent1"/>
+          </a:effectRef>
+          <a:fontRef idx="minor">
+            <a:schemeClr val="lt1"/>
+          </a:fontRef>
+        </p:style>
+        <p:txBody>
+          <a:bodyPr rtlCol="0" anchor="ctr" wrap="square" lIns="0" rIns="0"/>
+          <a:lstStyle/>
+          <a:p>
+            <a:pPr algn="ctr">
+              <a:lnSpc>
+                <a:spcPct val="125000"/>
+              </a:lnSpc>
+              <a:spcBef>
+                <a:spcPts val="0"/>
+              </a:spcBef>
+              <a:spcAft>
+                <a:spcPts val="0"/>
+              </a:spcAft>
+            </a:pPr>
+            <a:r>
+              <a:rPr sz="1600" b="1">
+                <a:solidFill>
+                  <a:srgbClr val="3FB950"/>
+                </a:solidFill>
+                <a:latin typeface="Segoe UI"/>
+              </a:rPr>
+              <a:t>2</a:t>
+            </a:r>
+          </a:p>
+        </p:txBody>
+      </p:sp>
+      <p:sp>
+        <p:nvSpPr>
+          <p:cNvPr id="9" name="TextBox 8"/>
+          <p:cNvSpPr txBox="1"/>
+          <p:nvPr/>
+        </p:nvSpPr>
+        <p:spPr>
+          <a:xfrm>
+            <a:off x="1490472" y="2706624"/>
+            <a:ext cx="10058400" cy="731520"/>
+          </a:xfrm>
+          <a:prstGeom prst="rect">
+            <a:avLst/>
+          </a:prstGeom>
+          <a:noFill/>
+        </p:spPr>
+        <p:txBody>
+          <a:bodyPr wrap="square" lIns="0" rIns="0" tIns="0" bIns="0">
+            <a:spAutoFit/>
+          </a:bodyPr>
+          <a:lstStyle/>
+          <a:p>
+            <a:pPr algn="l">
+              <a:lnSpc>
+                <a:spcPct val="125000"/>
+              </a:lnSpc>
+              <a:spcBef>
+                <a:spcPts val="0"/>
+              </a:spcBef>
+              <a:spcAft>
+                <a:spcPts val="300"/>
+              </a:spcAft>
+            </a:pPr>
+            <a:r>
+              <a:rPr sz="1900" b="1">
+                <a:solidFill>
+                  <a:srgbClr val="E6EDF3"/>
+                </a:solidFill>
+                <a:latin typeface="Segoe UI"/>
+              </a:rPr>
+              <a:t>Automatize o gate para humanos primeiro</a:t>
+            </a:r>
+          </a:p>
+          <a:p>
+            <a:pPr algn="l">
+              <a:lnSpc>
+                <a:spcPct val="125000"/>
+              </a:lnSpc>
+              <a:spcBef>
+                <a:spcPts val="0"/>
+              </a:spcBef>
+              <a:spcAft>
+                <a:spcPts val="0"/>
+              </a:spcAft>
+            </a:pPr>
+            <a:r>
+              <a:rPr sz="1500" b="0">
+                <a:solidFill>
+                  <a:srgbClr val="9198A1"/>
+                </a:solidFill>
+                <a:latin typeface="Segoe UI"/>
+              </a:rPr>
+              <a:t>Se o seu CI não reprova um PR humano mal formatado, ele não vai reprovar o de um agente.</a:t>
+            </a:r>
+          </a:p>
+        </p:txBody>
+      </p:sp>
+      <p:sp>
+        <p:nvSpPr>
+          <p:cNvPr id="10" name="Rounded Rectangle 9"/>
+          <p:cNvSpPr/>
+          <p:nvPr/>
+        </p:nvSpPr>
+        <p:spPr>
+          <a:xfrm>
+            <a:off x="777240" y="3639312"/>
+            <a:ext cx="457200" cy="457200"/>
+          </a:xfrm>
+          <a:prstGeom prst="roundRect">
+            <a:avLst>
+              <a:gd name="adj" fmla="val 8000"/>
+            </a:avLst>
+          </a:prstGeom>
+          <a:solidFill>
+            <a:srgbClr val="010409"/>
+          </a:solidFill>
+          <a:ln w="12700">
+            <a:solidFill>
+              <a:srgbClr val="58A6FF"/>
+            </a:solidFill>
+          </a:ln>
+          <a:effectLst/>
+        </p:spPr>
+        <p:style>
+          <a:lnRef idx="1">
+            <a:schemeClr val="accent1"/>
+          </a:lnRef>
+          <a:fillRef idx="3">
+            <a:schemeClr val="accent1"/>
+          </a:fillRef>
+          <a:effectRef idx="2">
+            <a:schemeClr val="accent1"/>
+          </a:effectRef>
+          <a:fontRef idx="minor">
+            <a:schemeClr val="lt1"/>
+          </a:fontRef>
+        </p:style>
+        <p:txBody>
+          <a:bodyPr rtlCol="0" anchor="ctr" wrap="square" lIns="0" rIns="0"/>
+          <a:lstStyle/>
+          <a:p>
+            <a:pPr algn="ctr">
+              <a:lnSpc>
+                <a:spcPct val="125000"/>
+              </a:lnSpc>
+              <a:spcBef>
+                <a:spcPts val="0"/>
+              </a:spcBef>
+              <a:spcAft>
+                <a:spcPts val="0"/>
+              </a:spcAft>
+            </a:pPr>
+            <a:r>
+              <a:rPr sz="1600" b="1">
                 <a:solidFill>
                   <a:srgbClr val="58A6FF"/>
                 </a:solidFill>
                 <a:latin typeface="Segoe UI"/>
               </a:rPr>
-              <a:t>—  </a:t>
-            </a:r>
-            <a:r>
-              <a:rPr sz="1800" b="1">
+              <a:t>3</a:t>
+            </a:r>
+          </a:p>
+        </p:txBody>
+      </p:sp>
+      <p:sp>
+        <p:nvSpPr>
+          <p:cNvPr id="11" name="TextBox 10"/>
+          <p:cNvSpPr txBox="1"/>
+          <p:nvPr/>
+        </p:nvSpPr>
+        <p:spPr>
+          <a:xfrm>
+            <a:off x="1490472" y="3621024"/>
+            <a:ext cx="10058400" cy="731520"/>
+          </a:xfrm>
+          <a:prstGeom prst="rect">
+            <a:avLst/>
+          </a:prstGeom>
+          <a:noFill/>
+        </p:spPr>
+        <p:txBody>
+          <a:bodyPr wrap="square" lIns="0" rIns="0" tIns="0" bIns="0">
+            <a:spAutoFit/>
+          </a:bodyPr>
+          <a:lstStyle/>
+          <a:p>
+            <a:pPr algn="l">
+              <a:lnSpc>
+                <a:spcPct val="125000"/>
+              </a:lnSpc>
+              <a:spcBef>
+                <a:spcPts val="0"/>
+              </a:spcBef>
+              <a:spcAft>
+                <a:spcPts val="300"/>
+              </a:spcAft>
+            </a:pPr>
+            <a:r>
+              <a:rPr sz="1900" b="1">
                 <a:solidFill>
                   <a:srgbClr val="E6EDF3"/>
                 </a:solidFill>
                 <a:latin typeface="Segoe UI"/>
               </a:rPr>
-              <a:t>Verificação determinística. </a:t>
-            </a:r>
-            <a:r>
-              <a:rPr sz="1800" b="0">
+              <a:t>Um agente, uma issue, um worktree</a:t>
+            </a:r>
+          </a:p>
+          <a:p>
+            <a:pPr algn="l">
+              <a:lnSpc>
+                <a:spcPct val="125000"/>
+              </a:lnSpc>
+              <a:spcBef>
+                <a:spcPts val="0"/>
+              </a:spcBef>
+              <a:spcAft>
+                <a:spcPts val="0"/>
+              </a:spcAft>
+            </a:pPr>
+            <a:r>
+              <a:rPr sz="1500" b="0">
                 <a:solidFill>
                   <a:srgbClr val="9198A1"/>
                 </a:solidFill>
                 <a:latin typeface="Segoe UI"/>
               </a:rPr>
-              <a:t>O modelo produz, o programa verifica. Sempre.</a:t>
-            </a:r>
-          </a:p>
-          <a:p>
-            <a:pPr algn="l">
-              <a:lnSpc>
-                <a:spcPct val="125000"/>
-              </a:lnSpc>
-              <a:spcAft>
-                <a:spcPts val="1600"/>
-              </a:spcAft>
-            </a:pPr>
-            <a:r>
-              <a:rPr sz="1800" b="1">
+              <a:t>Não comece com cinco. Faça um funcionar de ponta a ponta, incluindo o PR.</a:t>
+            </a:r>
+          </a:p>
+        </p:txBody>
+      </p:sp>
+      <p:sp>
+        <p:nvSpPr>
+          <p:cNvPr id="12" name="Rounded Rectangle 11"/>
+          <p:cNvSpPr/>
+          <p:nvPr/>
+        </p:nvSpPr>
+        <p:spPr>
+          <a:xfrm>
+            <a:off x="777240" y="4553712"/>
+            <a:ext cx="457200" cy="457200"/>
+          </a:xfrm>
+          <a:prstGeom prst="roundRect">
+            <a:avLst>
+              <a:gd name="adj" fmla="val 8000"/>
+            </a:avLst>
+          </a:prstGeom>
+          <a:solidFill>
+            <a:srgbClr val="010409"/>
+          </a:solidFill>
+          <a:ln w="12700">
+            <a:solidFill>
+              <a:srgbClr val="58A6FF"/>
+            </a:solidFill>
+          </a:ln>
+          <a:effectLst/>
+        </p:spPr>
+        <p:style>
+          <a:lnRef idx="1">
+            <a:schemeClr val="accent1"/>
+          </a:lnRef>
+          <a:fillRef idx="3">
+            <a:schemeClr val="accent1"/>
+          </a:fillRef>
+          <a:effectRef idx="2">
+            <a:schemeClr val="accent1"/>
+          </a:effectRef>
+          <a:fontRef idx="minor">
+            <a:schemeClr val="lt1"/>
+          </a:fontRef>
+        </p:style>
+        <p:txBody>
+          <a:bodyPr rtlCol="0" anchor="ctr" wrap="square" lIns="0" rIns="0"/>
+          <a:lstStyle/>
+          <a:p>
+            <a:pPr algn="ctr">
+              <a:lnSpc>
+                <a:spcPct val="125000"/>
+              </a:lnSpc>
+              <a:spcBef>
+                <a:spcPts val="0"/>
+              </a:spcBef>
+              <a:spcAft>
+                <a:spcPts val="0"/>
+              </a:spcAft>
+            </a:pPr>
+            <a:r>
+              <a:rPr sz="1600" b="1">
                 <a:solidFill>
                   <a:srgbClr val="58A6FF"/>
                 </a:solidFill>
                 <a:latin typeface="Segoe UI"/>
               </a:rPr>
-              <a:t>—  </a:t>
-            </a:r>
-            <a:r>
-              <a:rPr sz="1800" b="1">
+              <a:t>4</a:t>
+            </a:r>
+          </a:p>
+        </p:txBody>
+      </p:sp>
+      <p:sp>
+        <p:nvSpPr>
+          <p:cNvPr id="13" name="TextBox 12"/>
+          <p:cNvSpPr txBox="1"/>
+          <p:nvPr/>
+        </p:nvSpPr>
+        <p:spPr>
+          <a:xfrm>
+            <a:off x="1490472" y="4535424"/>
+            <a:ext cx="10058400" cy="731520"/>
+          </a:xfrm>
+          <a:prstGeom prst="rect">
+            <a:avLst/>
+          </a:prstGeom>
+          <a:noFill/>
+        </p:spPr>
+        <p:txBody>
+          <a:bodyPr wrap="square" lIns="0" rIns="0" tIns="0" bIns="0">
+            <a:spAutoFit/>
+          </a:bodyPr>
+          <a:lstStyle/>
+          <a:p>
+            <a:pPr algn="l">
+              <a:lnSpc>
+                <a:spcPct val="125000"/>
+              </a:lnSpc>
+              <a:spcBef>
+                <a:spcPts val="0"/>
+              </a:spcBef>
+              <a:spcAft>
+                <a:spcPts val="300"/>
+              </a:spcAft>
+            </a:pPr>
+            <a:r>
+              <a:rPr sz="1900" b="1">
                 <a:solidFill>
                   <a:srgbClr val="E6EDF3"/>
                 </a:solidFill>
                 <a:latin typeface="Segoe UI"/>
               </a:rPr>
-              <a:t>Merge humano. </a:t>
-            </a:r>
-            <a:r>
-              <a:rPr sz="1800" b="0">
+              <a:t>Só então paralelize</a:t>
+            </a:r>
+          </a:p>
+          <a:p>
+            <a:pPr algn="l">
+              <a:lnSpc>
+                <a:spcPct val="125000"/>
+              </a:lnSpc>
+              <a:spcBef>
+                <a:spcPts val="0"/>
+              </a:spcBef>
+              <a:spcAft>
+                <a:spcPts val="0"/>
+              </a:spcAft>
+            </a:pPr>
+            <a:r>
+              <a:rPr sz="1500" b="0">
                 <a:solidFill>
                   <a:srgbClr val="9198A1"/>
                 </a:solidFill>
                 <a:latin typeface="Segoe UI"/>
               </a:rPr>
-              <a:t>Sem exceção, por mais confiável que o agente pareça.</a:t>
-            </a:r>
-          </a:p>
-          <a:p>
-            <a:pPr algn="l">
-              <a:lnSpc>
-                <a:spcPct val="125000"/>
-              </a:lnSpc>
-              <a:spcAft>
-                <a:spcPts val="1600"/>
-              </a:spcAft>
-            </a:pPr>
-            <a:r>
-              <a:rPr sz="1800" b="1">
-                <a:solidFill>
-                  <a:srgbClr val="58A6FF"/>
-                </a:solidFill>
-                <a:latin typeface="Segoe UI"/>
-              </a:rPr>
-              <a:t>—  </a:t>
-            </a:r>
-            <a:r>
-              <a:rPr sz="1800" b="1">
-                <a:solidFill>
-                  <a:srgbClr val="E6EDF3"/>
-                </a:solidFill>
-                <a:latin typeface="Segoe UI"/>
-              </a:rPr>
-              <a:t>Sandbox técnico, não instrução. </a:t>
-            </a:r>
-            <a:r>
-              <a:rPr sz="1800" b="0">
-                <a:solidFill>
-                  <a:srgbClr val="9198A1"/>
-                </a:solidFill>
-                <a:latin typeface="Segoe UI"/>
-              </a:rPr>
-              <a:t>Impedir é diferente de pedir. Numa auditoria, muito diferente.</a:t>
-            </a:r>
-          </a:p>
-          <a:p>
-            <a:pPr algn="l">
-              <a:lnSpc>
-                <a:spcPct val="125000"/>
-              </a:lnSpc>
-              <a:spcAft>
-                <a:spcPts val="1600"/>
-              </a:spcAft>
-            </a:pPr>
-            <a:r>
-              <a:rPr sz="1800" b="1">
-                <a:solidFill>
-                  <a:srgbClr val="58A6FF"/>
-                </a:solidFill>
-                <a:latin typeface="Segoe UI"/>
-              </a:rPr>
-              <a:t>—  </a:t>
-            </a:r>
-            <a:r>
-              <a:rPr sz="1800" b="1">
-                <a:solidFill>
-                  <a:srgbClr val="E6EDF3"/>
-                </a:solidFill>
-                <a:latin typeface="Segoe UI"/>
-              </a:rPr>
-              <a:t>Teto de gasto e de iteração. </a:t>
-            </a:r>
-            <a:r>
-              <a:rPr sz="1800" b="0">
-                <a:solidFill>
-                  <a:srgbClr val="9198A1"/>
-                </a:solidFill>
-                <a:latin typeface="Segoe UI"/>
-              </a:rPr>
-              <a:t>Tentativas, timeout por agente, timeout por execução, limite de concorrência.</a:t>
-            </a:r>
-          </a:p>
-          <a:p>
-            <a:pPr algn="l">
-              <a:lnSpc>
-                <a:spcPct val="125000"/>
-              </a:lnSpc>
-              <a:spcAft>
-                <a:spcPts val="1600"/>
-              </a:spcAft>
-            </a:pPr>
-            <a:r>
-              <a:rPr sz="1800" b="1">
-                <a:solidFill>
-                  <a:srgbClr val="58A6FF"/>
-                </a:solidFill>
-                <a:latin typeface="Segoe UI"/>
-              </a:rPr>
-              <a:t>—  </a:t>
-            </a:r>
-            <a:r>
-              <a:rPr sz="1800" b="1">
-                <a:solidFill>
-                  <a:srgbClr val="E6EDF3"/>
-                </a:solidFill>
-                <a:latin typeface="Segoe UI"/>
-              </a:rPr>
-              <a:t>Auditabilidade. </a:t>
-            </a:r>
-            <a:r>
-              <a:rPr sz="1800" b="0">
-                <a:solidFill>
-                  <a:srgbClr val="9198A1"/>
-                </a:solidFill>
-                <a:latin typeface="Segoe UI"/>
-              </a:rPr>
-              <a:t>Prompt, modelo, tokens, ferramentas chamadas, permissões negadas e diff — tudo gravado.</a:t>
-            </a:r>
-          </a:p>
-          <a:p>
-            <a:pPr algn="l">
-              <a:lnSpc>
-                <a:spcPct val="125000"/>
-              </a:lnSpc>
-              <a:spcAft>
-                <a:spcPts val="1600"/>
-              </a:spcAft>
-            </a:pPr>
-            <a:r>
-              <a:rPr sz="1800" b="1">
-                <a:solidFill>
-                  <a:srgbClr val="58A6FF"/>
-                </a:solidFill>
-                <a:latin typeface="Segoe UI"/>
-              </a:rPr>
-              <a:t>—  </a:t>
-            </a:r>
-            <a:r>
-              <a:rPr sz="1800" b="1">
-                <a:solidFill>
-                  <a:srgbClr val="E6EDF3"/>
-                </a:solidFill>
-                <a:latin typeface="Segoe UI"/>
-              </a:rPr>
-              <a:t>Transparência. </a:t>
-            </a:r>
-            <a:r>
-              <a:rPr sz="1800" b="0">
-                <a:solidFill>
-                  <a:srgbClr val="9198A1"/>
-                </a:solidFill>
-                <a:latin typeface="Segoe UI"/>
-              </a:rPr>
-              <a:t>Todo PR de agente é rotulado e declara qual modelo o produziu.</a:t>
-            </a:r>
-          </a:p>
-        </p:txBody>
-      </p:sp>
-      <p:sp>
-        <p:nvSpPr>
-          <p:cNvPr id="7" name="Rounded Rectangle 6"/>
+              <a:t>E no minuto em que paralelizar, implemente a regra do conflito de arquivo.</a:t>
+            </a:r>
+          </a:p>
+        </p:txBody>
+      </p:sp>
+      <p:sp>
+        <p:nvSpPr>
+          <p:cNvPr id="14" name="Rounded Rectangle 13"/>
           <p:cNvSpPr/>
           <p:nvPr/>
         </p:nvSpPr>
         <p:spPr>
           <a:xfrm>
-            <a:off x="777240" y="5394960"/>
-            <a:ext cx="10637215" cy="777240"/>
+            <a:off x="777240" y="5468112"/>
+            <a:ext cx="457200" cy="457200"/>
           </a:xfrm>
           <a:prstGeom prst="roundRect">
             <a:avLst>
@@ -23302,7 +23256,7 @@
           </a:fontRef>
         </p:style>
         <p:txBody>
-          <a:bodyPr rtlCol="0" anchor="ctr" wrap="square" lIns="320040"/>
+          <a:bodyPr rtlCol="0" anchor="ctr" wrap="square" lIns="0" rIns="0"/>
           <a:lstStyle/>
           <a:p>
             <a:pPr algn="ctr">
@@ -23317,27 +23271,27 @@
               </a:spcAft>
             </a:pPr>
             <a:r>
-              <a:rPr sz="1800" b="0">
-                <a:solidFill>
-                  <a:srgbClr val="E6EDF3"/>
-                </a:solidFill>
-                <a:latin typeface="Segoe UI"/>
-              </a:rPr>
-              <a:t>Essas seis coisas são o que separa uma demo de um sistema que você pode colocar numa empresa.</a:t>
-            </a:r>
-          </a:p>
-        </p:txBody>
-      </p:sp>
-      <p:sp>
-        <p:nvSpPr>
-          <p:cNvPr id="8" name="TextBox 7"/>
+              <a:rPr sz="1600" b="1">
+                <a:solidFill>
+                  <a:srgbClr val="D29922"/>
+                </a:solidFill>
+                <a:latin typeface="Segoe UI"/>
+              </a:rPr>
+              <a:t>5</a:t>
+            </a:r>
+          </a:p>
+        </p:txBody>
+      </p:sp>
+      <p:sp>
+        <p:nvSpPr>
+          <p:cNvPr id="15" name="TextBox 14"/>
           <p:cNvSpPr txBox="1"/>
           <p:nvPr/>
         </p:nvSpPr>
         <p:spPr>
           <a:xfrm>
-            <a:off x="777240" y="6291072"/>
-            <a:ext cx="7446050" cy="274320"/>
+            <a:off x="1490472" y="5449824"/>
+            <a:ext cx="10058400" cy="731520"/>
           </a:xfrm>
           <a:prstGeom prst="rect">
             <a:avLst/>
@@ -23358,31 +23312,53 @@
                 <a:spcPts val="0"/>
               </a:spcBef>
               <a:spcAft>
-                <a:spcPts val="0"/>
-              </a:spcAft>
-            </a:pPr>
-            <a:r>
-              <a:rPr sz="1100" b="0">
-                <a:solidFill>
-                  <a:srgbClr val="6E7681"/>
-                </a:solidFill>
-                <a:latin typeface="Segoe UI"/>
-              </a:rPr>
-              <a:t>Agent Squad · TDC São Paulo 2026</a:t>
-            </a:r>
-          </a:p>
-        </p:txBody>
-      </p:sp>
-      <p:sp>
-        <p:nvSpPr>
-          <p:cNvPr id="9" name="TextBox 8"/>
+                <a:spcPts val="300"/>
+              </a:spcAft>
+            </a:pPr>
+            <a:r>
+              <a:rPr sz="1900" b="1">
+                <a:solidFill>
+                  <a:srgbClr val="E6EDF3"/>
+                </a:solidFill>
+                <a:latin typeface="Segoe UI"/>
+              </a:rPr>
+              <a:t>Meça antes de otimizar</a:t>
+            </a:r>
+          </a:p>
+          <a:p>
+            <a:pPr algn="l">
+              <a:lnSpc>
+                <a:spcPct val="125000"/>
+              </a:lnSpc>
+              <a:spcBef>
+                <a:spcPts val="0"/>
+              </a:spcBef>
+              <a:spcAft>
+                <a:spcPts val="0"/>
+              </a:spcAft>
+            </a:pPr>
+            <a:r>
+              <a:rPr sz="1500" b="0">
+                <a:solidFill>
+                  <a:srgbClr val="9198A1"/>
+                </a:solidFill>
+                <a:latin typeface="Segoe UI"/>
+              </a:rPr>
+              <a:t>Quanto custa uma execução? Quantos reparos por item? Onde o tempo vai?</a:t>
+            </a:r>
+          </a:p>
+        </p:txBody>
+      </p:sp>
+      <p:sp>
+        <p:nvSpPr>
+          <p:cNvPr id="16" name="TextBox 15"/>
           <p:cNvSpPr txBox="1"/>
           <p:nvPr/>
         </p:nvSpPr>
         <p:spPr>
           <a:xfrm>
-            <a:off x="10317175" y="6291072"/>
-            <a:ext cx="1097280" cy="274320"/>
+            <a:off x="777240" y="6291072"/>
+            <a:ext cx="7446050" cy="274320"/>
           </a:xfrm>
           <a:prstGeom prst="rect">
             <a:avLst/>
@@ -23395,6 +23371,51 @@
           </a:bodyPr>
           <a:lstStyle/>
           <a:p>
+            <a:pPr algn="l">
+              <a:lnSpc>
+                <a:spcPct val="125000"/>
+              </a:lnSpc>
+              <a:spcBef>
+                <a:spcPts val="0"/>
+              </a:spcBef>
+              <a:spcAft>
+                <a:spcPts val="0"/>
+              </a:spcAft>
+            </a:pPr>
+            <a:r>
+              <a:rPr sz="1100" b="0">
+                <a:solidFill>
+                  <a:srgbClr val="6E7681"/>
+                </a:solidFill>
+                <a:latin typeface="Segoe UI"/>
+              </a:rPr>
+              <a:t>Agent Squad · TDC São Paulo 2026</a:t>
+            </a:r>
+          </a:p>
+        </p:txBody>
+      </p:sp>
+      <p:sp>
+        <p:nvSpPr>
+          <p:cNvPr id="17" name="TextBox 16"/>
+          <p:cNvSpPr txBox="1"/>
+          <p:nvPr/>
+        </p:nvSpPr>
+        <p:spPr>
+          <a:xfrm>
+            <a:off x="10317175" y="6291072"/>
+            <a:ext cx="1097280" cy="274320"/>
+          </a:xfrm>
+          <a:prstGeom prst="rect">
+            <a:avLst/>
+          </a:prstGeom>
+          <a:noFill/>
+        </p:spPr>
+        <p:txBody>
+          <a:bodyPr wrap="square" lIns="0" rIns="0" tIns="0" bIns="0">
+            <a:spAutoFit/>
+          </a:bodyPr>
+          <a:lstStyle/>
+          <a:p>
             <a:pPr algn="r">
               <a:lnSpc>
                 <a:spcPct val="125000"/>
@@ -23413,7 +23434,7 @@
                 </a:solidFill>
                 <a:latin typeface="Segoe UI"/>
               </a:rPr>
-              <a:t>32/35</a:t>
+              <a:t>32/36</a:t>
             </a:r>
           </a:p>
         </p:txBody>
@@ -23520,7 +23541,7 @@
                 </a:solidFill>
                 <a:latin typeface="Segoe UI"/>
               </a:rPr>
-              <a:t>HONESTIDADE</a:t>
+              <a:t>NA SUA EMPRESA</a:t>
             </a:r>
           </a:p>
         </p:txBody>
@@ -23565,7 +23586,7 @@
                 </a:solidFill>
                 <a:latin typeface="Segoe UI"/>
               </a:rPr>
-              <a:t>O que eu não resolvi</a:t>
+              <a:t>O que não negociar</a:t>
             </a:r>
           </a:p>
         </p:txBody>
@@ -23641,7 +23662,7 @@
                 <a:spcPct val="125000"/>
               </a:lnSpc>
               <a:spcAft>
-                <a:spcPts val="1700"/>
+                <a:spcPts val="1600"/>
               </a:spcAft>
             </a:pPr>
             <a:r>
@@ -23660,7 +23681,7 @@
                 </a:solidFill>
                 <a:latin typeface="Segoe UI"/>
               </a:rPr>
-              <a:t>Custo real por entrega. </a:t>
+              <a:t>Verificação determinística. </a:t>
             </a:r>
             <a:r>
               <a:rPr sz="1800" b="0">
@@ -23669,16 +23690,16 @@
                 </a:solidFill>
                 <a:latin typeface="Segoe UI"/>
               </a:rPr>
-              <a:t>Medi tempo, não dinheiro. Uma execução de 40 min consome tokens de 6 agentes.</a:t>
-            </a:r>
-          </a:p>
-          <a:p>
-            <a:pPr algn="l">
-              <a:lnSpc>
-                <a:spcPct val="125000"/>
-              </a:lnSpc>
-              <a:spcAft>
-                <a:spcPts val="1700"/>
+              <a:t>O modelo produz, o programa verifica. Sempre.</a:t>
+            </a:r>
+          </a:p>
+          <a:p>
+            <a:pPr algn="l">
+              <a:lnSpc>
+                <a:spcPct val="125000"/>
+              </a:lnSpc>
+              <a:spcAft>
+                <a:spcPts val="1600"/>
               </a:spcAft>
             </a:pPr>
             <a:r>
@@ -23697,7 +23718,7 @@
                 </a:solidFill>
                 <a:latin typeface="Segoe UI"/>
               </a:rPr>
-              <a:t>Brownfield grande de verdade. </a:t>
+              <a:t>Um PR que proponha mexer no main. </a:t>
             </a:r>
             <a:r>
               <a:rPr sz="1800" b="0">
@@ -23706,16 +23727,16 @@
                 </a:solidFill>
                 <a:latin typeface="Segoe UI"/>
               </a:rPr>
-              <a:t>Validei greenfield e mudanças pequenas. Repositório legado de 500 mil linhas é outro problema.</a:t>
-            </a:r>
-          </a:p>
-          <a:p>
-            <a:pPr algn="l">
-              <a:lnSpc>
-                <a:spcPct val="125000"/>
-              </a:lnSpc>
-              <a:spcAft>
-                <a:spcPts val="1700"/>
+              <a:t>E que nenhum agente tenha permissão de aprovar.</a:t>
+            </a:r>
+          </a:p>
+          <a:p>
+            <a:pPr algn="l">
+              <a:lnSpc>
+                <a:spcPct val="125000"/>
+              </a:lnSpc>
+              <a:spcAft>
+                <a:spcPts val="1600"/>
               </a:spcAft>
             </a:pPr>
             <a:r>
@@ -23734,7 +23755,7 @@
                 </a:solidFill>
                 <a:latin typeface="Segoe UI"/>
               </a:rPr>
-              <a:t>Retomada de execução. </a:t>
+              <a:t>Sandbox técnico, não instrução. </a:t>
             </a:r>
             <a:r>
               <a:rPr sz="1800" b="0">
@@ -23743,16 +23764,16 @@
                 </a:solidFill>
                 <a:latin typeface="Segoe UI"/>
               </a:rPr>
-              <a:t>Uma execução interrompida recomeça do zero. O journal preserva o histórico, mas não o estado.</a:t>
-            </a:r>
-          </a:p>
-          <a:p>
-            <a:pPr algn="l">
-              <a:lnSpc>
-                <a:spcPct val="125000"/>
-              </a:lnSpc>
-              <a:spcAft>
-                <a:spcPts val="1700"/>
+              <a:t>Impedir é diferente de pedir. Numa auditoria, muito diferente.</a:t>
+            </a:r>
+          </a:p>
+          <a:p>
+            <a:pPr algn="l">
+              <a:lnSpc>
+                <a:spcPct val="125000"/>
+              </a:lnSpc>
+              <a:spcAft>
+                <a:spcPts val="1600"/>
               </a:spcAft>
             </a:pPr>
             <a:r>
@@ -23771,7 +23792,7 @@
                 </a:solidFill>
                 <a:latin typeface="Segoe UI"/>
               </a:rPr>
-              <a:t>Qualidade sustentada. </a:t>
+              <a:t>Teto de gasto e de iteração. </a:t>
             </a:r>
             <a:r>
               <a:rPr sz="1800" b="0">
@@ -23780,16 +23801,16 @@
                 </a:solidFill>
                 <a:latin typeface="Segoe UI"/>
               </a:rPr>
-              <a:t>Cinco PRs aprovados no gate não são cinco PRs que eu mandaria para produção sem ler.</a:t>
-            </a:r>
-          </a:p>
-          <a:p>
-            <a:pPr algn="l">
-              <a:lnSpc>
-                <a:spcPct val="125000"/>
-              </a:lnSpc>
-              <a:spcAft>
-                <a:spcPts val="1700"/>
+              <a:t>Tentativas, timeout por agente, timeout por execução, limite de concorrência.</a:t>
+            </a:r>
+          </a:p>
+          <a:p>
+            <a:pPr algn="l">
+              <a:lnSpc>
+                <a:spcPct val="125000"/>
+              </a:lnSpc>
+              <a:spcAft>
+                <a:spcPts val="1600"/>
               </a:spcAft>
             </a:pPr>
             <a:r>
@@ -23808,7 +23829,7 @@
                 </a:solidFill>
                 <a:latin typeface="Segoe UI"/>
               </a:rPr>
-              <a:t>O crítico ainda é barulhento. </a:t>
+              <a:t>Auditabilidade. </a:t>
             </a:r>
             <a:r>
               <a:rPr sz="1800" b="0">
@@ -23817,7 +23838,44 @@
                 </a:solidFill>
                 <a:latin typeface="Segoe UI"/>
               </a:rPr>
-              <a:t>Melhorou com a mudança de hierarquia, mas ainda aponta mais do que deveria.</a:t>
+              <a:t>Prompt, modelo, tokens, ferramentas chamadas, permissões negadas e diff — tudo gravado.</a:t>
+            </a:r>
+          </a:p>
+          <a:p>
+            <a:pPr algn="l">
+              <a:lnSpc>
+                <a:spcPct val="125000"/>
+              </a:lnSpc>
+              <a:spcAft>
+                <a:spcPts val="1600"/>
+              </a:spcAft>
+            </a:pPr>
+            <a:r>
+              <a:rPr sz="1800" b="1">
+                <a:solidFill>
+                  <a:srgbClr val="58A6FF"/>
+                </a:solidFill>
+                <a:latin typeface="Segoe UI"/>
+              </a:rPr>
+              <a:t>—  </a:t>
+            </a:r>
+            <a:r>
+              <a:rPr sz="1800" b="1">
+                <a:solidFill>
+                  <a:srgbClr val="E6EDF3"/>
+                </a:solidFill>
+                <a:latin typeface="Segoe UI"/>
+              </a:rPr>
+              <a:t>Transparência. </a:t>
+            </a:r>
+            <a:r>
+              <a:rPr sz="1800" b="0">
+                <a:solidFill>
+                  <a:srgbClr val="9198A1"/>
+                </a:solidFill>
+                <a:latin typeface="Segoe UI"/>
+              </a:rPr>
+              <a:t>Todo PR de agente é rotulado e declara qual modelo o produziu.</a:t>
             </a:r>
           </a:p>
         </p:txBody>
@@ -23830,8 +23888,8 @@
         </p:nvSpPr>
         <p:spPr>
           <a:xfrm>
-            <a:off x="777240" y="5303520"/>
-            <a:ext cx="10637215" cy="868680"/>
+            <a:off x="777240" y="5394960"/>
+            <a:ext cx="10637215" cy="777240"/>
           </a:xfrm>
           <a:prstGeom prst="roundRect">
             <a:avLst>
@@ -23839,11 +23897,11 @@
             </a:avLst>
           </a:prstGeom>
           <a:solidFill>
-            <a:srgbClr val="161B22"/>
+            <a:srgbClr val="010409"/>
           </a:solidFill>
           <a:ln w="12700">
             <a:solidFill>
-              <a:srgbClr val="30363D"/>
+              <a:srgbClr val="D29922"/>
             </a:solidFill>
           </a:ln>
           <a:effectLst/>
@@ -23878,13 +23936,13 @@
               </a:spcAft>
             </a:pPr>
             <a:r>
-              <a:rPr sz="1900" b="0">
+              <a:rPr sz="1800" b="0">
                 <a:solidFill>
                   <a:srgbClr val="E6EDF3"/>
                 </a:solidFill>
                 <a:latin typeface="Segoe UI"/>
               </a:rPr>
-              <a:t>Se alguém te vender isso como resolvido, desconfie. É promissor, e está longe de pronto.</a:t>
+              <a:t>Essas seis coisas são o que separa uma demo de um sistema que você pode colocar numa empresa.</a:t>
             </a:r>
           </a:p>
         </p:txBody>
@@ -23974,7 +24032,7 @@
                 </a:solidFill>
                 <a:latin typeface="Segoe UI"/>
               </a:rPr>
-              <a:t>33/35</a:t>
+              <a:t>33/36</a:t>
             </a:r>
           </a:p>
         </p:txBody>
@@ -24043,58 +24101,14 @@
       </p:sp>
       <p:sp>
         <p:nvSpPr>
-          <p:cNvPr id="3" name="Rectangle 2"/>
-          <p:cNvSpPr/>
-          <p:nvPr/>
-        </p:nvSpPr>
-        <p:spPr>
-          <a:xfrm>
-            <a:off x="0" y="0"/>
-            <a:ext cx="146304" cy="6858000"/>
-          </a:xfrm>
-          <a:prstGeom prst="rect">
-            <a:avLst/>
-          </a:prstGeom>
-          <a:solidFill>
-            <a:srgbClr val="1F6FEB"/>
-          </a:solidFill>
-          <a:ln>
-            <a:noFill/>
-          </a:ln>
-          <a:effectLst/>
-        </p:spPr>
-        <p:style>
-          <a:lnRef idx="1">
-            <a:schemeClr val="accent1"/>
-          </a:lnRef>
-          <a:fillRef idx="3">
-            <a:schemeClr val="accent1"/>
-          </a:fillRef>
-          <a:effectRef idx="2">
-            <a:schemeClr val="accent1"/>
-          </a:effectRef>
-          <a:fontRef idx="minor">
-            <a:schemeClr val="lt1"/>
-          </a:fontRef>
-        </p:style>
-        <p:txBody>
-          <a:bodyPr rtlCol="0" anchor="ctr" wrap="square"/>
-          <a:lstStyle/>
-          <a:p>
-            <a:pPr algn="ctr"/>
-          </a:p>
-        </p:txBody>
-      </p:sp>
-      <p:sp>
-        <p:nvSpPr>
-          <p:cNvPr id="4" name="TextBox 3"/>
+          <p:cNvPr id="3" name="TextBox 2"/>
           <p:cNvSpPr txBox="1"/>
           <p:nvPr/>
         </p:nvSpPr>
         <p:spPr>
           <a:xfrm>
-            <a:off x="1051560" y="1280160"/>
-            <a:ext cx="10058400" cy="411480"/>
+            <a:off x="777240" y="502920"/>
+            <a:ext cx="10637215" cy="320040"/>
           </a:xfrm>
           <a:prstGeom prst="rect">
             <a:avLst/>
@@ -24119,27 +24133,27 @@
               </a:spcAft>
             </a:pPr>
             <a:r>
-              <a:rPr sz="1500" b="1">
+              <a:rPr sz="1300" b="1">
                 <a:solidFill>
                   <a:srgbClr val="58A6FF"/>
                 </a:solidFill>
                 <a:latin typeface="Segoe UI"/>
               </a:rPr>
-              <a:t>PARA LEVAR PARA CASA</a:t>
-            </a:r>
-          </a:p>
-        </p:txBody>
-      </p:sp>
-      <p:sp>
-        <p:nvSpPr>
-          <p:cNvPr id="5" name="TextBox 4"/>
+              <a:t>HONESTIDADE</a:t>
+            </a:r>
+          </a:p>
+        </p:txBody>
+      </p:sp>
+      <p:sp>
+        <p:nvSpPr>
+          <p:cNvPr id="4" name="TextBox 3"/>
           <p:cNvSpPr txBox="1"/>
           <p:nvPr/>
         </p:nvSpPr>
         <p:spPr>
           <a:xfrm>
-            <a:off x="1051560" y="1828800"/>
-            <a:ext cx="10241280" cy="1463040"/>
+            <a:off x="777240" y="850392"/>
+            <a:ext cx="10637215" cy="731520"/>
           </a:xfrm>
           <a:prstGeom prst="rect">
             <a:avLst/>
@@ -24160,53 +24174,31 @@
                 <a:spcPts val="0"/>
               </a:spcBef>
               <a:spcAft>
-                <a:spcPts val="1000"/>
-              </a:spcAft>
-            </a:pPr>
-            <a:r>
-              <a:rPr sz="4000" b="1">
-                <a:solidFill>
-                  <a:srgbClr val="FFFFFF"/>
-                </a:solidFill>
-                <a:latin typeface="Segoe UI"/>
-              </a:rPr>
-              <a:t>O gargalo não é escrever código.</a:t>
-            </a:r>
-          </a:p>
-          <a:p>
-            <a:pPr algn="l">
-              <a:lnSpc>
-                <a:spcPct val="125000"/>
-              </a:lnSpc>
-              <a:spcBef>
-                <a:spcPts val="0"/>
-              </a:spcBef>
-              <a:spcAft>
-                <a:spcPts val="0"/>
-              </a:spcAft>
-            </a:pPr>
-            <a:r>
-              <a:rPr sz="2600" b="0">
-                <a:solidFill>
-                  <a:srgbClr val="9198A1"/>
-                </a:solidFill>
-                <a:latin typeface="Segoe UI"/>
-              </a:rPr>
-              <a:t>É decidir o que escrever, coordenar quem escreve, e verificar.</a:t>
-            </a:r>
-          </a:p>
-        </p:txBody>
-      </p:sp>
-      <p:sp>
-        <p:nvSpPr>
-          <p:cNvPr id="6" name="Rectangle 5"/>
+                <a:spcPts val="0"/>
+              </a:spcAft>
+            </a:pPr>
+            <a:r>
+              <a:rPr sz="3400" b="1">
+                <a:solidFill>
+                  <a:srgbClr val="E6EDF3"/>
+                </a:solidFill>
+                <a:latin typeface="Segoe UI"/>
+              </a:rPr>
+              <a:t>O que eu não resolvi</a:t>
+            </a:r>
+          </a:p>
+        </p:txBody>
+      </p:sp>
+      <p:sp>
+        <p:nvSpPr>
+          <p:cNvPr id="5" name="Rectangle 4"/>
           <p:cNvSpPr/>
           <p:nvPr/>
         </p:nvSpPr>
         <p:spPr>
           <a:xfrm>
-            <a:off x="1051560" y="3657600"/>
-            <a:ext cx="10058400" cy="15875"/>
+            <a:off x="777240" y="1563624"/>
+            <a:ext cx="10637215" cy="15875"/>
           </a:xfrm>
           <a:prstGeom prst="rect">
             <a:avLst/>
@@ -24243,14 +24235,14 @@
       </p:sp>
       <p:sp>
         <p:nvSpPr>
-          <p:cNvPr id="7" name="TextBox 6"/>
+          <p:cNvPr id="6" name="TextBox 5"/>
           <p:cNvSpPr txBox="1"/>
           <p:nvPr/>
         </p:nvSpPr>
         <p:spPr>
           <a:xfrm>
-            <a:off x="1051560" y="3977639"/>
-            <a:ext cx="10058400" cy="1828800"/>
+            <a:off x="777240" y="1901952"/>
+            <a:ext cx="10637215" cy="4133088"/>
           </a:xfrm>
           <a:prstGeom prst="rect">
             <a:avLst/>
@@ -24268,110 +24260,340 @@
                 <a:spcPct val="125000"/>
               </a:lnSpc>
               <a:spcAft>
-                <a:spcPts val="1400"/>
-              </a:spcAft>
-            </a:pPr>
-            <a:r>
-              <a:rPr sz="2000" b="1">
+                <a:spcPts val="1700"/>
+              </a:spcAft>
+            </a:pPr>
+            <a:r>
+              <a:rPr sz="1800" b="1">
                 <a:solidFill>
                   <a:srgbClr val="58A6FF"/>
                 </a:solidFill>
                 <a:latin typeface="Segoe UI"/>
               </a:rPr>
-              <a:t>▸  </a:t>
-            </a:r>
-            <a:r>
-              <a:rPr sz="2000" b="0">
+              <a:t>—  </a:t>
+            </a:r>
+            <a:r>
+              <a:rPr sz="1800" b="1">
                 <a:solidFill>
                   <a:srgbClr val="E6EDF3"/>
                 </a:solidFill>
                 <a:latin typeface="Segoe UI"/>
               </a:rPr>
-              <a:t>O modelo produz. O programa verifica.</a:t>
-            </a:r>
-          </a:p>
-          <a:p>
-            <a:pPr algn="l">
-              <a:lnSpc>
-                <a:spcPct val="125000"/>
-              </a:lnSpc>
-              <a:spcAft>
-                <a:spcPts val="1400"/>
-              </a:spcAft>
-            </a:pPr>
-            <a:r>
-              <a:rPr sz="2000" b="1">
+              <a:t>Custo real por entrega. </a:t>
+            </a:r>
+            <a:r>
+              <a:rPr sz="1800" b="0">
+                <a:solidFill>
+                  <a:srgbClr val="9198A1"/>
+                </a:solidFill>
+                <a:latin typeface="Segoe UI"/>
+              </a:rPr>
+              <a:t>Medi tempo, não dinheiro. Uma execução de 40 min consome tokens de 6 agentes.</a:t>
+            </a:r>
+          </a:p>
+          <a:p>
+            <a:pPr algn="l">
+              <a:lnSpc>
+                <a:spcPct val="125000"/>
+              </a:lnSpc>
+              <a:spcAft>
+                <a:spcPts val="1700"/>
+              </a:spcAft>
+            </a:pPr>
+            <a:r>
+              <a:rPr sz="1800" b="1">
                 <a:solidFill>
                   <a:srgbClr val="58A6FF"/>
                 </a:solidFill>
                 <a:latin typeface="Segoe UI"/>
               </a:rPr>
-              <a:t>▸  </a:t>
-            </a:r>
-            <a:r>
-              <a:rPr sz="2000" b="0">
+              <a:t>—  </a:t>
+            </a:r>
+            <a:r>
+              <a:rPr sz="1800" b="1">
                 <a:solidFill>
                   <a:srgbClr val="E6EDF3"/>
                 </a:solidFill>
                 <a:latin typeface="Segoe UI"/>
               </a:rPr>
-              <a:t>Restrição é o que faz paralelismo funcionar — não inteligência.</a:t>
-            </a:r>
-          </a:p>
-          <a:p>
-            <a:pPr algn="l">
-              <a:lnSpc>
-                <a:spcPct val="125000"/>
-              </a:lnSpc>
-              <a:spcAft>
-                <a:spcPts val="1400"/>
-              </a:spcAft>
-            </a:pPr>
-            <a:r>
-              <a:rPr sz="2000" b="1">
+              <a:t>Brownfield grande de verdade. </a:t>
+            </a:r>
+            <a:r>
+              <a:rPr sz="1800" b="0">
+                <a:solidFill>
+                  <a:srgbClr val="9198A1"/>
+                </a:solidFill>
+                <a:latin typeface="Segoe UI"/>
+              </a:rPr>
+              <a:t>Validei greenfield e mudanças pequenas. Repositório legado de 500 mil linhas é outro problema.</a:t>
+            </a:r>
+          </a:p>
+          <a:p>
+            <a:pPr algn="l">
+              <a:lnSpc>
+                <a:spcPct val="125000"/>
+              </a:lnSpc>
+              <a:spcAft>
+                <a:spcPts val="1700"/>
+              </a:spcAft>
+            </a:pPr>
+            <a:r>
+              <a:rPr sz="1800" b="1">
                 <a:solidFill>
                   <a:srgbClr val="58A6FF"/>
                 </a:solidFill>
                 <a:latin typeface="Segoe UI"/>
               </a:rPr>
-              <a:t>▸  </a:t>
-            </a:r>
-            <a:r>
-              <a:rPr sz="2000" b="0">
+              <a:t>—  </a:t>
+            </a:r>
+            <a:r>
+              <a:rPr sz="1800" b="1">
                 <a:solidFill>
                   <a:srgbClr val="E6EDF3"/>
                 </a:solidFill>
                 <a:latin typeface="Segoe UI"/>
               </a:rPr>
-              <a:t>As regras da sua empresa são arquivo versionado, não prompt escondido.</a:t>
-            </a:r>
-          </a:p>
-          <a:p>
-            <a:pPr algn="l">
-              <a:lnSpc>
-                <a:spcPct val="125000"/>
-              </a:lnSpc>
-              <a:spcAft>
-                <a:spcPts val="1400"/>
-              </a:spcAft>
-            </a:pPr>
-            <a:r>
-              <a:rPr sz="2000" b="1">
+              <a:t>Retomada de execução. </a:t>
+            </a:r>
+            <a:r>
+              <a:rPr sz="1800" b="0">
+                <a:solidFill>
+                  <a:srgbClr val="9198A1"/>
+                </a:solidFill>
+                <a:latin typeface="Segoe UI"/>
+              </a:rPr>
+              <a:t>Uma execução interrompida recomeça do zero. O journal preserva o histórico, mas não o estado.</a:t>
+            </a:r>
+          </a:p>
+          <a:p>
+            <a:pPr algn="l">
+              <a:lnSpc>
+                <a:spcPct val="125000"/>
+              </a:lnSpc>
+              <a:spcAft>
+                <a:spcPts val="1700"/>
+              </a:spcAft>
+            </a:pPr>
+            <a:r>
+              <a:rPr sz="1800" b="1">
                 <a:solidFill>
                   <a:srgbClr val="58A6FF"/>
                 </a:solidFill>
                 <a:latin typeface="Segoe UI"/>
               </a:rPr>
-              <a:t>▸  </a:t>
-            </a:r>
-            <a:r>
-              <a:rPr sz="2000" b="0">
+              <a:t>—  </a:t>
+            </a:r>
+            <a:r>
+              <a:rPr sz="1800" b="1">
                 <a:solidFill>
                   <a:srgbClr val="E6EDF3"/>
                 </a:solidFill>
                 <a:latin typeface="Segoe UI"/>
               </a:rPr>
-              <a:t>O merge continua sendo humano. Isso não é limitação, é o desenho.</a:t>
+              <a:t>Qualidade sustentada. </a:t>
+            </a:r>
+            <a:r>
+              <a:rPr sz="1800" b="0">
+                <a:solidFill>
+                  <a:srgbClr val="9198A1"/>
+                </a:solidFill>
+                <a:latin typeface="Segoe UI"/>
+              </a:rPr>
+              <a:t>Cinco PRs aprovados no gate não são cinco PRs que eu mandaria para produção sem ler.</a:t>
+            </a:r>
+          </a:p>
+          <a:p>
+            <a:pPr algn="l">
+              <a:lnSpc>
+                <a:spcPct val="125000"/>
+              </a:lnSpc>
+              <a:spcAft>
+                <a:spcPts val="1700"/>
+              </a:spcAft>
+            </a:pPr>
+            <a:r>
+              <a:rPr sz="1800" b="1">
+                <a:solidFill>
+                  <a:srgbClr val="58A6FF"/>
+                </a:solidFill>
+                <a:latin typeface="Segoe UI"/>
+              </a:rPr>
+              <a:t>—  </a:t>
+            </a:r>
+            <a:r>
+              <a:rPr sz="1800" b="1">
+                <a:solidFill>
+                  <a:srgbClr val="E6EDF3"/>
+                </a:solidFill>
+                <a:latin typeface="Segoe UI"/>
+              </a:rPr>
+              <a:t>O crítico ainda é barulhento. </a:t>
+            </a:r>
+            <a:r>
+              <a:rPr sz="1800" b="0">
+                <a:solidFill>
+                  <a:srgbClr val="9198A1"/>
+                </a:solidFill>
+                <a:latin typeface="Segoe UI"/>
+              </a:rPr>
+              <a:t>Melhorou com a mudança de hierarquia, mas ainda aponta mais do que deveria.</a:t>
+            </a:r>
+          </a:p>
+        </p:txBody>
+      </p:sp>
+      <p:sp>
+        <p:nvSpPr>
+          <p:cNvPr id="7" name="Rounded Rectangle 6"/>
+          <p:cNvSpPr/>
+          <p:nvPr/>
+        </p:nvSpPr>
+        <p:spPr>
+          <a:xfrm>
+            <a:off x="777240" y="5303520"/>
+            <a:ext cx="10637215" cy="868680"/>
+          </a:xfrm>
+          <a:prstGeom prst="roundRect">
+            <a:avLst>
+              <a:gd name="adj" fmla="val 8000"/>
+            </a:avLst>
+          </a:prstGeom>
+          <a:solidFill>
+            <a:srgbClr val="161B22"/>
+          </a:solidFill>
+          <a:ln w="12700">
+            <a:solidFill>
+              <a:srgbClr val="30363D"/>
+            </a:solidFill>
+          </a:ln>
+          <a:effectLst/>
+        </p:spPr>
+        <p:style>
+          <a:lnRef idx="1">
+            <a:schemeClr val="accent1"/>
+          </a:lnRef>
+          <a:fillRef idx="3">
+            <a:schemeClr val="accent1"/>
+          </a:fillRef>
+          <a:effectRef idx="2">
+            <a:schemeClr val="accent1"/>
+          </a:effectRef>
+          <a:fontRef idx="minor">
+            <a:schemeClr val="lt1"/>
+          </a:fontRef>
+        </p:style>
+        <p:txBody>
+          <a:bodyPr rtlCol="0" anchor="ctr" wrap="square" lIns="320040"/>
+          <a:lstStyle/>
+          <a:p>
+            <a:pPr algn="ctr">
+              <a:lnSpc>
+                <a:spcPct val="125000"/>
+              </a:lnSpc>
+              <a:spcBef>
+                <a:spcPts val="0"/>
+              </a:spcBef>
+              <a:spcAft>
+                <a:spcPts val="0"/>
+              </a:spcAft>
+            </a:pPr>
+            <a:r>
+              <a:rPr sz="1900" b="0">
+                <a:solidFill>
+                  <a:srgbClr val="E6EDF3"/>
+                </a:solidFill>
+                <a:latin typeface="Segoe UI"/>
+              </a:rPr>
+              <a:t>Se alguém te vender isso como resolvido, desconfie. É promissor, e está longe de pronto.</a:t>
+            </a:r>
+          </a:p>
+        </p:txBody>
+      </p:sp>
+      <p:sp>
+        <p:nvSpPr>
+          <p:cNvPr id="8" name="TextBox 7"/>
+          <p:cNvSpPr txBox="1"/>
+          <p:nvPr/>
+        </p:nvSpPr>
+        <p:spPr>
+          <a:xfrm>
+            <a:off x="777240" y="6291072"/>
+            <a:ext cx="7446050" cy="274320"/>
+          </a:xfrm>
+          <a:prstGeom prst="rect">
+            <a:avLst/>
+          </a:prstGeom>
+          <a:noFill/>
+        </p:spPr>
+        <p:txBody>
+          <a:bodyPr wrap="square" lIns="0" rIns="0" tIns="0" bIns="0">
+            <a:spAutoFit/>
+          </a:bodyPr>
+          <a:lstStyle/>
+          <a:p>
+            <a:pPr algn="l">
+              <a:lnSpc>
+                <a:spcPct val="125000"/>
+              </a:lnSpc>
+              <a:spcBef>
+                <a:spcPts val="0"/>
+              </a:spcBef>
+              <a:spcAft>
+                <a:spcPts val="0"/>
+              </a:spcAft>
+            </a:pPr>
+            <a:r>
+              <a:rPr sz="1100" b="0">
+                <a:solidFill>
+                  <a:srgbClr val="6E7681"/>
+                </a:solidFill>
+                <a:latin typeface="Segoe UI"/>
+              </a:rPr>
+              <a:t>Agent Squad · TDC São Paulo 2026</a:t>
+            </a:r>
+          </a:p>
+        </p:txBody>
+      </p:sp>
+      <p:sp>
+        <p:nvSpPr>
+          <p:cNvPr id="9" name="TextBox 8"/>
+          <p:cNvSpPr txBox="1"/>
+          <p:nvPr/>
+        </p:nvSpPr>
+        <p:spPr>
+          <a:xfrm>
+            <a:off x="10317175" y="6291072"/>
+            <a:ext cx="1097280" cy="274320"/>
+          </a:xfrm>
+          <a:prstGeom prst="rect">
+            <a:avLst/>
+          </a:prstGeom>
+          <a:noFill/>
+        </p:spPr>
+        <p:txBody>
+          <a:bodyPr wrap="square" lIns="0" rIns="0" tIns="0" bIns="0">
+            <a:spAutoFit/>
+          </a:bodyPr>
+          <a:lstStyle/>
+          <a:p>
+            <a:pPr algn="r">
+              <a:lnSpc>
+                <a:spcPct val="125000"/>
+              </a:lnSpc>
+              <a:spcBef>
+                <a:spcPts val="0"/>
+              </a:spcBef>
+              <a:spcAft>
+                <a:spcPts val="0"/>
+              </a:spcAft>
+            </a:pPr>
+            <a:r>
+              <a:rPr sz="1100" b="0">
+                <a:solidFill>
+                  <a:srgbClr val="6E7681"/>
+                </a:solidFill>
+                <a:latin typeface="Segoe UI"/>
+              </a:rPr>
+              <a:t>34/36</a:t>
             </a:r>
           </a:p>
         </p:txBody>
@@ -24453,6 +24675,403 @@
             <a:avLst/>
           </a:prstGeom>
           <a:solidFill>
+            <a:srgbClr val="1F6FEB"/>
+          </a:solidFill>
+          <a:ln>
+            <a:noFill/>
+          </a:ln>
+          <a:effectLst/>
+        </p:spPr>
+        <p:style>
+          <a:lnRef idx="1">
+            <a:schemeClr val="accent1"/>
+          </a:lnRef>
+          <a:fillRef idx="3">
+            <a:schemeClr val="accent1"/>
+          </a:fillRef>
+          <a:effectRef idx="2">
+            <a:schemeClr val="accent1"/>
+          </a:effectRef>
+          <a:fontRef idx="minor">
+            <a:schemeClr val="lt1"/>
+          </a:fontRef>
+        </p:style>
+        <p:txBody>
+          <a:bodyPr rtlCol="0" anchor="ctr" wrap="square"/>
+          <a:lstStyle/>
+          <a:p>
+            <a:pPr algn="ctr"/>
+          </a:p>
+        </p:txBody>
+      </p:sp>
+      <p:sp>
+        <p:nvSpPr>
+          <p:cNvPr id="4" name="TextBox 3"/>
+          <p:cNvSpPr txBox="1"/>
+          <p:nvPr/>
+        </p:nvSpPr>
+        <p:spPr>
+          <a:xfrm>
+            <a:off x="1051560" y="1280160"/>
+            <a:ext cx="10058400" cy="411480"/>
+          </a:xfrm>
+          <a:prstGeom prst="rect">
+            <a:avLst/>
+          </a:prstGeom>
+          <a:noFill/>
+        </p:spPr>
+        <p:txBody>
+          <a:bodyPr wrap="square" lIns="0" rIns="0" tIns="0" bIns="0">
+            <a:spAutoFit/>
+          </a:bodyPr>
+          <a:lstStyle/>
+          <a:p>
+            <a:pPr algn="l">
+              <a:lnSpc>
+                <a:spcPct val="125000"/>
+              </a:lnSpc>
+              <a:spcBef>
+                <a:spcPts val="0"/>
+              </a:spcBef>
+              <a:spcAft>
+                <a:spcPts val="0"/>
+              </a:spcAft>
+            </a:pPr>
+            <a:r>
+              <a:rPr sz="1500" b="1">
+                <a:solidFill>
+                  <a:srgbClr val="58A6FF"/>
+                </a:solidFill>
+                <a:latin typeface="Segoe UI"/>
+              </a:rPr>
+              <a:t>PARA LEVAR PARA CASA</a:t>
+            </a:r>
+          </a:p>
+        </p:txBody>
+      </p:sp>
+      <p:sp>
+        <p:nvSpPr>
+          <p:cNvPr id="5" name="TextBox 4"/>
+          <p:cNvSpPr txBox="1"/>
+          <p:nvPr/>
+        </p:nvSpPr>
+        <p:spPr>
+          <a:xfrm>
+            <a:off x="1051560" y="1828800"/>
+            <a:ext cx="10241280" cy="1463040"/>
+          </a:xfrm>
+          <a:prstGeom prst="rect">
+            <a:avLst/>
+          </a:prstGeom>
+          <a:noFill/>
+        </p:spPr>
+        <p:txBody>
+          <a:bodyPr wrap="square" lIns="0" rIns="0" tIns="0" bIns="0">
+            <a:spAutoFit/>
+          </a:bodyPr>
+          <a:lstStyle/>
+          <a:p>
+            <a:pPr algn="l">
+              <a:lnSpc>
+                <a:spcPct val="125000"/>
+              </a:lnSpc>
+              <a:spcBef>
+                <a:spcPts val="0"/>
+              </a:spcBef>
+              <a:spcAft>
+                <a:spcPts val="1000"/>
+              </a:spcAft>
+            </a:pPr>
+            <a:r>
+              <a:rPr sz="4000" b="1">
+                <a:solidFill>
+                  <a:srgbClr val="FFFFFF"/>
+                </a:solidFill>
+                <a:latin typeface="Segoe UI"/>
+              </a:rPr>
+              <a:t>O gargalo não é escrever código.</a:t>
+            </a:r>
+          </a:p>
+          <a:p>
+            <a:pPr algn="l">
+              <a:lnSpc>
+                <a:spcPct val="125000"/>
+              </a:lnSpc>
+              <a:spcBef>
+                <a:spcPts val="0"/>
+              </a:spcBef>
+              <a:spcAft>
+                <a:spcPts val="0"/>
+              </a:spcAft>
+            </a:pPr>
+            <a:r>
+              <a:rPr sz="2600" b="0">
+                <a:solidFill>
+                  <a:srgbClr val="9198A1"/>
+                </a:solidFill>
+                <a:latin typeface="Segoe UI"/>
+              </a:rPr>
+              <a:t>É decidir o que escrever, coordenar quem escreve, e verificar.</a:t>
+            </a:r>
+          </a:p>
+        </p:txBody>
+      </p:sp>
+      <p:sp>
+        <p:nvSpPr>
+          <p:cNvPr id="6" name="Rectangle 5"/>
+          <p:cNvSpPr/>
+          <p:nvPr/>
+        </p:nvSpPr>
+        <p:spPr>
+          <a:xfrm>
+            <a:off x="1051560" y="3657600"/>
+            <a:ext cx="10058400" cy="15875"/>
+          </a:xfrm>
+          <a:prstGeom prst="rect">
+            <a:avLst/>
+          </a:prstGeom>
+          <a:solidFill>
+            <a:srgbClr val="30363D"/>
+          </a:solidFill>
+          <a:ln>
+            <a:noFill/>
+          </a:ln>
+          <a:effectLst/>
+        </p:spPr>
+        <p:style>
+          <a:lnRef idx="1">
+            <a:schemeClr val="accent1"/>
+          </a:lnRef>
+          <a:fillRef idx="3">
+            <a:schemeClr val="accent1"/>
+          </a:fillRef>
+          <a:effectRef idx="2">
+            <a:schemeClr val="accent1"/>
+          </a:effectRef>
+          <a:fontRef idx="minor">
+            <a:schemeClr val="lt1"/>
+          </a:fontRef>
+        </p:style>
+        <p:txBody>
+          <a:bodyPr rtlCol="0" anchor="ctr"/>
+          <a:lstStyle/>
+          <a:p>
+            <a:pPr algn="ctr"/>
+          </a:p>
+        </p:txBody>
+      </p:sp>
+      <p:sp>
+        <p:nvSpPr>
+          <p:cNvPr id="7" name="TextBox 6"/>
+          <p:cNvSpPr txBox="1"/>
+          <p:nvPr/>
+        </p:nvSpPr>
+        <p:spPr>
+          <a:xfrm>
+            <a:off x="1051560" y="3977639"/>
+            <a:ext cx="10058400" cy="1828800"/>
+          </a:xfrm>
+          <a:prstGeom prst="rect">
+            <a:avLst/>
+          </a:prstGeom>
+          <a:noFill/>
+        </p:spPr>
+        <p:txBody>
+          <a:bodyPr wrap="square" lIns="0" rIns="0" tIns="0" bIns="0">
+            <a:spAutoFit/>
+          </a:bodyPr>
+          <a:lstStyle/>
+          <a:p>
+            <a:pPr algn="l">
+              <a:lnSpc>
+                <a:spcPct val="125000"/>
+              </a:lnSpc>
+              <a:spcAft>
+                <a:spcPts val="1400"/>
+              </a:spcAft>
+            </a:pPr>
+            <a:r>
+              <a:rPr sz="2000" b="1">
+                <a:solidFill>
+                  <a:srgbClr val="58A6FF"/>
+                </a:solidFill>
+                <a:latin typeface="Segoe UI"/>
+              </a:rPr>
+              <a:t>▸  </a:t>
+            </a:r>
+            <a:r>
+              <a:rPr sz="2000" b="0">
+                <a:solidFill>
+                  <a:srgbClr val="E6EDF3"/>
+                </a:solidFill>
+                <a:latin typeface="Segoe UI"/>
+              </a:rPr>
+              <a:t>O modelo produz. O programa verifica.</a:t>
+            </a:r>
+          </a:p>
+          <a:p>
+            <a:pPr algn="l">
+              <a:lnSpc>
+                <a:spcPct val="125000"/>
+              </a:lnSpc>
+              <a:spcAft>
+                <a:spcPts val="1400"/>
+              </a:spcAft>
+            </a:pPr>
+            <a:r>
+              <a:rPr sz="2000" b="1">
+                <a:solidFill>
+                  <a:srgbClr val="58A6FF"/>
+                </a:solidFill>
+                <a:latin typeface="Segoe UI"/>
+              </a:rPr>
+              <a:t>▸  </a:t>
+            </a:r>
+            <a:r>
+              <a:rPr sz="2000" b="0">
+                <a:solidFill>
+                  <a:srgbClr val="E6EDF3"/>
+                </a:solidFill>
+                <a:latin typeface="Segoe UI"/>
+              </a:rPr>
+              <a:t>Restrição é o que faz paralelismo funcionar — não inteligência.</a:t>
+            </a:r>
+          </a:p>
+          <a:p>
+            <a:pPr algn="l">
+              <a:lnSpc>
+                <a:spcPct val="125000"/>
+              </a:lnSpc>
+              <a:spcAft>
+                <a:spcPts val="1400"/>
+              </a:spcAft>
+            </a:pPr>
+            <a:r>
+              <a:rPr sz="2000" b="1">
+                <a:solidFill>
+                  <a:srgbClr val="58A6FF"/>
+                </a:solidFill>
+                <a:latin typeface="Segoe UI"/>
+              </a:rPr>
+              <a:t>▸  </a:t>
+            </a:r>
+            <a:r>
+              <a:rPr sz="2000" b="0">
+                <a:solidFill>
+                  <a:srgbClr val="E6EDF3"/>
+                </a:solidFill>
+                <a:latin typeface="Segoe UI"/>
+              </a:rPr>
+              <a:t>As regras da sua empresa são arquivo versionado, não prompt escondido.</a:t>
+            </a:r>
+          </a:p>
+          <a:p>
+            <a:pPr algn="l">
+              <a:lnSpc>
+                <a:spcPct val="125000"/>
+              </a:lnSpc>
+              <a:spcAft>
+                <a:spcPts val="1400"/>
+              </a:spcAft>
+            </a:pPr>
+            <a:r>
+              <a:rPr sz="2000" b="1">
+                <a:solidFill>
+                  <a:srgbClr val="58A6FF"/>
+                </a:solidFill>
+                <a:latin typeface="Segoe UI"/>
+              </a:rPr>
+              <a:t>▸  </a:t>
+            </a:r>
+            <a:r>
+              <a:rPr sz="2000" b="0">
+                <a:solidFill>
+                  <a:srgbClr val="E6EDF3"/>
+                </a:solidFill>
+                <a:latin typeface="Segoe UI"/>
+              </a:rPr>
+              <a:t>O merge continua sendo humano. Isso não é limitação, é o desenho.</a:t>
+            </a:r>
+          </a:p>
+        </p:txBody>
+      </p:sp>
+    </p:spTree>
+  </p:cSld>
+  <p:clrMapOvr>
+    <a:masterClrMapping/>
+  </p:clrMapOvr>
+</p:sld>
+</file>
+
+<file path=ppt/slides/slide36.xml><?xml version="1.0" encoding="utf-8"?>
+<p:sld xmlns:a="http://schemas.openxmlformats.org/drawingml/2006/main" xmlns:p="http://schemas.openxmlformats.org/presentationml/2006/main" xmlns:r="http://schemas.openxmlformats.org/officeDocument/2006/relationships">
+  <p:cSld>
+    <p:spTree>
+      <p:nvGrpSpPr>
+        <p:cNvPr id="1" name=""/>
+        <p:cNvGrpSpPr/>
+        <p:nvPr/>
+      </p:nvGrpSpPr>
+      <p:grpSpPr/>
+      <p:sp>
+        <p:nvSpPr>
+          <p:cNvPr id="2" name="Rectangle 1"/>
+          <p:cNvSpPr/>
+          <p:nvPr/>
+        </p:nvSpPr>
+        <p:spPr>
+          <a:xfrm>
+            <a:off x="0" y="0"/>
+            <a:ext cx="12191695" cy="6858000"/>
+          </a:xfrm>
+          <a:prstGeom prst="rect">
+            <a:avLst/>
+          </a:prstGeom>
+          <a:solidFill>
+            <a:srgbClr val="0D1117"/>
+          </a:solidFill>
+          <a:ln>
+            <a:noFill/>
+          </a:ln>
+          <a:effectLst/>
+        </p:spPr>
+        <p:style>
+          <a:lnRef idx="1">
+            <a:schemeClr val="accent1"/>
+          </a:lnRef>
+          <a:fillRef idx="3">
+            <a:schemeClr val="accent1"/>
+          </a:fillRef>
+          <a:effectRef idx="2">
+            <a:schemeClr val="accent1"/>
+          </a:effectRef>
+          <a:fontRef idx="minor">
+            <a:schemeClr val="lt1"/>
+          </a:fontRef>
+        </p:style>
+        <p:txBody>
+          <a:bodyPr rtlCol="0" anchor="ctr"/>
+          <a:lstStyle/>
+          <a:p>
+            <a:pPr algn="ctr"/>
+          </a:p>
+        </p:txBody>
+      </p:sp>
+      <p:sp>
+        <p:nvSpPr>
+          <p:cNvPr id="3" name="Rectangle 2"/>
+          <p:cNvSpPr/>
+          <p:nvPr/>
+        </p:nvSpPr>
+        <p:spPr>
+          <a:xfrm>
+            <a:off x="0" y="0"/>
+            <a:ext cx="146304" cy="6858000"/>
+          </a:xfrm>
+          <a:prstGeom prst="rect">
+            <a:avLst/>
+          </a:prstGeom>
+          <a:solidFill>
             <a:srgbClr val="BC8CFF"/>
           </a:solidFill>
           <a:ln>
@@ -25345,7 +25964,7 @@
                 </a:solidFill>
                 <a:latin typeface="Segoe UI"/>
               </a:rPr>
-              <a:t>4/35</a:t>
+              <a:t>4/36</a:t>
             </a:r>
           </a:p>
         </p:txBody>
@@ -25912,7 +26531,7 @@
                 </a:solidFill>
                 <a:latin typeface="Segoe UI"/>
               </a:rPr>
-              <a:t>5/35</a:t>
+              <a:t>5/36</a:t>
             </a:r>
           </a:p>
         </p:txBody>
@@ -26122,7 +26741,7 @@
         <p:spPr>
           <a:xfrm>
             <a:off x="777240" y="2267712"/>
-            <a:ext cx="1217637" cy="1600200"/>
+            <a:ext cx="1068120" cy="1600200"/>
           </a:xfrm>
           <a:prstGeom prst="roundRect">
             <a:avLst>
@@ -26211,7 +26830,7 @@
         </p:nvSpPr>
         <p:spPr>
           <a:xfrm>
-            <a:off x="2004021" y="2962656"/>
+            <a:off x="1854504" y="2962656"/>
             <a:ext cx="109728" cy="182880"/>
           </a:xfrm>
           <a:prstGeom prst="rightArrow">
@@ -26255,8 +26874,8 @@
         </p:nvSpPr>
         <p:spPr>
           <a:xfrm>
-            <a:off x="2122893" y="2267712"/>
-            <a:ext cx="1217637" cy="1600200"/>
+            <a:off x="1973376" y="2267712"/>
+            <a:ext cx="1068120" cy="1600200"/>
           </a:xfrm>
           <a:prstGeom prst="roundRect">
             <a:avLst>
@@ -26345,7 +26964,7 @@
         </p:nvSpPr>
         <p:spPr>
           <a:xfrm>
-            <a:off x="3349675" y="2962656"/>
+            <a:off x="3050641" y="2962656"/>
             <a:ext cx="109728" cy="182880"/>
           </a:xfrm>
           <a:prstGeom prst="rightArrow">
@@ -26389,8 +27008,8 @@
         </p:nvSpPr>
         <p:spPr>
           <a:xfrm>
-            <a:off x="3468547" y="2267712"/>
-            <a:ext cx="1217637" cy="1600200"/>
+            <a:off x="3169513" y="2267712"/>
+            <a:ext cx="1068120" cy="1600200"/>
           </a:xfrm>
           <a:prstGeom prst="roundRect">
             <a:avLst>
@@ -26479,7 +27098,7 @@
         </p:nvSpPr>
         <p:spPr>
           <a:xfrm>
-            <a:off x="4695329" y="2962656"/>
+            <a:off x="4246778" y="2962656"/>
             <a:ext cx="109728" cy="182880"/>
           </a:xfrm>
           <a:prstGeom prst="rightArrow">
@@ -26523,8 +27142,8 @@
         </p:nvSpPr>
         <p:spPr>
           <a:xfrm>
-            <a:off x="4814201" y="2267712"/>
-            <a:ext cx="1217637" cy="1600200"/>
+            <a:off x="4365650" y="2267712"/>
+            <a:ext cx="1068120" cy="1600200"/>
           </a:xfrm>
           <a:prstGeom prst="roundRect">
             <a:avLst>
@@ -26613,7 +27232,7 @@
         </p:nvSpPr>
         <p:spPr>
           <a:xfrm>
-            <a:off x="6040983" y="2962656"/>
+            <a:off x="5442915" y="2962656"/>
             <a:ext cx="109728" cy="182880"/>
           </a:xfrm>
           <a:prstGeom prst="rightArrow">
@@ -26657,8 +27276,8 @@
         </p:nvSpPr>
         <p:spPr>
           <a:xfrm>
-            <a:off x="6159855" y="2267712"/>
-            <a:ext cx="1217637" cy="1600200"/>
+            <a:off x="5561787" y="2267712"/>
+            <a:ext cx="1068120" cy="1600200"/>
           </a:xfrm>
           <a:prstGeom prst="roundRect">
             <a:avLst>
@@ -26747,7 +27366,7 @@
         </p:nvSpPr>
         <p:spPr>
           <a:xfrm>
-            <a:off x="7386637" y="2962656"/>
+            <a:off x="6639051" y="2962656"/>
             <a:ext cx="109728" cy="182880"/>
           </a:xfrm>
           <a:prstGeom prst="rightArrow">
@@ -26791,8 +27410,8 @@
         </p:nvSpPr>
         <p:spPr>
           <a:xfrm>
-            <a:off x="7505509" y="2267712"/>
-            <a:ext cx="1217637" cy="1600200"/>
+            <a:off x="6757923" y="2267712"/>
+            <a:ext cx="1068120" cy="1600200"/>
           </a:xfrm>
           <a:prstGeom prst="roundRect">
             <a:avLst>
@@ -26881,7 +27500,7 @@
         </p:nvSpPr>
         <p:spPr>
           <a:xfrm>
-            <a:off x="8732291" y="2962656"/>
+            <a:off x="7835188" y="2962656"/>
             <a:ext cx="109728" cy="182880"/>
           </a:xfrm>
           <a:prstGeom prst="rightArrow">
@@ -26925,8 +27544,8 @@
         </p:nvSpPr>
         <p:spPr>
           <a:xfrm>
-            <a:off x="8851163" y="2267712"/>
-            <a:ext cx="1217637" cy="1600200"/>
+            <a:off x="7954060" y="2267712"/>
+            <a:ext cx="1068120" cy="1600200"/>
           </a:xfrm>
           <a:prstGeom prst="roundRect">
             <a:avLst>
@@ -27015,7 +27634,7 @@
         </p:nvSpPr>
         <p:spPr>
           <a:xfrm>
-            <a:off x="10077945" y="2962656"/>
+            <a:off x="9031325" y="2962656"/>
             <a:ext cx="109728" cy="182880"/>
           </a:xfrm>
           <a:prstGeom prst="rightArrow">
@@ -27059,8 +27678,142 @@
         </p:nvSpPr>
         <p:spPr>
           <a:xfrm>
-            <a:off x="10196817" y="2267712"/>
-            <a:ext cx="1217637" cy="1600200"/>
+            <a:off x="9150197" y="2267712"/>
+            <a:ext cx="1068120" cy="1600200"/>
+          </a:xfrm>
+          <a:prstGeom prst="roundRect">
+            <a:avLst>
+              <a:gd name="adj" fmla="val 8000"/>
+            </a:avLst>
+          </a:prstGeom>
+          <a:solidFill>
+            <a:srgbClr val="161B22"/>
+          </a:solidFill>
+          <a:ln w="12700">
+            <a:solidFill>
+              <a:srgbClr val="58A6FF"/>
+            </a:solidFill>
+          </a:ln>
+          <a:effectLst/>
+        </p:spPr>
+        <p:style>
+          <a:lnRef idx="1">
+            <a:schemeClr val="accent1"/>
+          </a:lnRef>
+          <a:fillRef idx="3">
+            <a:schemeClr val="accent1"/>
+          </a:fillRef>
+          <a:effectRef idx="2">
+            <a:schemeClr val="accent1"/>
+          </a:effectRef>
+          <a:fontRef idx="minor">
+            <a:schemeClr val="lt1"/>
+          </a:fontRef>
+        </p:style>
+        <p:txBody>
+          <a:bodyPr rtlCol="0" anchor="ctr" wrap="square" lIns="73152" rIns="73152" tIns="146304"/>
+          <a:lstStyle/>
+          <a:p>
+            <a:pPr algn="ctr">
+              <a:lnSpc>
+                <a:spcPct val="125000"/>
+              </a:lnSpc>
+              <a:spcBef>
+                <a:spcPts val="0"/>
+              </a:spcBef>
+              <a:spcAft>
+                <a:spcPts val="700"/>
+              </a:spcAft>
+            </a:pPr>
+            <a:r>
+              <a:rPr sz="1200" b="1">
+                <a:solidFill>
+                  <a:srgbClr val="58A6FF"/>
+                </a:solidFill>
+                <a:latin typeface="Segoe UI"/>
+              </a:rPr>
+              <a:t>PR POR ITEM</a:t>
+            </a:r>
+          </a:p>
+          <a:p>
+            <a:pPr algn="ctr">
+              <a:lnSpc>
+                <a:spcPct val="120000"/>
+              </a:lnSpc>
+              <a:spcBef>
+                <a:spcPts val="0"/>
+              </a:spcBef>
+              <a:spcAft>
+                <a:spcPts val="0"/>
+              </a:spcAft>
+            </a:pPr>
+            <a:r>
+              <a:rPr sz="1100" b="0">
+                <a:solidFill>
+                  <a:srgbClr val="9198A1"/>
+                </a:solidFill>
+                <a:latin typeface="Segoe UI"/>
+              </a:rPr>
+              <a:t>unidade de
+revisão</a:t>
+            </a:r>
+          </a:p>
+        </p:txBody>
+      </p:sp>
+      <p:sp>
+        <p:nvSpPr>
+          <p:cNvPr id="21" name="Right Arrow 20"/>
+          <p:cNvSpPr/>
+          <p:nvPr/>
+        </p:nvSpPr>
+        <p:spPr>
+          <a:xfrm>
+            <a:off x="10227462" y="2962656"/>
+            <a:ext cx="109728" cy="182880"/>
+          </a:xfrm>
+          <a:prstGeom prst="rightArrow">
+            <a:avLst/>
+          </a:prstGeom>
+          <a:solidFill>
+            <a:srgbClr val="30363D"/>
+          </a:solidFill>
+          <a:ln>
+            <a:noFill/>
+          </a:ln>
+          <a:effectLst/>
+        </p:spPr>
+        <p:style>
+          <a:lnRef idx="1">
+            <a:schemeClr val="accent1"/>
+          </a:lnRef>
+          <a:fillRef idx="3">
+            <a:schemeClr val="accent1"/>
+          </a:fillRef>
+          <a:effectRef idx="2">
+            <a:schemeClr val="accent1"/>
+          </a:effectRef>
+          <a:fontRef idx="minor">
+            <a:schemeClr val="lt1"/>
+          </a:fontRef>
+        </p:style>
+        <p:txBody>
+          <a:bodyPr rtlCol="0" anchor="ctr"/>
+          <a:lstStyle/>
+          <a:p>
+            <a:pPr algn="ctr"/>
+          </a:p>
+        </p:txBody>
+      </p:sp>
+      <p:sp>
+        <p:nvSpPr>
+          <p:cNvPr id="22" name="Rounded Rectangle 21"/>
+          <p:cNvSpPr/>
+          <p:nvPr/>
+        </p:nvSpPr>
+        <p:spPr>
+          <a:xfrm>
+            <a:off x="10346334" y="2267712"/>
+            <a:ext cx="1068120" cy="1600200"/>
           </a:xfrm>
           <a:prstGeom prst="roundRect">
             <a:avLst>
@@ -27113,7 +27866,7 @@
                 </a:solidFill>
                 <a:latin typeface="Segoe UI"/>
               </a:rPr>
-              <a:t>PULL REQUEST</a:t>
+              <a:t>PR DE ENTREGA</a:t>
             </a:r>
           </a:p>
           <a:p>
@@ -27143,7 +27896,7 @@
       </p:sp>
       <p:sp>
         <p:nvSpPr>
-          <p:cNvPr id="21" name="Rounded Rectangle 20"/>
+          <p:cNvPr id="23" name="Rounded Rectangle 22"/>
           <p:cNvSpPr/>
           <p:nvPr/>
         </p:nvSpPr>
@@ -27244,7 +27997,7 @@
       </p:sp>
       <p:sp>
         <p:nvSpPr>
-          <p:cNvPr id="22" name="TextBox 21"/>
+          <p:cNvPr id="24" name="TextBox 23"/>
           <p:cNvSpPr txBox="1"/>
           <p:nvPr/>
         </p:nvSpPr>
@@ -27289,7 +28042,7 @@
       </p:sp>
       <p:sp>
         <p:nvSpPr>
-          <p:cNvPr id="23" name="TextBox 22"/>
+          <p:cNvPr id="25" name="TextBox 24"/>
           <p:cNvSpPr txBox="1"/>
           <p:nvPr/>
         </p:nvSpPr>
@@ -27327,7 +28080,7 @@
                 </a:solidFill>
                 <a:latin typeface="Segoe UI"/>
               </a:rPr>
-              <a:t>6/35</a:t>
+              <a:t>6/36</a:t>
             </a:r>
           </a:p>
         </p:txBody>
@@ -28285,7 +29038,7 @@
                 </a:solidFill>
                 <a:latin typeface="Segoe UI"/>
               </a:rPr>
-              <a:t>7/35</a:t>
+              <a:t>7/36</a:t>
             </a:r>
           </a:p>
         </p:txBody>
@@ -29613,7 +30366,7 @@
                 </a:solidFill>
                 <a:latin typeface="Segoe UI"/>
               </a:rPr>
-              <a:t>8/35</a:t>
+              <a:t>8/36</a:t>
             </a:r>
           </a:p>
         </p:txBody>
@@ -30730,7 +31483,7 @@
                 </a:solidFill>
                 <a:latin typeface="Segoe UI"/>
               </a:rPr>
-              <a:t>9/35</a:t>
+              <a:t>9/36</a:t>
             </a:r>
           </a:p>
         </p:txBody>

</xml_diff>

<commit_message>
docs: comando exato de cada demo nas notas do apresentador
As notas dos quatro slides de demo passam a trazer o comando copiável, não
a forma curta que a plateia lê no slide. Junto vai o que cada demo faz ou
não faz: a demo 2 com --plan-only não escreve nada no GitHub e pode
repetir à vontade; a demo 3 é a execução de verdade e vai sem
--unattended, porque a aprovação humana é parte do que se demonstra.

Escritas no arquivo existente em vez de regerar o deck: o slide de
apresentação é do palestrante e precisa sobreviver intacto. O script
localiza os slides pelo selo "DEMO n", não por número — inserir um slide
antes não desloca as notas em silêncio.

Co-Authored-By: Claude Opus 5 (1M context) <noreply@anthropic.com>
</commit_message>
<xml_diff>
--- a/docs/apresentacao/Agent-Squad-TDC-SP-2026.pptx
+++ b/docs/apresentacao/Agent-Squad-TDC-SP-2026.pptx
@@ -1689,6 +1689,435 @@
           <a:p>
             <a:r>
               <a:t>• 'Posso usar no meu trabalho?' — MIT, está tudo no repositório.</a:t>
+            </a:r>
+          </a:p>
+        </p:txBody>
+      </p:sp>
+      <p:sp>
+        <p:nvSpPr>
+          <p:cNvPr id="4" name="Slide Number Placeholder 3"/>
+          <p:cNvSpPr>
+            <a:spLocks noGrp="1"/>
+          </p:cNvSpPr>
+          <p:nvPr>
+            <p:ph type="sldNum" idx="5" sz="quarter"/>
+          </p:nvPr>
+        </p:nvSpPr>
+        <p:spPr/>
+      </p:sp>
+    </p:spTree>
+  </p:cSld>
+  <p:clrMapOvr>
+    <a:masterClrMapping/>
+  </p:clrMapOvr>
+</p:notes>
+</file>
+
+<file path=ppt/notesSlides/notesSlide25.xml><?xml version="1.0" encoding="utf-8"?>
+<p:notes xmlns:a="http://schemas.openxmlformats.org/drawingml/2006/main" xmlns:p="http://schemas.openxmlformats.org/presentationml/2006/main" xmlns:r="http://schemas.openxmlformats.org/officeDocument/2006/relationships">
+  <p:cSld>
+    <p:spTree>
+      <p:nvGrpSpPr>
+        <p:cNvPr id="1" name=""/>
+        <p:cNvGrpSpPr/>
+        <p:nvPr/>
+      </p:nvGrpSpPr>
+      <p:grpSpPr>
+        <a:xfrm>
+          <a:off x="0" y="0"/>
+          <a:ext cx="0" cy="0"/>
+          <a:chOff x="0" y="0"/>
+          <a:chExt cx="0" cy="0"/>
+        </a:xfrm>
+      </p:grpSpPr>
+      <p:sp>
+        <p:nvSpPr>
+          <p:cNvPr id="2" name="Slide Image Placeholder 1"/>
+          <p:cNvSpPr>
+            <a:spLocks noGrp="1"/>
+          </p:cNvSpPr>
+          <p:nvPr>
+            <p:ph type="sldImg" idx="2"/>
+          </p:nvPr>
+        </p:nvSpPr>
+        <p:spPr/>
+      </p:sp>
+      <p:sp>
+        <p:nvSpPr>
+          <p:cNvPr id="3" name="Notes Placeholder 2"/>
+          <p:cNvSpPr>
+            <a:spLocks noGrp="1"/>
+          </p:cNvSpPr>
+          <p:nvPr>
+            <p:ph type="body" idx="3" sz="quarter"/>
+          </p:nvPr>
+        </p:nvSpPr>
+        <p:spPr/>
+        <p:txBody>
+          <a:bodyPr/>
+          <a:lstStyle/>
+          <a:p>
+            <a:r>
+              <a:t>COMANDO EXATO — terminal na raiz do repositório da fábrica (E:\source\repos\TDCSP2026):</a:t>
+            </a:r>
+          </a:p>
+          <a:p/>
+          <a:p>
+            <a:r>
+              <a:t>dotnet run --project src/AgentSquad.Cli -- doctor --probe-models</a:t>
+            </a:r>
+          </a:p>
+          <a:p/>
+          <a:p>
+            <a:r>
+              <a:t>Leva ~40 s, quase tudo esperando o gpt-5.5 — que é o ponto: é chamada real a cada modelo, não checagem de configuração.</a:t>
+            </a:r>
+          </a:p>
+          <a:p/>
+          <a:p>
+            <a:r>
+              <a:t>ANTES DE SUBIR AO PALCO: rode uma vez "dotnet build AgentSquad.slnx -c Release" e depois acrescente "-c Release --no-build" a TODOS os comandos das demos. Sem isso você espera compilação na frente da plateia.</a:t>
+            </a:r>
+          </a:p>
+          <a:p/>
+          <a:p>
+            <a:r>
+              <a:t>Se quiser provar também o Copilot (24 s, isolado de propósito):</a:t>
+            </a:r>
+          </a:p>
+          <a:p>
+            <a:r>
+              <a:t>dotnet run --project src/AgentSquad.Cli -- doctor --probe-copilot</a:t>
+            </a:r>
+          </a:p>
+          <a:p/>
+          <a:p>
+            <a:r>
+              <a:t>O que apontar: cada falha traz o comando que corrige, não "algo deu errado". Repare nos 37 s do gpt-5.5 — modelo de raciocínio tem custo de latência, e isso volta no achado 2.</a:t>
+            </a:r>
+          </a:p>
+        </p:txBody>
+      </p:sp>
+      <p:sp>
+        <p:nvSpPr>
+          <p:cNvPr id="4" name="Slide Number Placeholder 3"/>
+          <p:cNvSpPr>
+            <a:spLocks noGrp="1"/>
+          </p:cNvSpPr>
+          <p:nvPr>
+            <p:ph type="sldNum" idx="5" sz="quarter"/>
+          </p:nvPr>
+        </p:nvSpPr>
+        <p:spPr/>
+      </p:sp>
+    </p:spTree>
+  </p:cSld>
+  <p:clrMapOvr>
+    <a:masterClrMapping/>
+  </p:clrMapOvr>
+</p:notes>
+</file>
+
+<file path=ppt/notesSlides/notesSlide26.xml><?xml version="1.0" encoding="utf-8"?>
+<p:notes xmlns:a="http://schemas.openxmlformats.org/drawingml/2006/main" xmlns:p="http://schemas.openxmlformats.org/presentationml/2006/main" xmlns:r="http://schemas.openxmlformats.org/officeDocument/2006/relationships">
+  <p:cSld>
+    <p:spTree>
+      <p:nvGrpSpPr>
+        <p:cNvPr id="1" name=""/>
+        <p:cNvGrpSpPr/>
+        <p:nvPr/>
+      </p:nvGrpSpPr>
+      <p:grpSpPr>
+        <a:xfrm>
+          <a:off x="0" y="0"/>
+          <a:ext cx="0" cy="0"/>
+          <a:chOff x="0" y="0"/>
+          <a:chExt cx="0" cy="0"/>
+        </a:xfrm>
+      </p:grpSpPr>
+      <p:sp>
+        <p:nvSpPr>
+          <p:cNvPr id="2" name="Slide Image Placeholder 1"/>
+          <p:cNvSpPr>
+            <a:spLocks noGrp="1"/>
+          </p:cNvSpPr>
+          <p:nvPr>
+            <p:ph type="sldImg" idx="2"/>
+          </p:nvPr>
+        </p:nvSpPr>
+        <p:spPr/>
+      </p:sp>
+      <p:sp>
+        <p:nvSpPr>
+          <p:cNvPr id="3" name="Notes Placeholder 2"/>
+          <p:cNvSpPr>
+            <a:spLocks noGrp="1"/>
+          </p:cNvSpPr>
+          <p:nvPr>
+            <p:ph type="body" idx="3" sz="quarter"/>
+          </p:nvPr>
+        </p:nvSpPr>
+        <p:spPr/>
+        <p:txBody>
+          <a:bodyPr/>
+          <a:lstStyle/>
+          <a:p>
+            <a:r>
+              <a:t>COMANDO EXATO:</a:t>
+            </a:r>
+          </a:p>
+          <a:p/>
+          <a:p>
+            <a:r>
+              <a:t>dotnet run --project src/AgentSquad.Cli -- run `</a:t>
+            </a:r>
+          </a:p>
+          <a:p>
+            <a:r>
+              <a:t>  --transcript samples/meeting-transcripts/kickoff-catalogo.md `</a:t>
+            </a:r>
+          </a:p>
+          <a:p>
+            <a:r>
+              <a:t>  --repo squad-demo-catalogo --plan-only</a:t>
+            </a:r>
+          </a:p>
+          <a:p/>
+          <a:p>
+            <a:r>
+              <a:t>--plan-only para depois do plano e NÃO escreve nada no GitHub. Pode repetir quantas vezes quiser, inclusive se algo der errado no palco. É a demo mais segura da apresentação.</a:t>
+            </a:r>
+          </a:p>
+          <a:p/>
+          <a:p>
+            <a:r>
+              <a:t>Enquanto o agente lê a transcrição (~60 s), conte como o arquivo foi escrito: um requisito que ninguém quantificou, uma divergência que ficou sem resolução, um "obviamente" que não é óbvio, um escopo que cresceu no meio da conversa.</a:t>
+            </a:r>
+          </a:p>
+          <a:p/>
+          <a:p>
+            <a:r>
+              <a:t>O teste de fogo: o agente lista o p95 como PENDÊNCIA ou registra como requisito? O gabarito está no fim do próprio arquivo da transcrição.</a:t>
+            </a:r>
+          </a:p>
+        </p:txBody>
+      </p:sp>
+      <p:sp>
+        <p:nvSpPr>
+          <p:cNvPr id="4" name="Slide Number Placeholder 3"/>
+          <p:cNvSpPr>
+            <a:spLocks noGrp="1"/>
+          </p:cNvSpPr>
+          <p:nvPr>
+            <p:ph type="sldNum" idx="5" sz="quarter"/>
+          </p:nvPr>
+        </p:nvSpPr>
+        <p:spPr/>
+      </p:sp>
+    </p:spTree>
+  </p:cSld>
+  <p:clrMapOvr>
+    <a:masterClrMapping/>
+  </p:clrMapOvr>
+</p:notes>
+</file>
+
+<file path=ppt/notesSlides/notesSlide27.xml><?xml version="1.0" encoding="utf-8"?>
+<p:notes xmlns:a="http://schemas.openxmlformats.org/drawingml/2006/main" xmlns:p="http://schemas.openxmlformats.org/presentationml/2006/main" xmlns:r="http://schemas.openxmlformats.org/officeDocument/2006/relationships">
+  <p:cSld>
+    <p:spTree>
+      <p:nvGrpSpPr>
+        <p:cNvPr id="1" name=""/>
+        <p:cNvGrpSpPr/>
+        <p:nvPr/>
+      </p:nvGrpSpPr>
+      <p:grpSpPr>
+        <a:xfrm>
+          <a:off x="0" y="0"/>
+          <a:ext cx="0" cy="0"/>
+          <a:chOff x="0" y="0"/>
+          <a:chExt cx="0" cy="0"/>
+        </a:xfrm>
+      </p:grpSpPr>
+      <p:sp>
+        <p:nvSpPr>
+          <p:cNvPr id="2" name="Slide Image Placeholder 1"/>
+          <p:cNvSpPr>
+            <a:spLocks noGrp="1"/>
+          </p:cNvSpPr>
+          <p:nvPr>
+            <p:ph type="sldImg" idx="2"/>
+          </p:nvPr>
+        </p:nvSpPr>
+        <p:spPr/>
+      </p:sp>
+      <p:sp>
+        <p:nvSpPr>
+          <p:cNvPr id="3" name="Notes Placeholder 2"/>
+          <p:cNvSpPr>
+            <a:spLocks noGrp="1"/>
+          </p:cNvSpPr>
+          <p:nvPr>
+            <p:ph type="body" idx="3" sz="quarter"/>
+          </p:nvPr>
+        </p:nvSpPr>
+        <p:spPr/>
+        <p:txBody>
+          <a:bodyPr/>
+          <a:lstStyle/>
+          <a:p>
+            <a:r>
+              <a:t>COMANDO EXATO — esta é a execução de verdade: escreve issues, branches e pull requests no GitHub.</a:t>
+            </a:r>
+          </a:p>
+          <a:p/>
+          <a:p>
+            <a:r>
+              <a:t>dotnet run --project src/AgentSquad.Cli -- run `</a:t>
+            </a:r>
+          </a:p>
+          <a:p>
+            <a:r>
+              <a:t>  --request "Preciso de uma API REST de catálogo de produtos em .NET: busca paginada por nome, filtro por categoria e faixa de preço, com testes de integração." `</a:t>
+            </a:r>
+          </a:p>
+          <a:p>
+            <a:r>
+              <a:t>  --repo squad-demo-catalogo --parallel 3</a:t>
+            </a:r>
+          </a:p>
+          <a:p/>
+          <a:p>
+            <a:r>
+              <a:t>SEM --plan-only (você quer que escreva) e SEM --unattended (você quer mostrar a aprovação humana do plano).</a:t>
+            </a:r>
+          </a:p>
+          <a:p/>
+          <a:p>
+            <a:r>
+              <a:t>Com a interface web e o dashboard do Aspire, em outro terminal:</a:t>
+            </a:r>
+          </a:p>
+          <a:p>
+            <a:r>
+              <a:t>dotnet run --project src/AgentSquad.AppHost</a:t>
+            </a:r>
+          </a:p>
+          <a:p/>
+          <a:p>
+            <a:r>
+              <a:t>Tempos: intake ~40 s · requisitos ~90 s · planejamento 4 a 6 min · agentes 3 a 20 min por onda. Você NÃO vai esperar em silêncio — o roteiro tem o que falar em cada espera.</a:t>
+            </a:r>
+          </a:p>
+          <a:p/>
+          <a:p>
+            <a:r>
+              <a:t>Se o gate reprovar, COMEMORE e pare para mostrar o diagnóstico voltando para o agente.</a:t>
+            </a:r>
+          </a:p>
+        </p:txBody>
+      </p:sp>
+      <p:sp>
+        <p:nvSpPr>
+          <p:cNvPr id="4" name="Slide Number Placeholder 3"/>
+          <p:cNvSpPr>
+            <a:spLocks noGrp="1"/>
+          </p:cNvSpPr>
+          <p:nvPr>
+            <p:ph type="sldNum" idx="5" sz="quarter"/>
+          </p:nvPr>
+        </p:nvSpPr>
+        <p:spPr/>
+      </p:sp>
+    </p:spTree>
+  </p:cSld>
+  <p:clrMapOvr>
+    <a:masterClrMapping/>
+  </p:clrMapOvr>
+</p:notes>
+</file>
+
+<file path=ppt/notesSlides/notesSlide28.xml><?xml version="1.0" encoding="utf-8"?>
+<p:notes xmlns:a="http://schemas.openxmlformats.org/drawingml/2006/main" xmlns:p="http://schemas.openxmlformats.org/presentationml/2006/main" xmlns:r="http://schemas.openxmlformats.org/officeDocument/2006/relationships">
+  <p:cSld>
+    <p:spTree>
+      <p:nvGrpSpPr>
+        <p:cNvPr id="1" name=""/>
+        <p:cNvGrpSpPr/>
+        <p:nvPr/>
+      </p:nvGrpSpPr>
+      <p:grpSpPr>
+        <a:xfrm>
+          <a:off x="0" y="0"/>
+          <a:ext cx="0" cy="0"/>
+          <a:chOff x="0" y="0"/>
+          <a:chExt cx="0" cy="0"/>
+        </a:xfrm>
+      </p:grpSpPr>
+      <p:sp>
+        <p:nvSpPr>
+          <p:cNvPr id="2" name="Slide Image Placeholder 1"/>
+          <p:cNvSpPr>
+            <a:spLocks noGrp="1"/>
+          </p:cNvSpPr>
+          <p:nvPr>
+            <p:ph type="sldImg" idx="2"/>
+          </p:nvPr>
+        </p:nvSpPr>
+        <p:spPr/>
+      </p:sp>
+      <p:sp>
+        <p:nvSpPr>
+          <p:cNvPr id="3" name="Notes Placeholder 2"/>
+          <p:cNvSpPr>
+            <a:spLocks noGrp="1"/>
+          </p:cNvSpPr>
+          <p:nvPr>
+            <p:ph type="body" idx="3" sz="quarter"/>
+          </p:nvPr>
+        </p:nvSpPr>
+        <p:spPr/>
+        <p:txBody>
+          <a:bodyPr/>
+          <a:lstStyle/>
+          <a:p>
+            <a:r>
+              <a:t>COMANDO EXATO:</a:t>
+            </a:r>
+          </a:p>
+          <a:p/>
+          <a:p>
+            <a:r>
+              <a:t>gh pr list --repo magoolation/squad-demo-catalogo</a:t>
+            </a:r>
+          </a:p>
+          <a:p/>
+          <a:p>
+            <a:r>
+              <a:t>Para abrir um no navegador direto do terminal:</a:t>
+            </a:r>
+          </a:p>
+          <a:p>
+            <a:r>
+              <a:t>gh pr view &lt;numero&gt; --repo magoolation/squad-demo-catalogo --web</a:t>
+            </a:r>
+          </a:p>
+          <a:p/>
+          <a:p>
+            <a:r>
+              <a:t>Ordem: abra primeiro um PR de ITEM (tabela do gate, apontamento citando TST-004 com arquivo:linha, bloco de procedência). Depois o PR de ENTREGA, o que vai de agent/run-... para main: o que entrou, o que NÃO entrou, e a última linha, "O merge é seu."</a:t>
+            </a:r>
+          </a:p>
+          <a:p/>
+          <a:p>
+            <a:r>
+              <a:t>Explique os dois níveis ANTES que alguém pergunte: os PRs por item apontam para o branch de integração e servem para ler uma mudança de cada vez; o de entrega é a única coisa que propõe mexer no main. Alguns PRs de item aparecem como MERGED — o GitHub faz isso sozinho quando os commits viram alcançáveis pela base. Emende no achado 8.</a:t>
+            </a:r>
+          </a:p>
+          <a:p/>
+          <a:p>
+            <a:r>
+              <a:t>Em uma frase: "revisar em pedaços, decidir de uma vez".</a:t>
             </a:r>
           </a:p>
         </p:txBody>

</xml_diff>

<commit_message>
docs: slide do palestrante preenchido
Cargo, empresa e redes: Cloud Solution Architect · AI & Apps · Microsoft,
e magoolation no GitHub, LinkedIn e X. O slide de perguntas também tinha
colchetes e agora fecha com os mesmos handles — e sem e-mail, que ninguém
pediu para pôr no telão.

A bio é rascunho, feita só do que é verificável: o cargo e o que o projeto
é. Está lá para não haver colchete no telão, não para dizer por ele quem
ele é — vale reescrever em uma linha se quiser.

Junto vão os scripts que geram o deck e o roteiro, que até agora viviam
fora do repositório. Sem eles, regerar qualquer um dos dois exigiria
refazer do zero.

Co-Authored-By: Claude Opus 5 (1M context) <noreply@anthropic.com>
</commit_message>
<xml_diff>
--- a/docs/apresentacao/Agent-Squad-TDC-SP-2026.pptx
+++ b/docs/apresentacao/Agent-Squad-TDC-SP-2026.pptx
@@ -677,7 +677,42 @@
           <a:lstStyle/>
           <a:p>
             <a:r>
-              <a:t>Aqui é onde a plateia corporativa acorda. A pergunta que todo tech lead faz é 'como eu faço ele seguir o NOSSO padrão?'. A resposta: não é fine-tuning, não é prompt secreto — é arquivo no repositório, que passa por code review como qualquer outro. Mostre o comando 'copilot skill list' ao vivo se sobrar tempo.</a:t>
+              <a:t>COMANDO EXATO — terminal na raiz do repositório da fábrica (E:\source\repos\TDCSP2026):</a:t>
+            </a:r>
+          </a:p>
+          <a:p/>
+          <a:p>
+            <a:r>
+              <a:t>dotnet run --project src/AgentSquad.Cli -- doctor --probe-models</a:t>
+            </a:r>
+          </a:p>
+          <a:p/>
+          <a:p>
+            <a:r>
+              <a:t>Leva ~40 s, quase tudo esperando o gpt-5.5 — que é o ponto: é chamada real a cada modelo, não checagem de configuração.</a:t>
+            </a:r>
+          </a:p>
+          <a:p/>
+          <a:p>
+            <a:r>
+              <a:t>ANTES DE SUBIR AO PALCO: rode uma vez "dotnet build AgentSquad.slnx -c Release" e depois acrescente "-c Release --no-build" a TODOS os comandos das demos. Sem isso você espera compilação na frente da plateia.</a:t>
+            </a:r>
+          </a:p>
+          <a:p/>
+          <a:p>
+            <a:r>
+              <a:t>Se quiser provar também o Copilot (24 s, isolado de propósito):</a:t>
+            </a:r>
+          </a:p>
+          <a:p>
+            <a:r>
+              <a:t>dotnet run --project src/AgentSquad.Cli -- doctor --probe-copilot</a:t>
+            </a:r>
+          </a:p>
+          <a:p/>
+          <a:p>
+            <a:r>
+              <a:t>O que apontar: cada falha traz o comando que corrige, não "algo deu errado". Repare nos 37 s do gpt-5.5 — modelo de raciocínio tem custo de latência, e isso volta no achado 2.</a:t>
             </a:r>
           </a:p>
         </p:txBody>
@@ -747,7 +782,7 @@
           <a:lstStyle/>
           <a:p>
             <a:r>
-              <a:t>O painel embaixo é a prova: o revisor automatizado não diz 'achei feio'. Ele cita SEC-004, arquivo, linha, e a correção concreta. Diga: um revisor que não sabe nomear a regra que está aplicando está expressando gosto — e gosto não pode bloquear um pipeline.</a:t>
+              <a:t>Aqui é onde a plateia corporativa acorda. A pergunta que todo tech lead faz é 'como eu faço ele seguir o NOSSO padrão?'. A resposta: não é fine-tuning, não é prompt secreto — é arquivo no repositório, que passa por code review como qualquer outro. Mostre o comando 'copilot skill list' ao vivo se sobrar tempo.</a:t>
             </a:r>
           </a:p>
         </p:txBody>
@@ -817,7 +852,7 @@
           <a:lstStyle/>
           <a:p>
             <a:r>
-              <a:t>Este é o slide que as pessoas fotografam. A transcrição de exemplo foi escrita de propósito com as patologias de uma reunião real: um requisito que ninguém quantificou, uma divergência sem resolução, um 'obviamente' que não é óbvio, e uma decisão tomada por quem chegou atrasado. Se o agente acertar ao vivo, pare e deixe a plateia ler. Se errar, também pare — e explique que é exatamente por isso que existe aprovação humana.</a:t>
+              <a:t>O painel embaixo é a prova: o revisor automatizado não diz 'achei feio'. Ele cita SEC-004, arquivo, linha, e a correção concreta. Diga: um revisor que não sabe nomear a regra que está aplicando está expressando gosto — e gosto não pode bloquear um pipeline.</a:t>
             </a:r>
           </a:p>
         </p:txBody>
@@ -887,7 +922,41 @@
           <a:lstStyle/>
           <a:p>
             <a:r>
-              <a:t>Uma pergunta ruim é pior que nenhuma pergunta: consome atenção e não melhora a decisão. O critério que uso: a pergunta só existe se (a) muda o PLANO, (b) não dá para responder lendo o repositório, e (c) escolher errado é caro de desfazer. Falhou em qualquer um dos três? O agente decide e registra como suposição, para o humano contestar na aprovação.</a:t>
+              <a:t>COMANDO EXATO:</a:t>
+            </a:r>
+          </a:p>
+          <a:p/>
+          <a:p>
+            <a:r>
+              <a:t>dotnet run --project src/AgentSquad.Cli -- run `</a:t>
+            </a:r>
+          </a:p>
+          <a:p>
+            <a:r>
+              <a:t>  --transcript samples/meeting-transcripts/kickoff-catalogo.md `</a:t>
+            </a:r>
+          </a:p>
+          <a:p>
+            <a:r>
+              <a:t>  --repo squad-demo-catalogo --plan-only</a:t>
+            </a:r>
+          </a:p>
+          <a:p/>
+          <a:p>
+            <a:r>
+              <a:t>--plan-only para depois do plano e NÃO escreve nada no GitHub. Pode repetir quantas vezes quiser, inclusive se algo der errado no palco. É a demo mais segura da apresentação.</a:t>
+            </a:r>
+          </a:p>
+          <a:p/>
+          <a:p>
+            <a:r>
+              <a:t>Enquanto o agente lê a transcrição (~60 s), conte como o arquivo foi escrito: um requisito que ninguém quantificou, uma divergência que ficou sem resolução, um "obviamente" que não é óbvio, um escopo que cresceu no meio da conversa.</a:t>
+            </a:r>
+          </a:p>
+          <a:p/>
+          <a:p>
+            <a:r>
+              <a:t>O teste de fogo: o agente lista o p95 como PENDÊNCIA ou registra como requisito? O gabarito está no fim do próprio arquivo da transcrição.</a:t>
             </a:r>
           </a:p>
         </p:txBody>
@@ -957,7 +1026,7 @@
           <a:lstStyle/>
           <a:p>
             <a:r>
-              <a:t>Adiante um dos achados aqui — ele encaixa perfeitamente. Eu pedi ao crítico, no prompt, para aprovar quando o plano estivesse bom. Ele nunca aprovou. A lição não é 'melhore o prompt': é que você não pode dar poder de veto a algo que não sabe parar de opinar. Validador é portão, crítico é conselho.</a:t>
+              <a:t>Este é o slide que as pessoas fotografam. A transcrição de exemplo foi escrita de propósito com as patologias de uma reunião real: um requisito que ninguém quantificou, uma divergência sem resolução, um 'obviamente' que não é óbvio, e uma decisão tomada por quem chegou atrasado. Se o agente acertar ao vivo, pare e deixe a plateia ler. Se errar, também pare — e explique que é exatamente por isso que existe aprovação humana.</a:t>
             </a:r>
           </a:p>
         </p:txBody>
@@ -1027,7 +1096,7 @@
           <a:lstStyle/>
           <a:p>
             <a:r>
-              <a:t>PREPARE-SE para isso acontecer. Na minha execução de validação, o gate reprovou duas vezes antes de aprovar. Se acontecer, use o roteiro: 'repararam? o agente disse que terminou, o compilador discordou, e o diagnóstico volta para ele'. Isso vende a ideia melhor do que qualquer slide.</a:t>
+              <a:t>Uma pergunta ruim é pior que nenhuma pergunta: consome atenção e não melhora a decisão. O critério que uso: a pergunta só existe se (a) muda o PLANO, (b) não dá para responder lendo o repositório, e (c) escolher errado é caro de desfazer. Falhou em qualquer um dos três? O agente decide e registra como suposição, para o humano contestar na aprovação.</a:t>
             </a:r>
           </a:p>
         </p:txBody>
@@ -1097,7 +1166,7 @@
           <a:lstStyle/>
           <a:p>
             <a:r>
-              <a:t>Slide obrigatório para plateia corporativa — é a primeira pergunta do time de segurança. O ponto central: não é que a gente PEÇA ao agente para não dar push. A política de permissões do Copilot SDK IMPEDE, e negação vence aprovação automática. Isso é diferente de instrução em prompt, e a diferença importa numa auditoria.</a:t>
+              <a:t>Adiante um dos achados aqui — ele encaixa perfeitamente. Eu pedi ao crítico, no prompt, para aprovar quando o plano estivesse bom. Ele nunca aprovou. A lição não é 'melhore o prompt': é que você não pode dar poder de veto a algo que não sabe parar de opinar. Validador é portão, crítico é conselho.</a:t>
             </a:r>
           </a:p>
         </p:txBody>
@@ -1167,7 +1236,52 @@
           <a:lstStyle/>
           <a:p>
             <a:r>
-              <a:t>Transição importante. Diga: 'a partir daqui eu paro de te vender a solução e começo a te contar o que deu errado'. Plateia técnica confia muito mais em quem mostra as cicatrizes. Estes oito achados custaram horas cada um. E o oitavo é consequência direta da correção do sétimo.</a:t>
+              <a:t>COMANDO EXATO — esta é a execução de verdade: escreve issues, branches e pull requests no GitHub.</a:t>
+            </a:r>
+          </a:p>
+          <a:p/>
+          <a:p>
+            <a:r>
+              <a:t>dotnet run --project src/AgentSquad.Cli -- run `</a:t>
+            </a:r>
+          </a:p>
+          <a:p>
+            <a:r>
+              <a:t>  --request "Preciso de uma API REST de catálogo de produtos em .NET: busca paginada por nome, filtro por categoria e faixa de preço, com testes de integração." `</a:t>
+            </a:r>
+          </a:p>
+          <a:p>
+            <a:r>
+              <a:t>  --repo squad-demo-catalogo --parallel 3</a:t>
+            </a:r>
+          </a:p>
+          <a:p/>
+          <a:p>
+            <a:r>
+              <a:t>SEM --plan-only (você quer que escreva) e SEM --unattended (você quer mostrar a aprovação humana do plano).</a:t>
+            </a:r>
+          </a:p>
+          <a:p/>
+          <a:p>
+            <a:r>
+              <a:t>Com a interface web e o dashboard do Aspire, em outro terminal:</a:t>
+            </a:r>
+          </a:p>
+          <a:p>
+            <a:r>
+              <a:t>dotnet run --project src/AgentSquad.AppHost</a:t>
+            </a:r>
+          </a:p>
+          <a:p/>
+          <a:p>
+            <a:r>
+              <a:t>Tempos: intake ~40 s · requisitos ~90 s · planejamento 4 a 6 min · agentes 3 a 20 min por onda. Você NÃO vai esperar em silêncio — o roteiro tem o que falar em cada espera.</a:t>
+            </a:r>
+          </a:p>
+          <a:p/>
+          <a:p>
+            <a:r>
+              <a:t>Se o gate reprovar, COMEMORE e pare para mostrar o diagnóstico voltando para o agente.</a:t>
             </a:r>
           </a:p>
         </p:txBody>
@@ -1237,7 +1351,7 @@
           <a:lstStyle/>
           <a:p>
             <a:r>
-              <a:t>Este slide é a tese da palestra em quatro linhas. Se alguém for embora depois disso, levou o essencial: construir uma fábrica de agentes é 20% prompt e 80% engenharia de integração e verificação.</a:t>
+              <a:t>PREPARE-SE para isso acontecer. Na minha execução de validação, o gate reprovou duas vezes antes de aprovar. Se acontecer, use o roteiro: 'repararam? o agente disse que terminou, o compilador discordou, e o diagnóstico volta para ele'. Isso vende a ideia melhor do que qualquer slide.</a:t>
             </a:r>
           </a:p>
         </p:txBody>
@@ -1307,7 +1421,7 @@
           <a:lstStyle/>
           <a:p>
             <a:r>
-              <a:t>PREENCHA ESTE SLIDE ANTES. Trinta segundos, no máximo um minuto. Diga uma coisa que te dá credibilidade para falar disso — não o currículo inteiro. Emende direto na agenda.</a:t>
+              <a:t>Trinta segundos, no máximo um minuto. Diga uma coisa que te dá credibilidade para falar disso — não o currículo inteiro. Emende direto na agenda.</a:t>
             </a:r>
           </a:p>
         </p:txBody>
@@ -1377,7 +1491,7 @@
           <a:lstStyle/>
           <a:p>
             <a:r>
-              <a:t>Slide prático — a plateia está esperando por ele. Enfatize o passo 2: se o CI de vocês hoje não reprova um PR humano mal formatado, automatizar agente é prematuro. O gate é pré-requisito, não consequência.</a:t>
+              <a:t>Slide obrigatório para plateia corporativa — é a primeira pergunta do time de segurança. O ponto central: não é que a gente PEÇA ao agente para não dar push. A política de permissões do Copilot SDK IMPEDE, e negação vence aprovação automática. Isso é diferente de instrução em prompt, e a diferença importa numa auditoria.</a:t>
             </a:r>
           </a:p>
         </p:txBody>
@@ -1447,7 +1561,42 @@
           <a:lstStyle/>
           <a:p>
             <a:r>
-              <a:t>Leia devagar. Cada item aqui é uma conversa que você vai ter com segurança, com compliance, ou com o seu diretor. Ter a resposta pronta é o que faz o projeto ser aprovado.</a:t>
+              <a:t>COMANDO EXATO:</a:t>
+            </a:r>
+          </a:p>
+          <a:p/>
+          <a:p>
+            <a:r>
+              <a:t>gh pr list --repo magoolation/squad-demo-catalogo</a:t>
+            </a:r>
+          </a:p>
+          <a:p/>
+          <a:p>
+            <a:r>
+              <a:t>Para abrir um no navegador direto do terminal:</a:t>
+            </a:r>
+          </a:p>
+          <a:p>
+            <a:r>
+              <a:t>gh pr view &lt;numero&gt; --repo magoolation/squad-demo-catalogo --web</a:t>
+            </a:r>
+          </a:p>
+          <a:p/>
+          <a:p>
+            <a:r>
+              <a:t>Ordem: abra primeiro um PR de ITEM (tabela do gate, apontamento citando TST-004 com arquivo:linha, bloco de procedência). Depois o PR de ENTREGA, o que vai de agent/run-... para main: o que entrou, o que NÃO entrou, e a última linha, "O merge é seu."</a:t>
+            </a:r>
+          </a:p>
+          <a:p/>
+          <a:p>
+            <a:r>
+              <a:t>Explique os dois níveis ANTES que alguém pergunte: os PRs por item apontam para o branch de integração e servem para ler uma mudança de cada vez; o de entrega é a única coisa que propõe mexer no main. Alguns PRs de item aparecem como MERGED — o GitHub faz isso sozinho quando os commits viram alcançáveis pela base. Emende no achado 8.</a:t>
+            </a:r>
+          </a:p>
+          <a:p/>
+          <a:p>
+            <a:r>
+              <a:t>Em uma frase: "revisar em pedaços, decidir de uma vez".</a:t>
             </a:r>
           </a:p>
         </p:txBody>
@@ -1517,7 +1666,7 @@
           <a:lstStyle/>
           <a:p>
             <a:r>
-              <a:t>Não pule este slide por falta de tempo — corte outro. Ele é o que separa a sua palestra das outras vinte sobre IA no evento. Plateia técnica perdoa limitação declarada e desconfia de solução perfeita.</a:t>
+              <a:t>Transição importante. Diga: 'a partir daqui eu paro de te vender a solução e começo a te contar o que deu errado'. Plateia técnica confia muito mais em quem mostra as cicatrizes. Estes oito achados custaram horas cada um. E o oitavo é consequência direta da correção do sétimo.</a:t>
             </a:r>
           </a:p>
         </p:txBody>
@@ -1587,7 +1736,7 @@
           <a:lstStyle/>
           <a:p>
             <a:r>
-              <a:t>Quatro frases, trinta segundos. Diga devagar e faça pausa entre elas. Depois passe direto para o slide de perguntas — não encerre duas vezes.</a:t>
+              <a:t>Este slide é a tese da palestra em quatro linhas. Se alguém for embora depois disso, levou o essencial: construir uma fábrica de agentes é 20% prompt e 80% engenharia de integração e verificação.</a:t>
             </a:r>
           </a:p>
         </p:txBody>
@@ -1657,38 +1806,7 @@
           <a:lstStyle/>
           <a:p>
             <a:r>
-              <a:t>Deixe este slide no telão durante todas as perguntas — o link fica visível. PERGUNTAS QUE VÃO VIR, e as respostas curtas:</a:t>
-            </a:r>
-          </a:p>
-          <a:p/>
-          <a:p>
-            <a:r>
-              <a:t>• 'Quanto custa?' — Medi tempo, não dinheiro; uma execução de 40 min usa 6 agentes. Seja honesto que não mediu.</a:t>
-            </a:r>
-          </a:p>
-          <a:p>
-            <a:r>
-              <a:t>• 'Funciona em legado?' — Validei greenfield e mudanças pequenas. Em legado o intake lê o repositório primeiro, mas não testei em escala.</a:t>
-            </a:r>
-          </a:p>
-          <a:p>
-            <a:r>
-              <a:t>• 'Substitui desenvolvedor?' — Não. Move o trabalho de escrever para especificar e revisar. E o merge continua humano.</a:t>
-            </a:r>
-          </a:p>
-          <a:p>
-            <a:r>
-              <a:t>• 'Por que não CrewAI/AutoGen/LangGraph?' — A escolha aqui foi .NET + Agent Framework porque era o contexto; o desenho (gate determinístico, regra de conflito, worktree) é independente de framework.</a:t>
-            </a:r>
-          </a:p>
-          <a:p>
-            <a:r>
-              <a:t>• 'E se o agente fizer besteira?' — A política de permissões impede push, PR e comandos de infraestrutura. E nada entra sem merge humano.</a:t>
-            </a:r>
-          </a:p>
-          <a:p>
-            <a:r>
-              <a:t>• 'Posso usar no meu trabalho?' — MIT, está tudo no repositório.</a:t>
+              <a:t>Slide prático — a plateia está esperando por ele. Enfatize o passo 2: se o CI de vocês hoje não reprova um PR humano mal formatado, automatizar agente é prematuro. O gate é pré-requisito, não consequência.</a:t>
             </a:r>
           </a:p>
         </p:txBody>
@@ -1758,42 +1876,7 @@
           <a:lstStyle/>
           <a:p>
             <a:r>
-              <a:t>COMANDO EXATO — terminal na raiz do repositório da fábrica (E:\source\repos\TDCSP2026):</a:t>
-            </a:r>
-          </a:p>
-          <a:p/>
-          <a:p>
-            <a:r>
-              <a:t>dotnet run --project src/AgentSquad.Cli -- doctor --probe-models</a:t>
-            </a:r>
-          </a:p>
-          <a:p/>
-          <a:p>
-            <a:r>
-              <a:t>Leva ~40 s, quase tudo esperando o gpt-5.5 — que é o ponto: é chamada real a cada modelo, não checagem de configuração.</a:t>
-            </a:r>
-          </a:p>
-          <a:p/>
-          <a:p>
-            <a:r>
-              <a:t>ANTES DE SUBIR AO PALCO: rode uma vez "dotnet build AgentSquad.slnx -c Release" e depois acrescente "-c Release --no-build" a TODOS os comandos das demos. Sem isso você espera compilação na frente da plateia.</a:t>
-            </a:r>
-          </a:p>
-          <a:p/>
-          <a:p>
-            <a:r>
-              <a:t>Se quiser provar também o Copilot (24 s, isolado de propósito):</a:t>
-            </a:r>
-          </a:p>
-          <a:p>
-            <a:r>
-              <a:t>dotnet run --project src/AgentSquad.Cli -- doctor --probe-copilot</a:t>
-            </a:r>
-          </a:p>
-          <a:p/>
-          <a:p>
-            <a:r>
-              <a:t>O que apontar: cada falha traz o comando que corrige, não "algo deu errado". Repare nos 37 s do gpt-5.5 — modelo de raciocínio tem custo de latência, e isso volta no achado 2.</a:t>
+              <a:t>Leia devagar. Cada item aqui é uma conversa que você vai ter com segurança, com compliance, ou com o seu diretor. Ter a resposta pronta é o que faz o projeto ser aprovado.</a:t>
             </a:r>
           </a:p>
         </p:txBody>
@@ -1863,41 +1946,7 @@
           <a:lstStyle/>
           <a:p>
             <a:r>
-              <a:t>COMANDO EXATO:</a:t>
-            </a:r>
-          </a:p>
-          <a:p/>
-          <a:p>
-            <a:r>
-              <a:t>dotnet run --project src/AgentSquad.Cli -- run `</a:t>
-            </a:r>
-          </a:p>
-          <a:p>
-            <a:r>
-              <a:t>  --transcript samples/meeting-transcripts/kickoff-catalogo.md `</a:t>
-            </a:r>
-          </a:p>
-          <a:p>
-            <a:r>
-              <a:t>  --repo squad-demo-catalogo --plan-only</a:t>
-            </a:r>
-          </a:p>
-          <a:p/>
-          <a:p>
-            <a:r>
-              <a:t>--plan-only para depois do plano e NÃO escreve nada no GitHub. Pode repetir quantas vezes quiser, inclusive se algo der errado no palco. É a demo mais segura da apresentação.</a:t>
-            </a:r>
-          </a:p>
-          <a:p/>
-          <a:p>
-            <a:r>
-              <a:t>Enquanto o agente lê a transcrição (~60 s), conte como o arquivo foi escrito: um requisito que ninguém quantificou, uma divergência que ficou sem resolução, um "obviamente" que não é óbvio, um escopo que cresceu no meio da conversa.</a:t>
-            </a:r>
-          </a:p>
-          <a:p/>
-          <a:p>
-            <a:r>
-              <a:t>O teste de fogo: o agente lista o p95 como PENDÊNCIA ou registra como requisito? O gabarito está no fim do próprio arquivo da transcrição.</a:t>
+              <a:t>Não pule este slide por falta de tempo — corte outro. Ele é o que separa a sua palestra das outras vinte sobre IA no evento. Plateia técnica perdoa limitação declarada e desconfia de solução perfeita.</a:t>
             </a:r>
           </a:p>
         </p:txBody>
@@ -1967,52 +2016,7 @@
           <a:lstStyle/>
           <a:p>
             <a:r>
-              <a:t>COMANDO EXATO — esta é a execução de verdade: escreve issues, branches e pull requests no GitHub.</a:t>
-            </a:r>
-          </a:p>
-          <a:p/>
-          <a:p>
-            <a:r>
-              <a:t>dotnet run --project src/AgentSquad.Cli -- run `</a:t>
-            </a:r>
-          </a:p>
-          <a:p>
-            <a:r>
-              <a:t>  --request "Preciso de uma API REST de catálogo de produtos em .NET: busca paginada por nome, filtro por categoria e faixa de preço, com testes de integração." `</a:t>
-            </a:r>
-          </a:p>
-          <a:p>
-            <a:r>
-              <a:t>  --repo squad-demo-catalogo --parallel 3</a:t>
-            </a:r>
-          </a:p>
-          <a:p/>
-          <a:p>
-            <a:r>
-              <a:t>SEM --plan-only (você quer que escreva) e SEM --unattended (você quer mostrar a aprovação humana do plano).</a:t>
-            </a:r>
-          </a:p>
-          <a:p/>
-          <a:p>
-            <a:r>
-              <a:t>Com a interface web e o dashboard do Aspire, em outro terminal:</a:t>
-            </a:r>
-          </a:p>
-          <a:p>
-            <a:r>
-              <a:t>dotnet run --project src/AgentSquad.AppHost</a:t>
-            </a:r>
-          </a:p>
-          <a:p/>
-          <a:p>
-            <a:r>
-              <a:t>Tempos: intake ~40 s · requisitos ~90 s · planejamento 4 a 6 min · agentes 3 a 20 min por onda. Você NÃO vai esperar em silêncio — o roteiro tem o que falar em cada espera.</a:t>
-            </a:r>
-          </a:p>
-          <a:p/>
-          <a:p>
-            <a:r>
-              <a:t>Se o gate reprovar, COMEMORE e pare para mostrar o diagnóstico voltando para o agente.</a:t>
+              <a:t>Quatro frases, trinta segundos. Diga devagar e faça pausa entre elas. Depois passe direto para o slide de perguntas — não encerre duas vezes.</a:t>
             </a:r>
           </a:p>
         </p:txBody>
@@ -2082,42 +2086,38 @@
           <a:lstStyle/>
           <a:p>
             <a:r>
-              <a:t>COMANDO EXATO:</a:t>
+              <a:t>Deixe este slide no telão durante todas as perguntas — o link fica visível. PERGUNTAS QUE VÃO VIR, e as respostas curtas:</a:t>
             </a:r>
           </a:p>
           <a:p/>
           <a:p>
             <a:r>
-              <a:t>gh pr list --repo magoolation/squad-demo-catalogo</a:t>
-            </a:r>
-          </a:p>
-          <a:p/>
-          <a:p>
-            <a:r>
-              <a:t>Para abrir um no navegador direto do terminal:</a:t>
-            </a:r>
-          </a:p>
-          <a:p>
-            <a:r>
-              <a:t>gh pr view &lt;numero&gt; --repo magoolation/squad-demo-catalogo --web</a:t>
-            </a:r>
-          </a:p>
-          <a:p/>
-          <a:p>
-            <a:r>
-              <a:t>Ordem: abra primeiro um PR de ITEM (tabela do gate, apontamento citando TST-004 com arquivo:linha, bloco de procedência). Depois o PR de ENTREGA, o que vai de agent/run-... para main: o que entrou, o que NÃO entrou, e a última linha, "O merge é seu."</a:t>
-            </a:r>
-          </a:p>
-          <a:p/>
-          <a:p>
-            <a:r>
-              <a:t>Explique os dois níveis ANTES que alguém pergunte: os PRs por item apontam para o branch de integração e servem para ler uma mudança de cada vez; o de entrega é a única coisa que propõe mexer no main. Alguns PRs de item aparecem como MERGED — o GitHub faz isso sozinho quando os commits viram alcançáveis pela base. Emende no achado 8.</a:t>
-            </a:r>
-          </a:p>
-          <a:p/>
-          <a:p>
-            <a:r>
-              <a:t>Em uma frase: "revisar em pedaços, decidir de uma vez".</a:t>
+              <a:t>• 'Quanto custa?' — Medi tempo, não dinheiro; uma execução de 40 min usa 6 agentes. Seja honesto que não mediu.</a:t>
+            </a:r>
+          </a:p>
+          <a:p>
+            <a:r>
+              <a:t>• 'Funciona em legado?' — Validei greenfield e mudanças pequenas. Em legado o intake lê o repositório primeiro, mas não testei em escala.</a:t>
+            </a:r>
+          </a:p>
+          <a:p>
+            <a:r>
+              <a:t>• 'Substitui desenvolvedor?' — Não. Move o trabalho de escrever para especificar e revisar. E o merge continua humano.</a:t>
+            </a:r>
+          </a:p>
+          <a:p>
+            <a:r>
+              <a:t>• 'Por que não CrewAI/AutoGen/LangGraph?' — A escolha aqui foi .NET + Agent Framework porque era o contexto; o desenho (gate determinístico, regra de conflito, worktree) é independente de framework.</a:t>
+            </a:r>
+          </a:p>
+          <a:p>
+            <a:r>
+              <a:t>• 'E se o agente fizer besteira?' — A política de permissões impede push, PR e comandos de infraestrutura. E nada entra sem merge humano.</a:t>
+            </a:r>
+          </a:p>
+          <a:p>
+            <a:r>
+              <a:t>• 'Posso usar no meu trabalho?' — MIT, está tudo no repositório.</a:t>
             </a:r>
           </a:p>
         </p:txBody>
@@ -14226,7 +14226,7 @@
                 </a:solidFill>
                 <a:latin typeface="Segoe UI"/>
               </a:rPr>
-              <a:t>[SEU CARGO] · [SUA EMPRESA]</a:t>
+              <a:t>Cloud Solution Architect · AI &amp; Apps · Microsoft</a:t>
             </a:r>
           </a:p>
         </p:txBody>
@@ -14271,7 +14271,7 @@
                 </a:solidFill>
                 <a:latin typeface="Segoe UI"/>
               </a:rPr>
-              <a:t>[Duas ou três linhas sobre você: anos de experiência, no que trabalha hoje, o que te levou a construir isto. Mantenha curto — a plateia quer o conteúdo, e você tem uma hora.]</a:t>
+              <a:t>Cloud Solution Architect na Microsoft, na área de IA e aplicações. Construí o Agent Squad para responder na prática a uma pergunta que times de engenharia fazem o tempo todo: dá para colocar agentes autônomos trabalhando em paralelo sem perder o controle do que entra no repositório?</a:t>
             </a:r>
           </a:p>
         </p:txBody>
@@ -14352,7 +14352,7 @@
         <p:spPr>
           <a:xfrm>
             <a:off x="6720840" y="4325112"/>
-            <a:ext cx="1385316" cy="310896"/>
+            <a:ext cx="2318004" cy="310896"/>
           </a:xfrm>
           <a:prstGeom prst="roundRect">
             <a:avLst>
@@ -14405,7 +14405,7 @@
                 </a:solidFill>
                 <a:latin typeface="Segoe UI"/>
               </a:rPr>
-              <a:t>[@seu-linkedin]</a:t>
+              <a:t>linkedin.com/in/magoolation</a:t>
             </a:r>
           </a:p>
         </p:txBody>
@@ -14418,8 +14418,8 @@
         </p:nvSpPr>
         <p:spPr>
           <a:xfrm>
-            <a:off x="9464040" y="4325112"/>
-            <a:ext cx="841248" cy="310896"/>
+            <a:off x="9829800" y="4325112"/>
+            <a:ext cx="1152144" cy="310896"/>
           </a:xfrm>
           <a:prstGeom prst="roundRect">
             <a:avLst>
@@ -14472,7 +14472,7 @@
                 </a:solidFill>
                 <a:latin typeface="Segoe UI"/>
               </a:rPr>
-              <a:t>[@seu-x]</a:t>
+              <a:t>@magoolation</a:t>
             </a:r>
           </a:p>
         </p:txBody>
@@ -25763,7 +25763,7 @@
                 </a:solidFill>
                 <a:latin typeface="Segoe UI"/>
               </a:rPr>
-              <a:t>[@seu-linkedin]</a:t>
+              <a:t>linkedin.com/in/magoolation</a:t>
             </a:r>
             <a:r>
               <a:rPr sz="1700" b="0">
@@ -25781,7 +25781,7 @@
                 </a:solidFill>
                 <a:latin typeface="Segoe UI"/>
               </a:rPr>
-              <a:t>[seu-email]</a:t>
+              <a:t>@magoolation</a:t>
             </a:r>
           </a:p>
         </p:txBody>

</xml_diff>

<commit_message>
docs: bio do palestrante, sem foto, e a resposta do "quanto tempo levou"
Texto do próprio Alexandre, literal. A foto sai por escolha dele, então o
slide reflui para a largura inteira e o tipo cresce — um slide de
apresentação com um vazio de três polegadas à esquerda parece defeito, e
este é o primeiro que a plateia lê com atenção.

Os chips de rede ganharam largura explícita: a automática é calibrada para
13pt e cortaria o texto em 15pt.

E a pergunta que estava esperando resposta agora tem uma: a primeira
versão do produto saiu em uma manhã. O que consumiu o resto do tempo foi
integração, não prompt — os oito achados da palestra saíram todos dessa
parte, nenhum da manhã.

Não sobrou marcador em slide nenhum.

Co-Authored-By: Claude Opus 5 (1M context) <noreply@anthropic.com>
</commit_message>
<xml_diff>
--- a/docs/apresentacao/Agent-Squad-TDC-SP-2026.pptx
+++ b/docs/apresentacao/Agent-Squad-TDC-SP-2026.pptx
@@ -14099,81 +14099,14 @@
       </p:sp>
       <p:sp>
         <p:nvSpPr>
-          <p:cNvPr id="6" name="Rounded Rectangle 5"/>
-          <p:cNvSpPr/>
-          <p:nvPr/>
-        </p:nvSpPr>
-        <p:spPr>
-          <a:xfrm>
-            <a:off x="777240" y="1947672"/>
-            <a:ext cx="2834640" cy="2834640"/>
-          </a:xfrm>
-          <a:prstGeom prst="roundRect">
-            <a:avLst>
-              <a:gd name="adj" fmla="val 8000"/>
-            </a:avLst>
-          </a:prstGeom>
-          <a:solidFill>
-            <a:srgbClr val="010409"/>
-          </a:solidFill>
-          <a:ln w="12700">
-            <a:solidFill>
-              <a:srgbClr val="30363D"/>
-            </a:solidFill>
-          </a:ln>
-          <a:effectLst/>
-        </p:spPr>
-        <p:style>
-          <a:lnRef idx="1">
-            <a:schemeClr val="accent1"/>
-          </a:lnRef>
-          <a:fillRef idx="3">
-            <a:schemeClr val="accent1"/>
-          </a:fillRef>
-          <a:effectRef idx="2">
-            <a:schemeClr val="accent1"/>
-          </a:effectRef>
-          <a:fontRef idx="minor">
-            <a:schemeClr val="lt1"/>
-          </a:fontRef>
-        </p:style>
-        <p:txBody>
-          <a:bodyPr rtlCol="0" anchor="ctr" wrap="square"/>
-          <a:lstStyle/>
-          <a:p>
-            <a:pPr algn="ctr">
-              <a:lnSpc>
-                <a:spcPct val="125000"/>
-              </a:lnSpc>
-              <a:spcBef>
-                <a:spcPts val="0"/>
-              </a:spcBef>
-              <a:spcAft>
-                <a:spcPts val="0"/>
-              </a:spcAft>
-            </a:pPr>
-            <a:r>
-              <a:rPr sz="1500" b="0">
-                <a:solidFill>
-                  <a:srgbClr val="6E7681"/>
-                </a:solidFill>
-                <a:latin typeface="Segoe UI"/>
-              </a:rPr>
-              <a:t>[ sua foto aqui ]</a:t>
-            </a:r>
-          </a:p>
-        </p:txBody>
-      </p:sp>
-      <p:sp>
-        <p:nvSpPr>
-          <p:cNvPr id="7" name="TextBox 6"/>
+          <p:cNvPr id="6" name="TextBox 5"/>
           <p:cNvSpPr txBox="1"/>
           <p:nvPr/>
         </p:nvSpPr>
         <p:spPr>
           <a:xfrm>
-            <a:off x="3977640" y="1993392"/>
-            <a:ext cx="7436815" cy="731520"/>
+            <a:off x="777240" y="2084832"/>
+            <a:ext cx="10637215" cy="822960"/>
           </a:xfrm>
           <a:prstGeom prst="rect">
             <a:avLst/>
@@ -14194,11 +14127,11 @@
                 <a:spcPts val="0"/>
               </a:spcBef>
               <a:spcAft>
-                <a:spcPts val="400"/>
-              </a:spcAft>
-            </a:pPr>
-            <a:r>
-              <a:rPr sz="3200" b="1">
+                <a:spcPts val="600"/>
+              </a:spcAft>
+            </a:pPr>
+            <a:r>
+              <a:rPr sz="3800" b="1">
                 <a:solidFill>
                   <a:srgbClr val="FFFFFF"/>
                 </a:solidFill>
@@ -14220,7 +14153,7 @@
               </a:spcAft>
             </a:pPr>
             <a:r>
-              <a:rPr sz="1900" b="0">
+              <a:rPr sz="2100" b="0">
                 <a:solidFill>
                   <a:srgbClr val="58A6FF"/>
                 </a:solidFill>
@@ -14233,14 +14166,14 @@
       </p:sp>
       <p:sp>
         <p:nvSpPr>
-          <p:cNvPr id="8" name="TextBox 7"/>
+          <p:cNvPr id="7" name="TextBox 6"/>
           <p:cNvSpPr txBox="1"/>
           <p:nvPr/>
         </p:nvSpPr>
         <p:spPr>
           <a:xfrm>
-            <a:off x="3977640" y="2999232"/>
-            <a:ext cx="7436815" cy="1645920"/>
+            <a:off x="777240" y="3319272"/>
+            <a:ext cx="10637215" cy="1371600"/>
           </a:xfrm>
           <a:prstGeom prst="rect">
             <a:avLst/>
@@ -14255,37 +14188,37 @@
           <a:p>
             <a:pPr algn="l">
               <a:lnSpc>
-                <a:spcPct val="125000"/>
-              </a:lnSpc>
-              <a:spcBef>
-                <a:spcPts val="0"/>
-              </a:spcBef>
-              <a:spcAft>
-                <a:spcPts val="0"/>
-              </a:spcAft>
-            </a:pPr>
-            <a:r>
-              <a:rPr sz="1700" b="0">
-                <a:solidFill>
-                  <a:srgbClr val="9198A1"/>
-                </a:solidFill>
-                <a:latin typeface="Segoe UI"/>
-              </a:rPr>
-              <a:t>Cloud Solution Architect na Microsoft, na área de IA e aplicações. Construí o Agent Squad para responder na prática a uma pergunta que times de engenharia fazem o tempo todo: dá para colocar agentes autônomos trabalhando em paralelo sem perder o controle do que entra no repositório?</a:t>
-            </a:r>
-          </a:p>
-        </p:txBody>
-      </p:sp>
-      <p:sp>
-        <p:nvSpPr>
-          <p:cNvPr id="9" name="Rounded Rectangle 8"/>
+                <a:spcPct val="135000"/>
+              </a:lnSpc>
+              <a:spcBef>
+                <a:spcPts val="0"/>
+              </a:spcBef>
+              <a:spcAft>
+                <a:spcPts val="0"/>
+              </a:spcAft>
+            </a:pPr>
+            <a:r>
+              <a:rPr sz="2100" b="0">
+                <a:solidFill>
+                  <a:srgbClr val="E6EDF3"/>
+                </a:solidFill>
+                <a:latin typeface="Segoe UI"/>
+              </a:rPr>
+              <a:t>Pessoa desenvolvedora com deficiência visual apaixonado por tecnologia e ativista da diversidade e inclusão. Palestrante internacional, Microsoft MVP Reconnect e TDC rockStar. Cloud Solution Architect na Microsoft contribui com a missão de empoderar cada pessoa e organização a conquistar mais.</a:t>
+            </a:r>
+          </a:p>
+        </p:txBody>
+      </p:sp>
+      <p:sp>
+        <p:nvSpPr>
+          <p:cNvPr id="8" name="Rounded Rectangle 7"/>
           <p:cNvSpPr/>
           <p:nvPr/>
         </p:nvSpPr>
         <p:spPr>
           <a:xfrm>
-            <a:off x="3977640" y="4325112"/>
-            <a:ext cx="1929384" cy="310896"/>
+            <a:off x="777240" y="4828032"/>
+            <a:ext cx="2651760" cy="310896"/>
           </a:xfrm>
           <a:prstGeom prst="roundRect">
             <a:avLst>
@@ -14332,7 +14265,7 @@
               </a:spcAft>
             </a:pPr>
             <a:r>
-              <a:rPr sz="1300" b="1">
+              <a:rPr sz="1500" b="1">
                 <a:solidFill>
                   <a:srgbClr val="58A6FF"/>
                 </a:solidFill>
@@ -14345,14 +14278,14 @@
       </p:sp>
       <p:sp>
         <p:nvSpPr>
-          <p:cNvPr id="10" name="Rounded Rectangle 9"/>
+          <p:cNvPr id="9" name="Rounded Rectangle 8"/>
           <p:cNvSpPr/>
           <p:nvPr/>
         </p:nvSpPr>
         <p:spPr>
           <a:xfrm>
-            <a:off x="6720840" y="4325112"/>
-            <a:ext cx="2318004" cy="310896"/>
+            <a:off x="3703320" y="4828032"/>
+            <a:ext cx="3200400" cy="310896"/>
           </a:xfrm>
           <a:prstGeom prst="roundRect">
             <a:avLst>
@@ -14399,7 +14332,7 @@
               </a:spcAft>
             </a:pPr>
             <a:r>
-              <a:rPr sz="1300" b="1">
+              <a:rPr sz="1500" b="1">
                 <a:solidFill>
                   <a:srgbClr val="BC8CFF"/>
                 </a:solidFill>
@@ -14412,14 +14345,14 @@
       </p:sp>
       <p:sp>
         <p:nvSpPr>
-          <p:cNvPr id="11" name="Rounded Rectangle 10"/>
+          <p:cNvPr id="10" name="Rounded Rectangle 9"/>
           <p:cNvSpPr/>
           <p:nvPr/>
         </p:nvSpPr>
         <p:spPr>
           <a:xfrm>
-            <a:off x="9829800" y="4325112"/>
-            <a:ext cx="1152144" cy="310896"/>
+            <a:off x="7178040" y="4828032"/>
+            <a:ext cx="1737360" cy="310896"/>
           </a:xfrm>
           <a:prstGeom prst="roundRect">
             <a:avLst>
@@ -14466,7 +14399,7 @@
               </a:spcAft>
             </a:pPr>
             <a:r>
-              <a:rPr sz="1300" b="1">
+              <a:rPr sz="1500" b="1">
                 <a:solidFill>
                   <a:srgbClr val="9198A1"/>
                 </a:solidFill>
@@ -14479,7 +14412,7 @@
       </p:sp>
       <p:sp>
         <p:nvSpPr>
-          <p:cNvPr id="12" name="TextBox 11"/>
+          <p:cNvPr id="11" name="TextBox 10"/>
           <p:cNvSpPr txBox="1"/>
           <p:nvPr/>
         </p:nvSpPr>
@@ -14530,7 +14463,7 @@
       </p:sp>
       <p:sp>
         <p:nvSpPr>
-          <p:cNvPr id="13" name="TextBox 12"/>
+          <p:cNvPr id="12" name="TextBox 11"/>
           <p:cNvSpPr txBox="1"/>
           <p:nvPr/>
         </p:nvSpPr>
@@ -14575,7 +14508,7 @@
       </p:sp>
       <p:sp>
         <p:nvSpPr>
-          <p:cNvPr id="14" name="TextBox 13"/>
+          <p:cNvPr id="13" name="TextBox 12"/>
           <p:cNvSpPr txBox="1"/>
           <p:nvPr/>
         </p:nvSpPr>

</xml_diff>